<commit_message>
Refocus deck: replace This Week's Progress with 3 dedicated slides (centrality binning, nHitsFit/nHitsMax, DCA/vertex cuts)
</commit_message>
<xml_diff>
--- a/docs/OO200_Spectra_Status_Update.pptx
+++ b/docs/OO200_Spectra_Status_Update.pptx
@@ -12,6 +12,8 @@
     <p:sldId id="272" r:id="rId23"/>
     <p:sldId id="273" r:id="rId24"/>
     <p:sldId id="274" r:id="rId25"/>
+    <p:sldId id="275" r:id="rId26"/>
+    <p:sldId id="276" r:id="rId27"/>
   </p:sldIdLst>
   <p:notesMasterIdLst>
     <p:notesMasterId r:id="rId14"/>
@@ -2588,9 +2590,9 @@
 </p:sld>
 </file>
 
-<file path=ppt/slides/slide19.xml><?xml version="1.0" encoding="utf-8"?>
+<file path=ppt/slides/slide20.xml><?xml version="1.0" encoding="utf-8"?>
 <p:sld xmlns:a="http://schemas.openxmlformats.org/drawingml/2006/main" xmlns:r="http://schemas.openxmlformats.org/officeDocument/2006/relationships" xmlns:p="http://schemas.openxmlformats.org/presentationml/2006/main">
-  <p:cSld name="Slide 19">
+  <p:cSld name="Slide 20">
     <p:bg>
       <p:bgPr>
         <a:solidFill>
@@ -2645,7 +2647,7 @@
                 <a:ea typeface="Arial" pitchFamily="34" charset="-122"/>
                 <a:cs typeface="Arial" pitchFamily="34" charset="-120"/>
               </a:rPr>
-              <a:t>THIS WEEK'S PROGRESS</a:t>
+              <a:t>CENTRALITY BINNING</a:t>
             </a:r>
             <a:endParaRPr lang="en-US" sz="1200" dirty="0"/>
           </a:p>
@@ -2684,7 +2686,7 @@
                 <a:ea typeface="Arial" pitchFamily="34" charset="-122"/>
                 <a:cs typeface="Arial" pitchFamily="34" charset="-120"/>
               </a:rPr>
-              <a:t>Analysis QA &amp; a Real Bug Fix</a:t>
+              <a:t>Added the Periphery</a:t>
             </a:r>
             <a:endParaRPr lang="en-US" sz="3000" dirty="0"/>
           </a:p>
@@ -2762,7 +2764,7 @@
                 <a:ea typeface="Arial" pitchFamily="34" charset="-122"/>
                 <a:cs typeface="Arial" pitchFamily="34" charset="-120"/>
               </a:rPr>
-              <a:t>Centrality binning fixed</a:t>
+              <a:t>6-bin scheme now in production</a:t>
             </a:r>
             <a:endParaRPr lang="en-US" sz="1550" dirty="0"/>
           </a:p>
@@ -2801,7 +2803,7 @@
                 <a:ea typeface="Arial" pitchFamily="34" charset="-122"/>
                 <a:cs typeface="Arial" pitchFamily="34" charset="-120"/>
               </a:rPr>
-              <a:t>Added the missing 80-100% peripheral bin -- those events are counted now, not dropped.</a:t>
+              <a:t>Edges {44,37,28,17,5,0} on refMult give 0-5/5-10/10-20/20-40/40-80/80-100% bins.</a:t>
             </a:r>
             <a:endParaRPr lang="en-US" sz="1250" dirty="0"/>
           </a:p>
@@ -2879,7 +2881,7 @@
                 <a:ea typeface="Arial" pitchFamily="34" charset="-122"/>
                 <a:cs typeface="Arial" pitchFamily="34" charset="-120"/>
               </a:rPr>
-              <a:t>New track-quality QA</a:t>
+              <a:t>80-100% peripheral bin restored</a:t>
             </a:r>
             <a:endParaRPr lang="en-US" sz="1550" dirty="0"/>
           </a:p>
@@ -2918,7 +2920,7 @@
                 <a:ea typeface="Arial" pitchFamily="34" charset="-122"/>
                 <a:cs typeface="Arial" pitchFamily="34" charset="-120"/>
               </a:rPr>
-              <a:t>Hit-count-vs-eta histograms traced a low-yield corner to real TPC acceptance, not a bad cut.</a:t>
+              <a:t>The previous scheme silently dropped the most peripheral events; they're counted now.</a:t>
             </a:r>
             <a:endParaRPr lang="en-US" sz="1250" dirty="0"/>
           </a:p>
@@ -2996,7 +2998,7 @@
                 <a:ea typeface="Arial" pitchFamily="34" charset="-122"/>
                 <a:cs typeface="Arial" pitchFamily="34" charset="-120"/>
               </a:rPr>
-              <a:t>Found a real cut bug</a:t>
+              <a:t>Downstream macros kept in sync</a:t>
             </a:r>
             <a:endParaRPr lang="en-US" sz="1550" dirty="0"/>
           </a:p>
@@ -3035,7 +3037,7 @@
                 <a:ea typeface="Arial" pitchFamily="34" charset="-122"/>
                 <a:cs typeface="Arial" pitchFamily="34" charset="-120"/>
               </a:rPr>
-              <a:t>The split-track quality cut was silently disabled by an integer-division error -- now fixed.</a:t>
+              <a:t>RunZFitter.C, RunRawSpectraModifier.C, and RunSpectraFitter.C all bumped their hardcoded bin count from 5 to 6.</a:t>
             </a:r>
             <a:endParaRPr lang="en-US" sz="1250" dirty="0"/>
           </a:p>
@@ -3113,7 +3115,7 @@
                 <a:ea typeface="Arial" pitchFamily="34" charset="-122"/>
                 <a:cs typeface="Arial" pitchFamily="34" charset="-120"/>
               </a:rPr>
-              <a:t>"Double pion" dE/dx band</a:t>
+              <a:t>QA overlay updated to match</a:t>
             </a:r>
             <a:endParaRPr lang="en-US" sz="1550" dirty="0"/>
           </a:p>
@@ -3152,7 +3154,7 @@
                 <a:ea typeface="Arial" pitchFamily="34" charset="-122"/>
                 <a:cs typeface="Arial" pitchFamily="34" charset="-120"/>
               </a:rPr>
-              <a:t>Two unresolved nearby tracks merging into one doubled signal -- a known TPC effect, not new physics.</a:t>
+              <a:t>PresentEventQA.C's refMult cut-line overlay now draws all 6 current edges, replacing a stale 5-bin overlay.</a:t>
             </a:r>
             <a:endParaRPr lang="en-US" sz="1250" dirty="0"/>
           </a:p>
@@ -3278,7 +3280,1415 @@
                 <a:ea typeface="Arial" pitchFamily="34" charset="-122"/>
                 <a:cs typeface="Arial" pitchFamily="34" charset="-120"/>
               </a:rPr>
-              <a:t>Andrew Liggett  •  July 8, 2026</a:t>
+              <a:t>Andrew Liggett  •  July 13, 2026</a:t>
+            </a:r>
+            <a:endParaRPr lang="en-US" sz="1000" dirty="0"/>
+          </a:p>
+        </p:txBody>
+      </p:sp>
+    </p:spTree>
+  </p:cSld>
+  <p:clrMapOvr>
+    <a:masterClrMapping/>
+  </p:clrMapOvr>
+</p:sld>
+</file>
+
+<file path=ppt/slides/slide21.xml><?xml version="1.0" encoding="utf-8"?>
+<p:sld xmlns:a="http://schemas.openxmlformats.org/drawingml/2006/main" xmlns:r="http://schemas.openxmlformats.org/officeDocument/2006/relationships" xmlns:p="http://schemas.openxmlformats.org/presentationml/2006/main">
+  <p:cSld name="Slide 21">
+    <p:bg>
+      <p:bgPr>
+        <a:solidFill>
+          <a:srgbClr val="FFFFFF"/>
+        </a:solidFill>
+      </p:bgPr>
+    </p:bg>
+    <p:spTree>
+      <p:nvGrpSpPr>
+        <p:cNvPr id="1" name=""/>
+        <p:cNvGrpSpPr/>
+        <p:nvPr/>
+      </p:nvGrpSpPr>
+      <p:grpSpPr>
+        <a:xfrm>
+          <a:off x="0" y="0"/>
+          <a:ext cx="0" cy="0"/>
+          <a:chOff x="0" y="0"/>
+          <a:chExt cx="0" cy="0"/>
+        </a:xfrm>
+      </p:grpSpPr>
+      <p:sp>
+        <p:nvSpPr>
+          <p:cNvPr id="2" name="Text 0"/>
+          <p:cNvSpPr/>
+          <p:nvPr/>
+        </p:nvSpPr>
+        <p:spPr>
+          <a:xfrm>
+            <a:off x="457200" y="320040"/>
+            <a:ext cx="8229600" cy="274320"/>
+          </a:xfrm>
+          <a:prstGeom prst="rect">
+            <a:avLst/>
+          </a:prstGeom>
+          <a:noFill/>
+          <a:ln/>
+        </p:spPr>
+        <p:txBody>
+          <a:bodyPr wrap="square" lIns="0" tIns="0" rIns="0" bIns="0" rtlCol="0" anchor="ctr"/>
+          <a:lstStyle/>
+          <a:p>
+            <a:pPr indent="0" marL="0">
+              <a:buNone/>
+            </a:pPr>
+            <a:r>
+              <a:rPr lang="en-US" sz="1200" b="1" spc="200" kern="0" dirty="0">
+                <a:solidFill>
+                  <a:srgbClr val="5B6382"/>
+                </a:solidFill>
+                <a:latin typeface="Arial" pitchFamily="34" charset="0"/>
+                <a:ea typeface="Arial" pitchFamily="34" charset="-122"/>
+                <a:cs typeface="Arial" pitchFamily="34" charset="-120"/>
+              </a:rPr>
+              <a:t>TRACK QUALITY</a:t>
+            </a:r>
+            <a:endParaRPr lang="en-US" sz="1200" dirty="0"/>
+          </a:p>
+        </p:txBody>
+      </p:sp>
+      <p:sp>
+        <p:nvSpPr>
+          <p:cNvPr id="3" name="Text 1"/>
+          <p:cNvSpPr/>
+          <p:nvPr/>
+        </p:nvSpPr>
+        <p:spPr>
+          <a:xfrm>
+            <a:off x="457200" y="566928"/>
+            <a:ext cx="8229600" cy="640080"/>
+          </a:xfrm>
+          <a:prstGeom prst="rect">
+            <a:avLst/>
+          </a:prstGeom>
+          <a:noFill/>
+          <a:ln/>
+        </p:spPr>
+        <p:txBody>
+          <a:bodyPr wrap="square" lIns="0" tIns="0" rIns="0" bIns="0" rtlCol="0" anchor="ctr"/>
+          <a:lstStyle/>
+          <a:p>
+            <a:pPr indent="0" marL="0">
+              <a:buNone/>
+            </a:pPr>
+            <a:r>
+              <a:rPr lang="en-US" sz="3000" b="1" dirty="0">
+                <a:solidFill>
+                  <a:srgbClr val="1E2761"/>
+                </a:solidFill>
+                <a:latin typeface="Arial" pitchFamily="34" charset="0"/>
+                <a:ea typeface="Arial" pitchFamily="34" charset="-122"/>
+                <a:cs typeface="Arial" pitchFamily="34" charset="-120"/>
+              </a:rPr>
+              <a:t>NHitsFit &amp; NHitsMax</a:t>
+            </a:r>
+            <a:endParaRPr lang="en-US" sz="3000" dirty="0"/>
+          </a:p>
+        </p:txBody>
+      </p:sp>
+      <p:sp>
+        <p:nvSpPr>
+          <p:cNvPr id="4" name="Text 2"/>
+          <p:cNvSpPr/>
+          <p:nvPr/>
+        </p:nvSpPr>
+        <p:spPr>
+          <a:xfrm>
+            <a:off x="502920" y="1557008"/>
+            <a:ext cx="365760" cy="370840"/>
+          </a:xfrm>
+          <a:prstGeom prst="rect">
+            <a:avLst/>
+          </a:prstGeom>
+          <a:noFill/>
+          <a:ln/>
+        </p:spPr>
+        <p:txBody>
+          <a:bodyPr wrap="square" lIns="0" tIns="0" rIns="0" bIns="0" rtlCol="0" anchor="ctr"/>
+          <a:lstStyle/>
+          <a:p>
+            <a:pPr indent="0" marL="0">
+              <a:buNone/>
+            </a:pPr>
+            <a:r>
+              <a:rPr lang="en-US" sz="1700" b="1" dirty="0">
+                <a:solidFill>
+                  <a:srgbClr val="1E2761"/>
+                </a:solidFill>
+                <a:latin typeface="Arial" pitchFamily="34" charset="0"/>
+                <a:ea typeface="Arial" pitchFamily="34" charset="-122"/>
+                <a:cs typeface="Arial" pitchFamily="34" charset="-120"/>
+              </a:rPr>
+              <a:t>1.</a:t>
+            </a:r>
+            <a:endParaRPr lang="en-US" sz="1700" dirty="0"/>
+          </a:p>
+        </p:txBody>
+      </p:sp>
+      <p:sp>
+        <p:nvSpPr>
+          <p:cNvPr id="5" name="Text 3"/>
+          <p:cNvSpPr/>
+          <p:nvPr/>
+        </p:nvSpPr>
+        <p:spPr>
+          <a:xfrm>
+            <a:off x="886968" y="1557008"/>
+            <a:ext cx="3593592" cy="370840"/>
+          </a:xfrm>
+          <a:prstGeom prst="rect">
+            <a:avLst/>
+          </a:prstGeom>
+          <a:noFill/>
+          <a:ln/>
+        </p:spPr>
+        <p:txBody>
+          <a:bodyPr wrap="square" lIns="0" tIns="0" rIns="0" bIns="0" rtlCol="0" anchor="ctr"/>
+          <a:lstStyle/>
+          <a:p>
+            <a:pPr indent="0" marL="0">
+              <a:buNone/>
+            </a:pPr>
+            <a:r>
+              <a:rPr lang="en-US" sz="1550" b="1" dirty="0">
+                <a:solidFill>
+                  <a:srgbClr val="1E2761"/>
+                </a:solidFill>
+                <a:latin typeface="Arial" pitchFamily="34" charset="0"/>
+                <a:ea typeface="Arial" pitchFamily="34" charset="-122"/>
+                <a:cs typeface="Arial" pitchFamily="34" charset="-120"/>
+              </a:rPr>
+              <a:t>New side-by-side QA plot</a:t>
+            </a:r>
+            <a:endParaRPr lang="en-US" sz="1550" dirty="0"/>
+          </a:p>
+        </p:txBody>
+      </p:sp>
+      <p:sp>
+        <p:nvSpPr>
+          <p:cNvPr id="6" name="Text 4"/>
+          <p:cNvSpPr/>
+          <p:nvPr/>
+        </p:nvSpPr>
+        <p:spPr>
+          <a:xfrm>
+            <a:off x="886968" y="1927848"/>
+            <a:ext cx="3593592" cy="740000"/>
+          </a:xfrm>
+          <a:prstGeom prst="rect">
+            <a:avLst/>
+          </a:prstGeom>
+          <a:noFill/>
+          <a:ln/>
+        </p:spPr>
+        <p:txBody>
+          <a:bodyPr wrap="square" lIns="0" tIns="0" rIns="0" bIns="0" rtlCol="0" anchor="t"/>
+          <a:lstStyle/>
+          <a:p>
+            <a:pPr indent="0" marL="0">
+              <a:buNone/>
+            </a:pPr>
+            <a:r>
+              <a:rPr lang="en-US" sz="1250" dirty="0">
+                <a:solidFill>
+                  <a:srgbClr val="5B6382"/>
+                </a:solidFill>
+                <a:latin typeface="Arial" pitchFamily="34" charset="0"/>
+                <a:ea typeface="Arial" pitchFamily="34" charset="-122"/>
+                <a:cs typeface="Arial" pitchFamily="34" charset="-120"/>
+              </a:rPr>
+              <a:t>PresentNHitsEta.C now plots N_{hits}^{fit} and N_{hits}^{max} vs #eta together, to separate acceptance from cut effects.</a:t>
+            </a:r>
+            <a:endParaRPr lang="en-US" sz="1250" dirty="0"/>
+          </a:p>
+        </p:txBody>
+      </p:sp>
+      <p:sp>
+        <p:nvSpPr>
+          <p:cNvPr id="7" name="Text 5"/>
+          <p:cNvSpPr/>
+          <p:nvPr/>
+        </p:nvSpPr>
+        <p:spPr>
+          <a:xfrm>
+            <a:off x="4754880" y="1557008"/>
+            <a:ext cx="365760" cy="370840"/>
+          </a:xfrm>
+          <a:prstGeom prst="rect">
+            <a:avLst/>
+          </a:prstGeom>
+          <a:noFill/>
+          <a:ln/>
+        </p:spPr>
+        <p:txBody>
+          <a:bodyPr wrap="square" lIns="0" tIns="0" rIns="0" bIns="0" rtlCol="0" anchor="ctr"/>
+          <a:lstStyle/>
+          <a:p>
+            <a:pPr indent="0" marL="0">
+              <a:buNone/>
+            </a:pPr>
+            <a:r>
+              <a:rPr lang="en-US" sz="1700" b="1" dirty="0">
+                <a:solidFill>
+                  <a:srgbClr val="1E2761"/>
+                </a:solidFill>
+                <a:latin typeface="Arial" pitchFamily="34" charset="0"/>
+                <a:ea typeface="Arial" pitchFamily="34" charset="-122"/>
+                <a:cs typeface="Arial" pitchFamily="34" charset="-120"/>
+              </a:rPr>
+              <a:t>2.</a:t>
+            </a:r>
+            <a:endParaRPr lang="en-US" sz="1700" dirty="0"/>
+          </a:p>
+        </p:txBody>
+      </p:sp>
+      <p:sp>
+        <p:nvSpPr>
+          <p:cNvPr id="8" name="Text 6"/>
+          <p:cNvSpPr/>
+          <p:nvPr/>
+        </p:nvSpPr>
+        <p:spPr>
+          <a:xfrm>
+            <a:off x="5138928" y="1557008"/>
+            <a:ext cx="3593592" cy="370840"/>
+          </a:xfrm>
+          <a:prstGeom prst="rect">
+            <a:avLst/>
+          </a:prstGeom>
+          <a:noFill/>
+          <a:ln/>
+        </p:spPr>
+        <p:txBody>
+          <a:bodyPr wrap="square" lIns="0" tIns="0" rIns="0" bIns="0" rtlCol="0" anchor="ctr"/>
+          <a:lstStyle/>
+          <a:p>
+            <a:pPr indent="0" marL="0">
+              <a:buNone/>
+            </a:pPr>
+            <a:r>
+              <a:rPr lang="en-US" sz="1550" b="1" dirty="0">
+                <a:solidFill>
+                  <a:srgbClr val="1E2761"/>
+                </a:solidFill>
+                <a:latin typeface="Arial" pitchFamily="34" charset="0"/>
+                <a:ea typeface="Arial" pitchFamily="34" charset="-122"/>
+                <a:cs typeface="Arial" pitchFamily="34" charset="-120"/>
+              </a:rPr>
+              <a:t>Confirmed post-iTPC geometry</a:t>
+            </a:r>
+            <a:endParaRPr lang="en-US" sz="1550" dirty="0"/>
+          </a:p>
+        </p:txBody>
+      </p:sp>
+      <p:sp>
+        <p:nvSpPr>
+          <p:cNvPr id="9" name="Text 7"/>
+          <p:cNvSpPr/>
+          <p:nvPr/>
+        </p:nvSpPr>
+        <p:spPr>
+          <a:xfrm>
+            <a:off x="5138928" y="1927848"/>
+            <a:ext cx="3593592" cy="740000"/>
+          </a:xfrm>
+          <a:prstGeom prst="rect">
+            <a:avLst/>
+          </a:prstGeom>
+          <a:noFill/>
+          <a:ln/>
+        </p:spPr>
+        <p:txBody>
+          <a:bodyPr wrap="square" lIns="0" tIns="0" rIns="0" bIns="0" rtlCol="0" anchor="t"/>
+          <a:lstStyle/>
+          <a:p>
+            <a:pPr indent="0" marL="0">
+              <a:buNone/>
+            </a:pPr>
+            <a:r>
+              <a:rPr lang="en-US" sz="1250" dirty="0">
+                <a:solidFill>
+                  <a:srgbClr val="5B6382"/>
+                </a:solidFill>
+                <a:latin typeface="Arial" pitchFamily="34" charset="0"/>
+                <a:ea typeface="Arial" pitchFamily="34" charset="-122"/>
+                <a:cs typeface="Arial" pitchFamily="34" charset="-120"/>
+              </a:rPr>
+              <a:t>This dataset uses 72 padrows (40 inner + 32 outer), not the pre-upgrade 45; histogram binning widened 0-50 to 0-80 to stop clipping.</a:t>
+            </a:r>
+            <a:endParaRPr lang="en-US" sz="1250" dirty="0"/>
+          </a:p>
+        </p:txBody>
+      </p:sp>
+      <p:sp>
+        <p:nvSpPr>
+          <p:cNvPr id="10" name="Text 8"/>
+          <p:cNvSpPr/>
+          <p:nvPr/>
+        </p:nvSpPr>
+        <p:spPr>
+          <a:xfrm>
+            <a:off x="502920" y="3017848"/>
+            <a:ext cx="365760" cy="370840"/>
+          </a:xfrm>
+          <a:prstGeom prst="rect">
+            <a:avLst/>
+          </a:prstGeom>
+          <a:noFill/>
+          <a:ln/>
+        </p:spPr>
+        <p:txBody>
+          <a:bodyPr wrap="square" lIns="0" tIns="0" rIns="0" bIns="0" rtlCol="0" anchor="ctr"/>
+          <a:lstStyle/>
+          <a:p>
+            <a:pPr indent="0" marL="0">
+              <a:buNone/>
+            </a:pPr>
+            <a:r>
+              <a:rPr lang="en-US" sz="1700" b="1" dirty="0">
+                <a:solidFill>
+                  <a:srgbClr val="1E2761"/>
+                </a:solidFill>
+                <a:latin typeface="Arial" pitchFamily="34" charset="0"/>
+                <a:ea typeface="Arial" pitchFamily="34" charset="-122"/>
+                <a:cs typeface="Arial" pitchFamily="34" charset="-120"/>
+              </a:rPr>
+              <a:t>3.</a:t>
+            </a:r>
+            <a:endParaRPr lang="en-US" sz="1700" dirty="0"/>
+          </a:p>
+        </p:txBody>
+      </p:sp>
+      <p:sp>
+        <p:nvSpPr>
+          <p:cNvPr id="11" name="Text 9"/>
+          <p:cNvSpPr/>
+          <p:nvPr/>
+        </p:nvSpPr>
+        <p:spPr>
+          <a:xfrm>
+            <a:off x="886968" y="3017848"/>
+            <a:ext cx="3593592" cy="370840"/>
+          </a:xfrm>
+          <a:prstGeom prst="rect">
+            <a:avLst/>
+          </a:prstGeom>
+          <a:noFill/>
+          <a:ln/>
+        </p:spPr>
+        <p:txBody>
+          <a:bodyPr wrap="square" lIns="0" tIns="0" rIns="0" bIns="0" rtlCol="0" anchor="ctr"/>
+          <a:lstStyle/>
+          <a:p>
+            <a:pPr indent="0" marL="0">
+              <a:buNone/>
+            </a:pPr>
+            <a:r>
+              <a:rPr lang="en-US" sz="1550" b="1" dirty="0">
+                <a:solidFill>
+                  <a:srgbClr val="1E2761"/>
+                </a:solidFill>
+                <a:latin typeface="Arial" pitchFamily="34" charset="0"/>
+                <a:ea typeface="Arial" pitchFamily="34" charset="-122"/>
+                <a:cs typeface="Arial" pitchFamily="34" charset="-120"/>
+              </a:rPr>
+              <a:t>NHitsFit cut loosened as a variation</a:t>
+            </a:r>
+            <a:endParaRPr lang="en-US" sz="1550" dirty="0"/>
+          </a:p>
+        </p:txBody>
+      </p:sp>
+      <p:sp>
+        <p:nvSpPr>
+          <p:cNvPr id="12" name="Text 10"/>
+          <p:cNvSpPr/>
+          <p:nvPr/>
+        </p:nvSpPr>
+        <p:spPr>
+          <a:xfrm>
+            <a:off x="886968" y="3388688"/>
+            <a:ext cx="3593592" cy="740000"/>
+          </a:xfrm>
+          <a:prstGeom prst="rect">
+            <a:avLst/>
+          </a:prstGeom>
+          <a:noFill/>
+          <a:ln/>
+        </p:spPr>
+        <p:txBody>
+          <a:bodyPr wrap="square" lIns="0" tIns="0" rIns="0" bIns="0" rtlCol="0" anchor="t"/>
+          <a:lstStyle/>
+          <a:p>
+            <a:pPr indent="0" marL="0">
+              <a:buNone/>
+            </a:pPr>
+            <a:r>
+              <a:rPr lang="en-US" sz="1250" dirty="0">
+                <a:solidFill>
+                  <a:srgbClr val="5B6382"/>
+                </a:solidFill>
+                <a:latin typeface="Arial" pitchFamily="34" charset="0"/>
+                <a:ea typeface="Arial" pitchFamily="34" charset="-122"/>
+                <a:cs typeface="Arial" pitchFamily="34" charset="-120"/>
+              </a:rPr>
+              <a:t>Lowered 20 to 10 to test forward-track recovery -- a systematic variation, not yet the validated production value.</a:t>
+            </a:r>
+            <a:endParaRPr lang="en-US" sz="1250" dirty="0"/>
+          </a:p>
+        </p:txBody>
+      </p:sp>
+      <p:sp>
+        <p:nvSpPr>
+          <p:cNvPr id="13" name="Text 11"/>
+          <p:cNvSpPr/>
+          <p:nvPr/>
+        </p:nvSpPr>
+        <p:spPr>
+          <a:xfrm>
+            <a:off x="4754880" y="3017848"/>
+            <a:ext cx="365760" cy="370840"/>
+          </a:xfrm>
+          <a:prstGeom prst="rect">
+            <a:avLst/>
+          </a:prstGeom>
+          <a:noFill/>
+          <a:ln/>
+        </p:spPr>
+        <p:txBody>
+          <a:bodyPr wrap="square" lIns="0" tIns="0" rIns="0" bIns="0" rtlCol="0" anchor="ctr"/>
+          <a:lstStyle/>
+          <a:p>
+            <a:pPr indent="0" marL="0">
+              <a:buNone/>
+            </a:pPr>
+            <a:r>
+              <a:rPr lang="en-US" sz="1700" b="1" dirty="0">
+                <a:solidFill>
+                  <a:srgbClr val="1E2761"/>
+                </a:solidFill>
+                <a:latin typeface="Arial" pitchFamily="34" charset="0"/>
+                <a:ea typeface="Arial" pitchFamily="34" charset="-122"/>
+                <a:cs typeface="Arial" pitchFamily="34" charset="-120"/>
+              </a:rPr>
+              <a:t>4.</a:t>
+            </a:r>
+            <a:endParaRPr lang="en-US" sz="1700" dirty="0"/>
+          </a:p>
+        </p:txBody>
+      </p:sp>
+      <p:sp>
+        <p:nvSpPr>
+          <p:cNvPr id="14" name="Text 12"/>
+          <p:cNvSpPr/>
+          <p:nvPr/>
+        </p:nvSpPr>
+        <p:spPr>
+          <a:xfrm>
+            <a:off x="5138928" y="3017848"/>
+            <a:ext cx="3593592" cy="370840"/>
+          </a:xfrm>
+          <a:prstGeom prst="rect">
+            <a:avLst/>
+          </a:prstGeom>
+          <a:noFill/>
+          <a:ln/>
+        </p:spPr>
+        <p:txBody>
+          <a:bodyPr wrap="square" lIns="0" tIns="0" rIns="0" bIns="0" rtlCol="0" anchor="ctr"/>
+          <a:lstStyle/>
+          <a:p>
+            <a:pPr indent="0" marL="0">
+              <a:buNone/>
+            </a:pPr>
+            <a:r>
+              <a:rPr lang="en-US" sz="1550" b="1" dirty="0">
+                <a:solidFill>
+                  <a:srgbClr val="1E2761"/>
+                </a:solidFill>
+                <a:latin typeface="Arial" pitchFamily="34" charset="0"/>
+                <a:ea typeface="Arial" pitchFamily="34" charset="-122"/>
+                <a:cs typeface="Arial" pitchFamily="34" charset="-120"/>
+              </a:rPr>
+              <a:t>TPC corner traced to acceptance</a:t>
+            </a:r>
+            <a:endParaRPr lang="en-US" sz="1550" dirty="0"/>
+          </a:p>
+        </p:txBody>
+      </p:sp>
+      <p:sp>
+        <p:nvSpPr>
+          <p:cNvPr id="15" name="Text 13"/>
+          <p:cNvSpPr/>
+          <p:nvPr/>
+        </p:nvSpPr>
+        <p:spPr>
+          <a:xfrm>
+            <a:off x="5138928" y="3388688"/>
+            <a:ext cx="3593592" cy="740000"/>
+          </a:xfrm>
+          <a:prstGeom prst="rect">
+            <a:avLst/>
+          </a:prstGeom>
+          <a:noFill/>
+          <a:ln/>
+        </p:spPr>
+        <p:txBody>
+          <a:bodyPr wrap="square" lIns="0" tIns="0" rIns="0" bIns="0" rtlCol="0" anchor="t"/>
+          <a:lstStyle/>
+          <a:p>
+            <a:pPr indent="0" marL="0">
+              <a:buNone/>
+            </a:pPr>
+            <a:r>
+              <a:rPr lang="en-US" sz="1250" dirty="0">
+                <a:solidFill>
+                  <a:srgbClr val="5B6382"/>
+                </a:solidFill>
+                <a:latin typeface="Arial" pitchFamily="34" charset="0"/>
+                <a:ea typeface="Arial" pitchFamily="34" charset="-122"/>
+                <a:cs typeface="Arial" pitchFamily="34" charset="-120"/>
+              </a:rPr>
+              <a:t>Large |#eta| combined with low p_{T} reduces both N_{hits}^{max} and N_{hits}^{fit} together -- geometric, not a cut artifact.</a:t>
+            </a:r>
+            <a:endParaRPr lang="en-US" sz="1250" dirty="0"/>
+          </a:p>
+        </p:txBody>
+      </p:sp>
+      <p:pic>
+        <p:nvPicPr>
+          <p:cNvPr id="19" name="Image 0" descr="assets/ucdavis_seal.png"/>
+          <p:cNvPicPr>
+            <a:picLocks noChangeAspect="1"/>
+          </p:cNvPicPr>
+          <p:nvPr/>
+        </p:nvPicPr>
+        <p:blipFill>
+          <a:blip r:embed="rId1"/>
+          <a:stretch>
+            <a:fillRect/>
+          </a:stretch>
+        </p:blipFill>
+        <p:spPr>
+          <a:xfrm>
+            <a:off x="457200" y="4709160"/>
+            <a:ext cx="274320" cy="282092"/>
+          </a:xfrm>
+          <a:prstGeom prst="rect">
+            <a:avLst/>
+          </a:prstGeom>
+        </p:spPr>
+      </p:pic>
+      <p:pic>
+        <p:nvPicPr>
+          <p:cNvPr id="20" name="Image 1" descr="assets/star_logo.png"/>
+          <p:cNvPicPr>
+            <a:picLocks noChangeAspect="1"/>
+          </p:cNvPicPr>
+          <p:nvPr/>
+        </p:nvPicPr>
+        <p:blipFill>
+          <a:blip r:embed="rId2"/>
+          <a:stretch>
+            <a:fillRect/>
+          </a:stretch>
+        </p:blipFill>
+        <p:spPr>
+          <a:xfrm>
+            <a:off x="8092440" y="4709160"/>
+            <a:ext cx="379365" cy="292608"/>
+          </a:xfrm>
+          <a:prstGeom prst="rect">
+            <a:avLst/>
+          </a:prstGeom>
+        </p:spPr>
+      </p:pic>
+      <p:sp>
+        <p:nvSpPr>
+          <p:cNvPr id="21" name="Text 17"/>
+          <p:cNvSpPr/>
+          <p:nvPr/>
+        </p:nvSpPr>
+        <p:spPr>
+          <a:xfrm>
+            <a:off x="8549640" y="4828032"/>
+            <a:ext cx="457200" cy="274320"/>
+          </a:xfrm>
+          <a:prstGeom prst="rect">
+            <a:avLst/>
+          </a:prstGeom>
+          <a:noFill/>
+          <a:ln/>
+        </p:spPr>
+        <p:txBody>
+          <a:bodyPr wrap="square" lIns="0" tIns="0" rIns="0" bIns="0" rtlCol="0" anchor="ctr"/>
+          <a:lstStyle/>
+          <a:p>
+            <a:pPr algn="r" indent="0" marL="0">
+              <a:buNone/>
+            </a:pPr>
+            <a:r>
+              <a:rPr lang="en-US" sz="1000" dirty="0">
+                <a:solidFill>
+                  <a:srgbClr val="5B6382"/>
+                </a:solidFill>
+                <a:latin typeface="Arial" pitchFamily="34" charset="0"/>
+                <a:ea typeface="Arial" pitchFamily="34" charset="-122"/>
+                <a:cs typeface="Arial" pitchFamily="34" charset="-120"/>
+              </a:rPr>
+              <a:t>8</a:t>
+            </a:r>
+            <a:endParaRPr lang="en-US" sz="1000" dirty="0"/>
+          </a:p>
+        </p:txBody>
+      </p:sp>
+      <p:sp>
+        <p:nvSpPr>
+          <p:cNvPr id="22" name="Text 18"/>
+          <p:cNvSpPr/>
+          <p:nvPr/>
+        </p:nvSpPr>
+        <p:spPr>
+          <a:xfrm>
+            <a:off x="841248" y="4828032"/>
+            <a:ext cx="6766560" cy="274320"/>
+          </a:xfrm>
+          <a:prstGeom prst="rect">
+            <a:avLst/>
+          </a:prstGeom>
+          <a:noFill/>
+          <a:ln/>
+        </p:spPr>
+        <p:txBody>
+          <a:bodyPr wrap="square" lIns="0" tIns="0" rIns="0" bIns="0" rtlCol="0" anchor="ctr"/>
+          <a:lstStyle/>
+          <a:p>
+            <a:pPr algn="l" indent="0" marL="0">
+              <a:buNone/>
+            </a:pPr>
+            <a:r>
+              <a:rPr lang="en-US" sz="1000" dirty="0">
+                <a:solidFill>
+                  <a:srgbClr val="5B6382"/>
+                </a:solidFill>
+                <a:latin typeface="Arial" pitchFamily="34" charset="0"/>
+                <a:ea typeface="Arial" pitchFamily="34" charset="-122"/>
+                <a:cs typeface="Arial" pitchFamily="34" charset="-120"/>
+              </a:rPr>
+              <a:t>Andrew Liggett  •  July 13, 2026</a:t>
+            </a:r>
+            <a:endParaRPr lang="en-US" sz="1000" dirty="0"/>
+          </a:p>
+        </p:txBody>
+      </p:sp>
+    </p:spTree>
+  </p:cSld>
+  <p:clrMapOvr>
+    <a:masterClrMapping/>
+  </p:clrMapOvr>
+</p:sld>
+</file>
+
+<file path=ppt/slides/slide22.xml><?xml version="1.0" encoding="utf-8"?>
+<p:sld xmlns:a="http://schemas.openxmlformats.org/drawingml/2006/main" xmlns:r="http://schemas.openxmlformats.org/officeDocument/2006/relationships" xmlns:p="http://schemas.openxmlformats.org/presentationml/2006/main">
+  <p:cSld name="Slide 22">
+    <p:bg>
+      <p:bgPr>
+        <a:solidFill>
+          <a:srgbClr val="FFFFFF"/>
+        </a:solidFill>
+      </p:bgPr>
+    </p:bg>
+    <p:spTree>
+      <p:nvGrpSpPr>
+        <p:cNvPr id="1" name=""/>
+        <p:cNvGrpSpPr/>
+        <p:nvPr/>
+      </p:nvGrpSpPr>
+      <p:grpSpPr>
+        <a:xfrm>
+          <a:off x="0" y="0"/>
+          <a:ext cx="0" cy="0"/>
+          <a:chOff x="0" y="0"/>
+          <a:chExt cx="0" cy="0"/>
+        </a:xfrm>
+      </p:grpSpPr>
+      <p:sp>
+        <p:nvSpPr>
+          <p:cNvPr id="2" name="Text 0"/>
+          <p:cNvSpPr/>
+          <p:nvPr/>
+        </p:nvSpPr>
+        <p:spPr>
+          <a:xfrm>
+            <a:off x="457200" y="320040"/>
+            <a:ext cx="8229600" cy="274320"/>
+          </a:xfrm>
+          <a:prstGeom prst="rect">
+            <a:avLst/>
+          </a:prstGeom>
+          <a:noFill/>
+          <a:ln/>
+        </p:spPr>
+        <p:txBody>
+          <a:bodyPr wrap="square" lIns="0" tIns="0" rIns="0" bIns="0" rtlCol="0" anchor="ctr"/>
+          <a:lstStyle/>
+          <a:p>
+            <a:pPr indent="0" marL="0">
+              <a:buNone/>
+            </a:pPr>
+            <a:r>
+              <a:rPr lang="en-US" sz="1200" b="1" spc="200" kern="0" dirty="0">
+                <a:solidFill>
+                  <a:srgbClr val="5B6382"/>
+                </a:solidFill>
+                <a:latin typeface="Arial" pitchFamily="34" charset="0"/>
+                <a:ea typeface="Arial" pitchFamily="34" charset="-122"/>
+                <a:cs typeface="Arial" pitchFamily="34" charset="-120"/>
+              </a:rPr>
+              <a:t>CUT UPDATES</a:t>
+            </a:r>
+            <a:endParaRPr lang="en-US" sz="1200" dirty="0"/>
+          </a:p>
+        </p:txBody>
+      </p:sp>
+      <p:sp>
+        <p:nvSpPr>
+          <p:cNvPr id="3" name="Text 1"/>
+          <p:cNvSpPr/>
+          <p:nvPr/>
+        </p:nvSpPr>
+        <p:spPr>
+          <a:xfrm>
+            <a:off x="457200" y="566928"/>
+            <a:ext cx="8229600" cy="640080"/>
+          </a:xfrm>
+          <a:prstGeom prst="rect">
+            <a:avLst/>
+          </a:prstGeom>
+          <a:noFill/>
+          <a:ln/>
+        </p:spPr>
+        <p:txBody>
+          <a:bodyPr wrap="square" lIns="0" tIns="0" rIns="0" bIns="0" rtlCol="0" anchor="ctr"/>
+          <a:lstStyle/>
+          <a:p>
+            <a:pPr indent="0" marL="0">
+              <a:buNone/>
+            </a:pPr>
+            <a:r>
+              <a:rPr lang="en-US" sz="3000" b="1" dirty="0">
+                <a:solidFill>
+                  <a:srgbClr val="1E2761"/>
+                </a:solidFill>
+                <a:latin typeface="Arial" pitchFamily="34" charset="0"/>
+                <a:ea typeface="Arial" pitchFamily="34" charset="-122"/>
+                <a:cs typeface="Arial" pitchFamily="34" charset="-120"/>
+              </a:rPr>
+              <a:t>DCA &amp; Vertex Cuts</a:t>
+            </a:r>
+            <a:endParaRPr lang="en-US" sz="3000" dirty="0"/>
+          </a:p>
+        </p:txBody>
+      </p:sp>
+      <p:sp>
+        <p:nvSpPr>
+          <p:cNvPr id="4" name="Text 2"/>
+          <p:cNvSpPr/>
+          <p:nvPr/>
+        </p:nvSpPr>
+        <p:spPr>
+          <a:xfrm>
+            <a:off x="502920" y="1557008"/>
+            <a:ext cx="365760" cy="370840"/>
+          </a:xfrm>
+          <a:prstGeom prst="rect">
+            <a:avLst/>
+          </a:prstGeom>
+          <a:noFill/>
+          <a:ln/>
+        </p:spPr>
+        <p:txBody>
+          <a:bodyPr wrap="square" lIns="0" tIns="0" rIns="0" bIns="0" rtlCol="0" anchor="ctr"/>
+          <a:lstStyle/>
+          <a:p>
+            <a:pPr indent="0" marL="0">
+              <a:buNone/>
+            </a:pPr>
+            <a:r>
+              <a:rPr lang="en-US" sz="1700" b="1" dirty="0">
+                <a:solidFill>
+                  <a:srgbClr val="1E2761"/>
+                </a:solidFill>
+                <a:latin typeface="Arial" pitchFamily="34" charset="0"/>
+                <a:ea typeface="Arial" pitchFamily="34" charset="-122"/>
+                <a:cs typeface="Arial" pitchFamily="34" charset="-120"/>
+              </a:rPr>
+              <a:t>1.</a:t>
+            </a:r>
+            <a:endParaRPr lang="en-US" sz="1700" dirty="0"/>
+          </a:p>
+        </p:txBody>
+      </p:sp>
+      <p:sp>
+        <p:nvSpPr>
+          <p:cNvPr id="5" name="Text 3"/>
+          <p:cNvSpPr/>
+          <p:nvPr/>
+        </p:nvSpPr>
+        <p:spPr>
+          <a:xfrm>
+            <a:off x="886968" y="1557008"/>
+            <a:ext cx="3593592" cy="370840"/>
+          </a:xfrm>
+          <a:prstGeom prst="rect">
+            <a:avLst/>
+          </a:prstGeom>
+          <a:noFill/>
+          <a:ln/>
+        </p:spPr>
+        <p:txBody>
+          <a:bodyPr wrap="square" lIns="0" tIns="0" rIns="0" bIns="0" rtlCol="0" anchor="ctr"/>
+          <a:lstStyle/>
+          <a:p>
+            <a:pPr indent="0" marL="0">
+              <a:buNone/>
+            </a:pPr>
+            <a:r>
+              <a:rPr lang="en-US" sz="1550" b="1" dirty="0">
+                <a:solidFill>
+                  <a:srgbClr val="1E2761"/>
+                </a:solidFill>
+                <a:latin typeface="Arial" pitchFamily="34" charset="0"/>
+                <a:ea typeface="Arial" pitchFamily="34" charset="-122"/>
+                <a:cs typeface="Arial" pitchFamily="34" charset="-120"/>
+              </a:rPr>
+              <a:t>DCA relaxed to 1 cm as a variation</a:t>
+            </a:r>
+            <a:endParaRPr lang="en-US" sz="1550" dirty="0"/>
+          </a:p>
+        </p:txBody>
+      </p:sp>
+      <p:sp>
+        <p:nvSpPr>
+          <p:cNvPr id="6" name="Text 4"/>
+          <p:cNvSpPr/>
+          <p:nvPr/>
+        </p:nvSpPr>
+        <p:spPr>
+          <a:xfrm>
+            <a:off x="886968" y="1927848"/>
+            <a:ext cx="3593592" cy="740000"/>
+          </a:xfrm>
+          <a:prstGeom prst="rect">
+            <a:avLst/>
+          </a:prstGeom>
+          <a:noFill/>
+          <a:ln/>
+        </p:spPr>
+        <p:txBody>
+          <a:bodyPr wrap="square" lIns="0" tIns="0" rIns="0" bIns="0" rtlCol="0" anchor="t"/>
+          <a:lstStyle/>
+          <a:p>
+            <a:pPr indent="0" marL="0">
+              <a:buNone/>
+            </a:pPr>
+            <a:r>
+              <a:rPr lang="en-US" sz="1250" dirty="0">
+                <a:solidFill>
+                  <a:srgbClr val="5B6382"/>
+                </a:solidFill>
+                <a:latin typeface="Arial" pitchFamily="34" charset="0"/>
+                <a:ea typeface="Arial" pitchFamily="34" charset="-122"/>
+                <a:cs typeface="Arial" pitchFamily="34" charset="-120"/>
+              </a:rPr>
+              <a:t>The SDCC-matched, validated value is 3 cm; the current 1 cm setting hasn't been re-verified against SDCC output.</a:t>
+            </a:r>
+            <a:endParaRPr lang="en-US" sz="1250" dirty="0"/>
+          </a:p>
+        </p:txBody>
+      </p:sp>
+      <p:sp>
+        <p:nvSpPr>
+          <p:cNvPr id="7" name="Text 5"/>
+          <p:cNvSpPr/>
+          <p:nvPr/>
+        </p:nvSpPr>
+        <p:spPr>
+          <a:xfrm>
+            <a:off x="4754880" y="1557008"/>
+            <a:ext cx="365760" cy="370840"/>
+          </a:xfrm>
+          <a:prstGeom prst="rect">
+            <a:avLst/>
+          </a:prstGeom>
+          <a:noFill/>
+          <a:ln/>
+        </p:spPr>
+        <p:txBody>
+          <a:bodyPr wrap="square" lIns="0" tIns="0" rIns="0" bIns="0" rtlCol="0" anchor="ctr"/>
+          <a:lstStyle/>
+          <a:p>
+            <a:pPr indent="0" marL="0">
+              <a:buNone/>
+            </a:pPr>
+            <a:r>
+              <a:rPr lang="en-US" sz="1700" b="1" dirty="0">
+                <a:solidFill>
+                  <a:srgbClr val="1E2761"/>
+                </a:solidFill>
+                <a:latin typeface="Arial" pitchFamily="34" charset="0"/>
+                <a:ea typeface="Arial" pitchFamily="34" charset="-122"/>
+                <a:cs typeface="Arial" pitchFamily="34" charset="-120"/>
+              </a:rPr>
+              <a:t>2.</a:t>
+            </a:r>
+            <a:endParaRPr lang="en-US" sz="1700" dirty="0"/>
+          </a:p>
+        </p:txBody>
+      </p:sp>
+      <p:sp>
+        <p:nvSpPr>
+          <p:cNvPr id="8" name="Text 6"/>
+          <p:cNvSpPr/>
+          <p:nvPr/>
+        </p:nvSpPr>
+        <p:spPr>
+          <a:xfrm>
+            <a:off x="5138928" y="1557008"/>
+            <a:ext cx="3593592" cy="370840"/>
+          </a:xfrm>
+          <a:prstGeom prst="rect">
+            <a:avLst/>
+          </a:prstGeom>
+          <a:noFill/>
+          <a:ln/>
+        </p:spPr>
+        <p:txBody>
+          <a:bodyPr wrap="square" lIns="0" tIns="0" rIns="0" bIns="0" rtlCol="0" anchor="ctr"/>
+          <a:lstStyle/>
+          <a:p>
+            <a:pPr indent="0" marL="0">
+              <a:buNone/>
+            </a:pPr>
+            <a:r>
+              <a:rPr lang="en-US" sz="1550" b="1" dirty="0">
+                <a:solidFill>
+                  <a:srgbClr val="1E2761"/>
+                </a:solidFill>
+                <a:latin typeface="Arial" pitchFamily="34" charset="0"/>
+                <a:ea typeface="Arial" pitchFamily="34" charset="-122"/>
+                <a:cs typeface="Arial" pitchFamily="34" charset="-120"/>
+              </a:rPr>
+              <a:t>Event-level z-vertex cut unchanged</a:t>
+            </a:r>
+            <a:endParaRPr lang="en-US" sz="1550" dirty="0"/>
+          </a:p>
+        </p:txBody>
+      </p:sp>
+      <p:sp>
+        <p:nvSpPr>
+          <p:cNvPr id="9" name="Text 7"/>
+          <p:cNvSpPr/>
+          <p:nvPr/>
+        </p:nvSpPr>
+        <p:spPr>
+          <a:xfrm>
+            <a:off x="5138928" y="1927848"/>
+            <a:ext cx="3593592" cy="740000"/>
+          </a:xfrm>
+          <a:prstGeom prst="rect">
+            <a:avLst/>
+          </a:prstGeom>
+          <a:noFill/>
+          <a:ln/>
+        </p:spPr>
+        <p:txBody>
+          <a:bodyPr wrap="square" lIns="0" tIns="0" rIns="0" bIns="0" rtlCol="0" anchor="t"/>
+          <a:lstStyle/>
+          <a:p>
+            <a:pPr indent="0" marL="0">
+              <a:buNone/>
+            </a:pPr>
+            <a:r>
+              <a:rPr lang="en-US" sz="1250" dirty="0">
+                <a:solidFill>
+                  <a:srgbClr val="5B6382"/>
+                </a:solidFill>
+                <a:latin typeface="Arial" pitchFamily="34" charset="0"/>
+                <a:ea typeface="Arial" pitchFamily="34" charset="-122"/>
+                <a:cs typeface="Arial" pitchFamily="34" charset="-120"/>
+              </a:rPr>
+              <a:t>cuts-&gt;setZRange(-2,2) in SetCutClass.C is untouched -- this is the actual event selection, not a display setting.</a:t>
+            </a:r>
+            <a:endParaRPr lang="en-US" sz="1250" dirty="0"/>
+          </a:p>
+        </p:txBody>
+      </p:sp>
+      <p:sp>
+        <p:nvSpPr>
+          <p:cNvPr id="10" name="Text 8"/>
+          <p:cNvSpPr/>
+          <p:nvPr/>
+        </p:nvSpPr>
+        <p:spPr>
+          <a:xfrm>
+            <a:off x="502920" y="3017848"/>
+            <a:ext cx="365760" cy="370840"/>
+          </a:xfrm>
+          <a:prstGeom prst="rect">
+            <a:avLst/>
+          </a:prstGeom>
+          <a:noFill/>
+          <a:ln/>
+        </p:spPr>
+        <p:txBody>
+          <a:bodyPr wrap="square" lIns="0" tIns="0" rIns="0" bIns="0" rtlCol="0" anchor="ctr"/>
+          <a:lstStyle/>
+          <a:p>
+            <a:pPr indent="0" marL="0">
+              <a:buNone/>
+            </a:pPr>
+            <a:r>
+              <a:rPr lang="en-US" sz="1700" b="1" dirty="0">
+                <a:solidFill>
+                  <a:srgbClr val="1E2761"/>
+                </a:solidFill>
+                <a:latin typeface="Arial" pitchFamily="34" charset="0"/>
+                <a:ea typeface="Arial" pitchFamily="34" charset="-122"/>
+                <a:cs typeface="Arial" pitchFamily="34" charset="-120"/>
+              </a:rPr>
+              <a:t>3.</a:t>
+            </a:r>
+            <a:endParaRPr lang="en-US" sz="1700" dirty="0"/>
+          </a:p>
+        </p:txBody>
+      </p:sp>
+      <p:sp>
+        <p:nvSpPr>
+          <p:cNvPr id="11" name="Text 9"/>
+          <p:cNvSpPr/>
+          <p:nvPr/>
+        </p:nvSpPr>
+        <p:spPr>
+          <a:xfrm>
+            <a:off x="886968" y="3017848"/>
+            <a:ext cx="3593592" cy="370840"/>
+          </a:xfrm>
+          <a:prstGeom prst="rect">
+            <a:avLst/>
+          </a:prstGeom>
+          <a:noFill/>
+          <a:ln/>
+        </p:spPr>
+        <p:txBody>
+          <a:bodyPr wrap="square" lIns="0" tIns="0" rIns="0" bIns="0" rtlCol="0" anchor="ctr"/>
+          <a:lstStyle/>
+          <a:p>
+            <a:pPr indent="0" marL="0">
+              <a:buNone/>
+            </a:pPr>
+            <a:r>
+              <a:rPr lang="en-US" sz="1550" b="1" dirty="0">
+                <a:solidFill>
+                  <a:srgbClr val="1E2761"/>
+                </a:solidFill>
+                <a:latin typeface="Arial" pitchFamily="34" charset="0"/>
+                <a:ea typeface="Arial" pitchFamily="34" charset="-122"/>
+                <a:cs typeface="Arial" pitchFamily="34" charset="-120"/>
+              </a:rPr>
+              <a:t>QA display window tightened only</a:t>
+            </a:r>
+            <a:endParaRPr lang="en-US" sz="1550" dirty="0"/>
+          </a:p>
+        </p:txBody>
+      </p:sp>
+      <p:sp>
+        <p:nvSpPr>
+          <p:cNvPr id="12" name="Text 10"/>
+          <p:cNvSpPr/>
+          <p:nvPr/>
+        </p:nvSpPr>
+        <p:spPr>
+          <a:xfrm>
+            <a:off x="886968" y="3388688"/>
+            <a:ext cx="3593592" cy="740000"/>
+          </a:xfrm>
+          <a:prstGeom prst="rect">
+            <a:avLst/>
+          </a:prstGeom>
+          <a:noFill/>
+          <a:ln/>
+        </p:spPr>
+        <p:txBody>
+          <a:bodyPr wrap="square" lIns="0" tIns="0" rIns="0" bIns="0" rtlCol="0" anchor="t"/>
+          <a:lstStyle/>
+          <a:p>
+            <a:pPr indent="0" marL="0">
+              <a:buNone/>
+            </a:pPr>
+            <a:r>
+              <a:rPr lang="en-US" sz="1250" dirty="0">
+                <a:solidFill>
+                  <a:srgbClr val="5B6382"/>
+                </a:solidFill>
+                <a:latin typeface="Arial" pitchFamily="34" charset="0"/>
+                <a:ea typeface="Arial" pitchFamily="34" charset="-122"/>
+                <a:cs typeface="Arial" pitchFamily="34" charset="-120"/>
+              </a:rPr>
+              <a:t>PresentEventQA.C now zooms the z-vertex plot to +/-3cm for readability; it doesn't change the cut or drop any entries.</a:t>
+            </a:r>
+            <a:endParaRPr lang="en-US" sz="1250" dirty="0"/>
+          </a:p>
+        </p:txBody>
+      </p:sp>
+      <p:sp>
+        <p:nvSpPr>
+          <p:cNvPr id="13" name="Text 11"/>
+          <p:cNvSpPr/>
+          <p:nvPr/>
+        </p:nvSpPr>
+        <p:spPr>
+          <a:xfrm>
+            <a:off x="4754880" y="3017848"/>
+            <a:ext cx="365760" cy="370840"/>
+          </a:xfrm>
+          <a:prstGeom prst="rect">
+            <a:avLst/>
+          </a:prstGeom>
+          <a:noFill/>
+          <a:ln/>
+        </p:spPr>
+        <p:txBody>
+          <a:bodyPr wrap="square" lIns="0" tIns="0" rIns="0" bIns="0" rtlCol="0" anchor="ctr"/>
+          <a:lstStyle/>
+          <a:p>
+            <a:pPr indent="0" marL="0">
+              <a:buNone/>
+            </a:pPr>
+            <a:r>
+              <a:rPr lang="en-US" sz="1700" b="1" dirty="0">
+                <a:solidFill>
+                  <a:srgbClr val="1E2761"/>
+                </a:solidFill>
+                <a:latin typeface="Arial" pitchFamily="34" charset="0"/>
+                <a:ea typeface="Arial" pitchFamily="34" charset="-122"/>
+                <a:cs typeface="Arial" pitchFamily="34" charset="-120"/>
+              </a:rPr>
+              <a:t/>
+            </a:r>
+            <a:endParaRPr lang="en-US" sz="1700" dirty="0"/>
+          </a:p>
+        </p:txBody>
+      </p:sp>
+      <p:sp>
+        <p:nvSpPr>
+          <p:cNvPr id="14" name="Text 12"/>
+          <p:cNvSpPr/>
+          <p:nvPr/>
+        </p:nvSpPr>
+        <p:spPr>
+          <a:xfrm>
+            <a:off x="5138928" y="3017848"/>
+            <a:ext cx="3593592" cy="370840"/>
+          </a:xfrm>
+          <a:prstGeom prst="rect">
+            <a:avLst/>
+          </a:prstGeom>
+          <a:noFill/>
+          <a:ln/>
+        </p:spPr>
+        <p:txBody>
+          <a:bodyPr wrap="square" lIns="0" tIns="0" rIns="0" bIns="0" rtlCol="0" anchor="ctr"/>
+          <a:lstStyle/>
+          <a:p>
+            <a:pPr indent="0" marL="0">
+              <a:buNone/>
+            </a:pPr>
+            <a:r>
+              <a:rPr lang="en-US" sz="1550" b="1" dirty="0">
+                <a:solidFill>
+                  <a:srgbClr val="1E2761"/>
+                </a:solidFill>
+                <a:latin typeface="Arial" pitchFamily="34" charset="0"/>
+                <a:ea typeface="Arial" pitchFamily="34" charset="-122"/>
+                <a:cs typeface="Arial" pitchFamily="34" charset="-120"/>
+              </a:rPr>
+              <a:t/>
+            </a:r>
+            <a:endParaRPr lang="en-US" sz="1550" dirty="0"/>
+          </a:p>
+        </p:txBody>
+      </p:sp>
+      <p:sp>
+        <p:nvSpPr>
+          <p:cNvPr id="15" name="Text 13"/>
+          <p:cNvSpPr/>
+          <p:nvPr/>
+        </p:nvSpPr>
+        <p:spPr>
+          <a:xfrm>
+            <a:off x="5138928" y="3388688"/>
+            <a:ext cx="3593592" cy="740000"/>
+          </a:xfrm>
+          <a:prstGeom prst="rect">
+            <a:avLst/>
+          </a:prstGeom>
+          <a:noFill/>
+          <a:ln/>
+        </p:spPr>
+        <p:txBody>
+          <a:bodyPr wrap="square" lIns="0" tIns="0" rIns="0" bIns="0" rtlCol="0" anchor="t"/>
+          <a:lstStyle/>
+          <a:p>
+            <a:pPr indent="0" marL="0">
+              <a:buNone/>
+            </a:pPr>
+            <a:r>
+              <a:rPr lang="en-US" sz="1250" dirty="0">
+                <a:solidFill>
+                  <a:srgbClr val="5B6382"/>
+                </a:solidFill>
+                <a:latin typeface="Arial" pitchFamily="34" charset="0"/>
+                <a:ea typeface="Arial" pitchFamily="34" charset="-122"/>
+                <a:cs typeface="Arial" pitchFamily="34" charset="-120"/>
+              </a:rPr>
+              <a:t/>
+            </a:r>
+            <a:endParaRPr lang="en-US" sz="1250" dirty="0"/>
+          </a:p>
+        </p:txBody>
+      </p:sp>
+      <p:pic>
+        <p:nvPicPr>
+          <p:cNvPr id="19" name="Image 0" descr="assets/ucdavis_seal.png"/>
+          <p:cNvPicPr>
+            <a:picLocks noChangeAspect="1"/>
+          </p:cNvPicPr>
+          <p:nvPr/>
+        </p:nvPicPr>
+        <p:blipFill>
+          <a:blip r:embed="rId1"/>
+          <a:stretch>
+            <a:fillRect/>
+          </a:stretch>
+        </p:blipFill>
+        <p:spPr>
+          <a:xfrm>
+            <a:off x="457200" y="4709160"/>
+            <a:ext cx="274320" cy="282092"/>
+          </a:xfrm>
+          <a:prstGeom prst="rect">
+            <a:avLst/>
+          </a:prstGeom>
+        </p:spPr>
+      </p:pic>
+      <p:pic>
+        <p:nvPicPr>
+          <p:cNvPr id="20" name="Image 1" descr="assets/star_logo.png"/>
+          <p:cNvPicPr>
+            <a:picLocks noChangeAspect="1"/>
+          </p:cNvPicPr>
+          <p:nvPr/>
+        </p:nvPicPr>
+        <p:blipFill>
+          <a:blip r:embed="rId2"/>
+          <a:stretch>
+            <a:fillRect/>
+          </a:stretch>
+        </p:blipFill>
+        <p:spPr>
+          <a:xfrm>
+            <a:off x="8092440" y="4709160"/>
+            <a:ext cx="379365" cy="292608"/>
+          </a:xfrm>
+          <a:prstGeom prst="rect">
+            <a:avLst/>
+          </a:prstGeom>
+        </p:spPr>
+      </p:pic>
+      <p:sp>
+        <p:nvSpPr>
+          <p:cNvPr id="21" name="Text 17"/>
+          <p:cNvSpPr/>
+          <p:nvPr/>
+        </p:nvSpPr>
+        <p:spPr>
+          <a:xfrm>
+            <a:off x="8549640" y="4828032"/>
+            <a:ext cx="457200" cy="274320"/>
+          </a:xfrm>
+          <a:prstGeom prst="rect">
+            <a:avLst/>
+          </a:prstGeom>
+          <a:noFill/>
+          <a:ln/>
+        </p:spPr>
+        <p:txBody>
+          <a:bodyPr wrap="square" lIns="0" tIns="0" rIns="0" bIns="0" rtlCol="0" anchor="ctr"/>
+          <a:lstStyle/>
+          <a:p>
+            <a:pPr algn="r" indent="0" marL="0">
+              <a:buNone/>
+            </a:pPr>
+            <a:r>
+              <a:rPr lang="en-US" sz="1000" dirty="0">
+                <a:solidFill>
+                  <a:srgbClr val="5B6382"/>
+                </a:solidFill>
+                <a:latin typeface="Arial" pitchFamily="34" charset="0"/>
+                <a:ea typeface="Arial" pitchFamily="34" charset="-122"/>
+                <a:cs typeface="Arial" pitchFamily="34" charset="-120"/>
+              </a:rPr>
+              <a:t>9</a:t>
+            </a:r>
+            <a:endParaRPr lang="en-US" sz="1000" dirty="0"/>
+          </a:p>
+        </p:txBody>
+      </p:sp>
+      <p:sp>
+        <p:nvSpPr>
+          <p:cNvPr id="22" name="Text 18"/>
+          <p:cNvSpPr/>
+          <p:nvPr/>
+        </p:nvSpPr>
+        <p:spPr>
+          <a:xfrm>
+            <a:off x="841248" y="4828032"/>
+            <a:ext cx="6766560" cy="274320"/>
+          </a:xfrm>
+          <a:prstGeom prst="rect">
+            <a:avLst/>
+          </a:prstGeom>
+          <a:noFill/>
+          <a:ln/>
+        </p:spPr>
+        <p:txBody>
+          <a:bodyPr wrap="square" lIns="0" tIns="0" rIns="0" bIns="0" rtlCol="0" anchor="ctr"/>
+          <a:lstStyle/>
+          <a:p>
+            <a:pPr algn="l" indent="0" marL="0">
+              <a:buNone/>
+            </a:pPr>
+            <a:r>
+              <a:rPr lang="en-US" sz="1000" dirty="0">
+                <a:solidFill>
+                  <a:srgbClr val="5B6382"/>
+                </a:solidFill>
+                <a:latin typeface="Arial" pitchFamily="34" charset="0"/>
+                <a:ea typeface="Arial" pitchFamily="34" charset="-122"/>
+                <a:cs typeface="Arial" pitchFamily="34" charset="-120"/>
+              </a:rPr>
+              <a:t>Andrew Liggett  •  July 13, 2026</a:t>
             </a:r>
             <a:endParaRPr lang="en-US" sz="1000" dirty="0"/>
           </a:p>

</xml_diff>

<commit_message>
Condense Centrality/NHits/DCA slides into one Summary slide, move to position 2
</commit_message>
<xml_diff>
--- a/docs/OO200_Spectra_Status_Update.pptx
+++ b/docs/OO200_Spectra_Status_Update.pptx
@@ -6,14 +6,12 @@
   </p:sldMasterIdLst>
   <p:sldIdLst>
     <p:sldId id="256" r:id="rId2"/>
+    <p:sldId id="274" r:id="rId25"/>
     <p:sldId id="271" r:id="rId22"/>
     <p:sldId id="269" r:id="rId20"/>
     <p:sldId id="270" r:id="rId21"/>
     <p:sldId id="272" r:id="rId23"/>
     <p:sldId id="273" r:id="rId24"/>
-    <p:sldId id="274" r:id="rId25"/>
-    <p:sldId id="275" r:id="rId26"/>
-    <p:sldId id="276" r:id="rId27"/>
   </p:sldIdLst>
   <p:notesMasterIdLst>
     <p:notesMasterId r:id="rId14"/>
@@ -1341,7 +1339,7 @@
                 <a:ea typeface="Arial" pitchFamily="34" charset="-122"/>
                 <a:cs typeface="Arial" pitchFamily="34" charset="-120"/>
               </a:rPr>
-              <a:t>3</a:t>
+              <a:t>4</a:t>
             </a:r>
             <a:endParaRPr lang="en-US" sz="1000" dirty="0"/>
           </a:p>
@@ -1640,7 +1638,7 @@
                 <a:ea typeface="Arial" pitchFamily="34" charset="-122"/>
                 <a:cs typeface="Arial" pitchFamily="34" charset="-120"/>
               </a:rPr>
-              <a:t>4</a:t>
+              <a:t>5</a:t>
             </a:r>
             <a:endParaRPr lang="en-US" sz="1000" dirty="0"/>
           </a:p>
@@ -1939,7 +1937,7 @@
                 <a:ea typeface="Arial" pitchFamily="34" charset="-122"/>
                 <a:cs typeface="Arial" pitchFamily="34" charset="-120"/>
               </a:rPr>
-              <a:t>2</a:t>
+              <a:t>3</a:t>
             </a:r>
             <a:endParaRPr lang="en-US" sz="1000" dirty="0"/>
           </a:p>
@@ -2238,7 +2236,7 @@
                 <a:ea typeface="Arial" pitchFamily="34" charset="-122"/>
                 <a:cs typeface="Arial" pitchFamily="34" charset="-120"/>
               </a:rPr>
-              <a:t>5</a:t>
+              <a:t>6</a:t>
             </a:r>
             <a:endParaRPr lang="en-US" sz="1000" dirty="0"/>
           </a:p>
@@ -2537,7 +2535,7 @@
                 <a:ea typeface="Arial" pitchFamily="34" charset="-122"/>
                 <a:cs typeface="Arial" pitchFamily="34" charset="-120"/>
               </a:rPr>
-              <a:t>6</a:t>
+              <a:t>7</a:t>
             </a:r>
             <a:endParaRPr lang="en-US" sz="1000" dirty="0"/>
           </a:p>
@@ -2590,9 +2588,9 @@
 </p:sld>
 </file>
 
-<file path=ppt/slides/slide20.xml><?xml version="1.0" encoding="utf-8"?>
+<file path=ppt/slides/slide23.xml><?xml version="1.0" encoding="utf-8"?>
 <p:sld xmlns:a="http://schemas.openxmlformats.org/drawingml/2006/main" xmlns:r="http://schemas.openxmlformats.org/officeDocument/2006/relationships" xmlns:p="http://schemas.openxmlformats.org/presentationml/2006/main">
-  <p:cSld name="Slide 20">
+  <p:cSld name="Slide 23">
     <p:bg>
       <p:bgPr>
         <a:solidFill>
@@ -2647,7 +2645,7 @@
                 <a:ea typeface="Arial" pitchFamily="34" charset="-122"/>
                 <a:cs typeface="Arial" pitchFamily="34" charset="-120"/>
               </a:rPr>
-              <a:t>CENTRALITY BINNING</a:t>
+              <a:t>THIS WEEK'S UPDATES</a:t>
             </a:r>
             <a:endParaRPr lang="en-US" sz="1200" dirty="0"/>
           </a:p>
@@ -2686,7 +2684,7 @@
                 <a:ea typeface="Arial" pitchFamily="34" charset="-122"/>
                 <a:cs typeface="Arial" pitchFamily="34" charset="-120"/>
               </a:rPr>
-              <a:t>Added the Periphery</a:t>
+              <a:t>Summary of Key Updates</a:t>
             </a:r>
             <a:endParaRPr lang="en-US" sz="3000" dirty="0"/>
           </a:p>
@@ -2764,7 +2762,7 @@
                 <a:ea typeface="Arial" pitchFamily="34" charset="-122"/>
                 <a:cs typeface="Arial" pitchFamily="34" charset="-120"/>
               </a:rPr>
-              <a:t>6-bin scheme now in production</a:t>
+              <a:t>Centrality: 6-bin scheme, periphery restored</a:t>
             </a:r>
             <a:endParaRPr lang="en-US" sz="1550" dirty="0"/>
           </a:p>
@@ -2803,7 +2801,7 @@
                 <a:ea typeface="Arial" pitchFamily="34" charset="-122"/>
                 <a:cs typeface="Arial" pitchFamily="34" charset="-120"/>
               </a:rPr>
-              <a:t>Edges {44,37,28,17,5,0} on refMult give 0-5/5-10/10-20/20-40/40-80/80-100% bins.</a:t>
+              <a:t>Added the 80-100% peripheral bin (previously dropped); all downstream macros updated to match.</a:t>
             </a:r>
             <a:endParaRPr lang="en-US" sz="1250" dirty="0"/>
           </a:p>
@@ -2881,7 +2879,7 @@
                 <a:ea typeface="Arial" pitchFamily="34" charset="-122"/>
                 <a:cs typeface="Arial" pitchFamily="34" charset="-120"/>
               </a:rPr>
-              <a:t>80-100% peripheral bin restored</a:t>
+              <a:t>Track quality: NHitsFit &amp; NHitsMax QA</a:t>
             </a:r>
             <a:endParaRPr lang="en-US" sz="1550" dirty="0"/>
           </a:p>
@@ -2920,7 +2918,7 @@
                 <a:ea typeface="Arial" pitchFamily="34" charset="-122"/>
                 <a:cs typeface="Arial" pitchFamily="34" charset="-120"/>
               </a:rPr>
-              <a:t>The previous scheme silently dropped the most peripheral events; they're counted now.</a:t>
+              <a:t>Confirmed post-iTPC geometry (72 padrows); corner yield loss traced to acceptance, not a cut artifact.</a:t>
             </a:r>
             <a:endParaRPr lang="en-US" sz="1250" dirty="0"/>
           </a:p>
@@ -2998,7 +2996,7 @@
                 <a:ea typeface="Arial" pitchFamily="34" charset="-122"/>
                 <a:cs typeface="Arial" pitchFamily="34" charset="-120"/>
               </a:rPr>
-              <a:t>Downstream macros kept in sync</a:t>
+              <a:t>DCA &amp; vertex: relaxed cuts under test</a:t>
             </a:r>
             <a:endParaRPr lang="en-US" sz="1550" dirty="0"/>
           </a:p>
@@ -3037,7 +3035,7 @@
                 <a:ea typeface="Arial" pitchFamily="34" charset="-122"/>
                 <a:cs typeface="Arial" pitchFamily="34" charset="-120"/>
               </a:rPr>
-              <a:t>RunZFitter.C, RunRawSpectraModifier.C, and RunSpectraFitter.C all bumped their hardcoded bin count from 5 to 6.</a:t>
+              <a:t>DCA loosened to 1cm as a variation, not yet production; the actual z-vertex cut is unchanged at +/-2cm.</a:t>
             </a:r>
             <a:endParaRPr lang="en-US" sz="1250" dirty="0"/>
           </a:p>
@@ -3076,7 +3074,7 @@
                 <a:ea typeface="Arial" pitchFamily="34" charset="-122"/>
                 <a:cs typeface="Arial" pitchFamily="34" charset="-120"/>
               </a:rPr>
-              <a:t>4.</a:t>
+              <a:t/>
             </a:r>
             <a:endParaRPr lang="en-US" sz="1700" dirty="0"/>
           </a:p>
@@ -3115,7 +3113,7 @@
                 <a:ea typeface="Arial" pitchFamily="34" charset="-122"/>
                 <a:cs typeface="Arial" pitchFamily="34" charset="-120"/>
               </a:rPr>
-              <a:t>QA overlay updated to match</a:t>
+              <a:t/>
             </a:r>
             <a:endParaRPr lang="en-US" sz="1550" dirty="0"/>
           </a:p>
@@ -3154,7 +3152,7 @@
                 <a:ea typeface="Arial" pitchFamily="34" charset="-122"/>
                 <a:cs typeface="Arial" pitchFamily="34" charset="-120"/>
               </a:rPr>
-              <a:t>PresentEventQA.C's refMult cut-line overlay now draws all 6 current edges, replacing a stale 5-bin overlay.</a:t>
+              <a:t/>
             </a:r>
             <a:endParaRPr lang="en-US" sz="1250" dirty="0"/>
           </a:p>
@@ -3241,7 +3239,7 @@
                 <a:ea typeface="Arial" pitchFamily="34" charset="-122"/>
                 <a:cs typeface="Arial" pitchFamily="34" charset="-120"/>
               </a:rPr>
-              <a:t>7</a:t>
+              <a:t>2</a:t>
             </a:r>
             <a:endParaRPr lang="en-US" sz="1000" dirty="0"/>
           </a:p>
@@ -3280,1415 +3278,7 @@
                 <a:ea typeface="Arial" pitchFamily="34" charset="-122"/>
                 <a:cs typeface="Arial" pitchFamily="34" charset="-120"/>
               </a:rPr>
-              <a:t>Andrew Liggett  •  July 13, 2026</a:t>
-            </a:r>
-            <a:endParaRPr lang="en-US" sz="1000" dirty="0"/>
-          </a:p>
-        </p:txBody>
-      </p:sp>
-    </p:spTree>
-  </p:cSld>
-  <p:clrMapOvr>
-    <a:masterClrMapping/>
-  </p:clrMapOvr>
-</p:sld>
-</file>
-
-<file path=ppt/slides/slide21.xml><?xml version="1.0" encoding="utf-8"?>
-<p:sld xmlns:a="http://schemas.openxmlformats.org/drawingml/2006/main" xmlns:r="http://schemas.openxmlformats.org/officeDocument/2006/relationships" xmlns:p="http://schemas.openxmlformats.org/presentationml/2006/main">
-  <p:cSld name="Slide 21">
-    <p:bg>
-      <p:bgPr>
-        <a:solidFill>
-          <a:srgbClr val="FFFFFF"/>
-        </a:solidFill>
-      </p:bgPr>
-    </p:bg>
-    <p:spTree>
-      <p:nvGrpSpPr>
-        <p:cNvPr id="1" name=""/>
-        <p:cNvGrpSpPr/>
-        <p:nvPr/>
-      </p:nvGrpSpPr>
-      <p:grpSpPr>
-        <a:xfrm>
-          <a:off x="0" y="0"/>
-          <a:ext cx="0" cy="0"/>
-          <a:chOff x="0" y="0"/>
-          <a:chExt cx="0" cy="0"/>
-        </a:xfrm>
-      </p:grpSpPr>
-      <p:sp>
-        <p:nvSpPr>
-          <p:cNvPr id="2" name="Text 0"/>
-          <p:cNvSpPr/>
-          <p:nvPr/>
-        </p:nvSpPr>
-        <p:spPr>
-          <a:xfrm>
-            <a:off x="457200" y="320040"/>
-            <a:ext cx="8229600" cy="274320"/>
-          </a:xfrm>
-          <a:prstGeom prst="rect">
-            <a:avLst/>
-          </a:prstGeom>
-          <a:noFill/>
-          <a:ln/>
-        </p:spPr>
-        <p:txBody>
-          <a:bodyPr wrap="square" lIns="0" tIns="0" rIns="0" bIns="0" rtlCol="0" anchor="ctr"/>
-          <a:lstStyle/>
-          <a:p>
-            <a:pPr indent="0" marL="0">
-              <a:buNone/>
-            </a:pPr>
-            <a:r>
-              <a:rPr lang="en-US" sz="1200" b="1" spc="200" kern="0" dirty="0">
-                <a:solidFill>
-                  <a:srgbClr val="5B6382"/>
-                </a:solidFill>
-                <a:latin typeface="Arial" pitchFamily="34" charset="0"/>
-                <a:ea typeface="Arial" pitchFamily="34" charset="-122"/>
-                <a:cs typeface="Arial" pitchFamily="34" charset="-120"/>
-              </a:rPr>
-              <a:t>TRACK QUALITY</a:t>
-            </a:r>
-            <a:endParaRPr lang="en-US" sz="1200" dirty="0"/>
-          </a:p>
-        </p:txBody>
-      </p:sp>
-      <p:sp>
-        <p:nvSpPr>
-          <p:cNvPr id="3" name="Text 1"/>
-          <p:cNvSpPr/>
-          <p:nvPr/>
-        </p:nvSpPr>
-        <p:spPr>
-          <a:xfrm>
-            <a:off x="457200" y="566928"/>
-            <a:ext cx="8229600" cy="640080"/>
-          </a:xfrm>
-          <a:prstGeom prst="rect">
-            <a:avLst/>
-          </a:prstGeom>
-          <a:noFill/>
-          <a:ln/>
-        </p:spPr>
-        <p:txBody>
-          <a:bodyPr wrap="square" lIns="0" tIns="0" rIns="0" bIns="0" rtlCol="0" anchor="ctr"/>
-          <a:lstStyle/>
-          <a:p>
-            <a:pPr indent="0" marL="0">
-              <a:buNone/>
-            </a:pPr>
-            <a:r>
-              <a:rPr lang="en-US" sz="3000" b="1" dirty="0">
-                <a:solidFill>
-                  <a:srgbClr val="1E2761"/>
-                </a:solidFill>
-                <a:latin typeface="Arial" pitchFamily="34" charset="0"/>
-                <a:ea typeface="Arial" pitchFamily="34" charset="-122"/>
-                <a:cs typeface="Arial" pitchFamily="34" charset="-120"/>
-              </a:rPr>
-              <a:t>NHitsFit &amp; NHitsMax</a:t>
-            </a:r>
-            <a:endParaRPr lang="en-US" sz="3000" dirty="0"/>
-          </a:p>
-        </p:txBody>
-      </p:sp>
-      <p:sp>
-        <p:nvSpPr>
-          <p:cNvPr id="4" name="Text 2"/>
-          <p:cNvSpPr/>
-          <p:nvPr/>
-        </p:nvSpPr>
-        <p:spPr>
-          <a:xfrm>
-            <a:off x="502920" y="1557008"/>
-            <a:ext cx="365760" cy="370840"/>
-          </a:xfrm>
-          <a:prstGeom prst="rect">
-            <a:avLst/>
-          </a:prstGeom>
-          <a:noFill/>
-          <a:ln/>
-        </p:spPr>
-        <p:txBody>
-          <a:bodyPr wrap="square" lIns="0" tIns="0" rIns="0" bIns="0" rtlCol="0" anchor="ctr"/>
-          <a:lstStyle/>
-          <a:p>
-            <a:pPr indent="0" marL="0">
-              <a:buNone/>
-            </a:pPr>
-            <a:r>
-              <a:rPr lang="en-US" sz="1700" b="1" dirty="0">
-                <a:solidFill>
-                  <a:srgbClr val="1E2761"/>
-                </a:solidFill>
-                <a:latin typeface="Arial" pitchFamily="34" charset="0"/>
-                <a:ea typeface="Arial" pitchFamily="34" charset="-122"/>
-                <a:cs typeface="Arial" pitchFamily="34" charset="-120"/>
-              </a:rPr>
-              <a:t>1.</a:t>
-            </a:r>
-            <a:endParaRPr lang="en-US" sz="1700" dirty="0"/>
-          </a:p>
-        </p:txBody>
-      </p:sp>
-      <p:sp>
-        <p:nvSpPr>
-          <p:cNvPr id="5" name="Text 3"/>
-          <p:cNvSpPr/>
-          <p:nvPr/>
-        </p:nvSpPr>
-        <p:spPr>
-          <a:xfrm>
-            <a:off x="886968" y="1557008"/>
-            <a:ext cx="3593592" cy="370840"/>
-          </a:xfrm>
-          <a:prstGeom prst="rect">
-            <a:avLst/>
-          </a:prstGeom>
-          <a:noFill/>
-          <a:ln/>
-        </p:spPr>
-        <p:txBody>
-          <a:bodyPr wrap="square" lIns="0" tIns="0" rIns="0" bIns="0" rtlCol="0" anchor="ctr"/>
-          <a:lstStyle/>
-          <a:p>
-            <a:pPr indent="0" marL="0">
-              <a:buNone/>
-            </a:pPr>
-            <a:r>
-              <a:rPr lang="en-US" sz="1550" b="1" dirty="0">
-                <a:solidFill>
-                  <a:srgbClr val="1E2761"/>
-                </a:solidFill>
-                <a:latin typeface="Arial" pitchFamily="34" charset="0"/>
-                <a:ea typeface="Arial" pitchFamily="34" charset="-122"/>
-                <a:cs typeface="Arial" pitchFamily="34" charset="-120"/>
-              </a:rPr>
-              <a:t>New side-by-side QA plot</a:t>
-            </a:r>
-            <a:endParaRPr lang="en-US" sz="1550" dirty="0"/>
-          </a:p>
-        </p:txBody>
-      </p:sp>
-      <p:sp>
-        <p:nvSpPr>
-          <p:cNvPr id="6" name="Text 4"/>
-          <p:cNvSpPr/>
-          <p:nvPr/>
-        </p:nvSpPr>
-        <p:spPr>
-          <a:xfrm>
-            <a:off x="886968" y="1927848"/>
-            <a:ext cx="3593592" cy="740000"/>
-          </a:xfrm>
-          <a:prstGeom prst="rect">
-            <a:avLst/>
-          </a:prstGeom>
-          <a:noFill/>
-          <a:ln/>
-        </p:spPr>
-        <p:txBody>
-          <a:bodyPr wrap="square" lIns="0" tIns="0" rIns="0" bIns="0" rtlCol="0" anchor="t"/>
-          <a:lstStyle/>
-          <a:p>
-            <a:pPr indent="0" marL="0">
-              <a:buNone/>
-            </a:pPr>
-            <a:r>
-              <a:rPr lang="en-US" sz="1250" dirty="0">
-                <a:solidFill>
-                  <a:srgbClr val="5B6382"/>
-                </a:solidFill>
-                <a:latin typeface="Arial" pitchFamily="34" charset="0"/>
-                <a:ea typeface="Arial" pitchFamily="34" charset="-122"/>
-                <a:cs typeface="Arial" pitchFamily="34" charset="-120"/>
-              </a:rPr>
-              <a:t>PresentNHitsEta.C now plots N_{hits}^{fit} and N_{hits}^{max} vs #eta together, to separate acceptance from cut effects.</a:t>
-            </a:r>
-            <a:endParaRPr lang="en-US" sz="1250" dirty="0"/>
-          </a:p>
-        </p:txBody>
-      </p:sp>
-      <p:sp>
-        <p:nvSpPr>
-          <p:cNvPr id="7" name="Text 5"/>
-          <p:cNvSpPr/>
-          <p:nvPr/>
-        </p:nvSpPr>
-        <p:spPr>
-          <a:xfrm>
-            <a:off x="4754880" y="1557008"/>
-            <a:ext cx="365760" cy="370840"/>
-          </a:xfrm>
-          <a:prstGeom prst="rect">
-            <a:avLst/>
-          </a:prstGeom>
-          <a:noFill/>
-          <a:ln/>
-        </p:spPr>
-        <p:txBody>
-          <a:bodyPr wrap="square" lIns="0" tIns="0" rIns="0" bIns="0" rtlCol="0" anchor="ctr"/>
-          <a:lstStyle/>
-          <a:p>
-            <a:pPr indent="0" marL="0">
-              <a:buNone/>
-            </a:pPr>
-            <a:r>
-              <a:rPr lang="en-US" sz="1700" b="1" dirty="0">
-                <a:solidFill>
-                  <a:srgbClr val="1E2761"/>
-                </a:solidFill>
-                <a:latin typeface="Arial" pitchFamily="34" charset="0"/>
-                <a:ea typeface="Arial" pitchFamily="34" charset="-122"/>
-                <a:cs typeface="Arial" pitchFamily="34" charset="-120"/>
-              </a:rPr>
-              <a:t>2.</a:t>
-            </a:r>
-            <a:endParaRPr lang="en-US" sz="1700" dirty="0"/>
-          </a:p>
-        </p:txBody>
-      </p:sp>
-      <p:sp>
-        <p:nvSpPr>
-          <p:cNvPr id="8" name="Text 6"/>
-          <p:cNvSpPr/>
-          <p:nvPr/>
-        </p:nvSpPr>
-        <p:spPr>
-          <a:xfrm>
-            <a:off x="5138928" y="1557008"/>
-            <a:ext cx="3593592" cy="370840"/>
-          </a:xfrm>
-          <a:prstGeom prst="rect">
-            <a:avLst/>
-          </a:prstGeom>
-          <a:noFill/>
-          <a:ln/>
-        </p:spPr>
-        <p:txBody>
-          <a:bodyPr wrap="square" lIns="0" tIns="0" rIns="0" bIns="0" rtlCol="0" anchor="ctr"/>
-          <a:lstStyle/>
-          <a:p>
-            <a:pPr indent="0" marL="0">
-              <a:buNone/>
-            </a:pPr>
-            <a:r>
-              <a:rPr lang="en-US" sz="1550" b="1" dirty="0">
-                <a:solidFill>
-                  <a:srgbClr val="1E2761"/>
-                </a:solidFill>
-                <a:latin typeface="Arial" pitchFamily="34" charset="0"/>
-                <a:ea typeface="Arial" pitchFamily="34" charset="-122"/>
-                <a:cs typeface="Arial" pitchFamily="34" charset="-120"/>
-              </a:rPr>
-              <a:t>Confirmed post-iTPC geometry</a:t>
-            </a:r>
-            <a:endParaRPr lang="en-US" sz="1550" dirty="0"/>
-          </a:p>
-        </p:txBody>
-      </p:sp>
-      <p:sp>
-        <p:nvSpPr>
-          <p:cNvPr id="9" name="Text 7"/>
-          <p:cNvSpPr/>
-          <p:nvPr/>
-        </p:nvSpPr>
-        <p:spPr>
-          <a:xfrm>
-            <a:off x="5138928" y="1927848"/>
-            <a:ext cx="3593592" cy="740000"/>
-          </a:xfrm>
-          <a:prstGeom prst="rect">
-            <a:avLst/>
-          </a:prstGeom>
-          <a:noFill/>
-          <a:ln/>
-        </p:spPr>
-        <p:txBody>
-          <a:bodyPr wrap="square" lIns="0" tIns="0" rIns="0" bIns="0" rtlCol="0" anchor="t"/>
-          <a:lstStyle/>
-          <a:p>
-            <a:pPr indent="0" marL="0">
-              <a:buNone/>
-            </a:pPr>
-            <a:r>
-              <a:rPr lang="en-US" sz="1250" dirty="0">
-                <a:solidFill>
-                  <a:srgbClr val="5B6382"/>
-                </a:solidFill>
-                <a:latin typeface="Arial" pitchFamily="34" charset="0"/>
-                <a:ea typeface="Arial" pitchFamily="34" charset="-122"/>
-                <a:cs typeface="Arial" pitchFamily="34" charset="-120"/>
-              </a:rPr>
-              <a:t>This dataset uses 72 padrows (40 inner + 32 outer), not the pre-upgrade 45; histogram binning widened 0-50 to 0-80 to stop clipping.</a:t>
-            </a:r>
-            <a:endParaRPr lang="en-US" sz="1250" dirty="0"/>
-          </a:p>
-        </p:txBody>
-      </p:sp>
-      <p:sp>
-        <p:nvSpPr>
-          <p:cNvPr id="10" name="Text 8"/>
-          <p:cNvSpPr/>
-          <p:nvPr/>
-        </p:nvSpPr>
-        <p:spPr>
-          <a:xfrm>
-            <a:off x="502920" y="3017848"/>
-            <a:ext cx="365760" cy="370840"/>
-          </a:xfrm>
-          <a:prstGeom prst="rect">
-            <a:avLst/>
-          </a:prstGeom>
-          <a:noFill/>
-          <a:ln/>
-        </p:spPr>
-        <p:txBody>
-          <a:bodyPr wrap="square" lIns="0" tIns="0" rIns="0" bIns="0" rtlCol="0" anchor="ctr"/>
-          <a:lstStyle/>
-          <a:p>
-            <a:pPr indent="0" marL="0">
-              <a:buNone/>
-            </a:pPr>
-            <a:r>
-              <a:rPr lang="en-US" sz="1700" b="1" dirty="0">
-                <a:solidFill>
-                  <a:srgbClr val="1E2761"/>
-                </a:solidFill>
-                <a:latin typeface="Arial" pitchFamily="34" charset="0"/>
-                <a:ea typeface="Arial" pitchFamily="34" charset="-122"/>
-                <a:cs typeface="Arial" pitchFamily="34" charset="-120"/>
-              </a:rPr>
-              <a:t>3.</a:t>
-            </a:r>
-            <a:endParaRPr lang="en-US" sz="1700" dirty="0"/>
-          </a:p>
-        </p:txBody>
-      </p:sp>
-      <p:sp>
-        <p:nvSpPr>
-          <p:cNvPr id="11" name="Text 9"/>
-          <p:cNvSpPr/>
-          <p:nvPr/>
-        </p:nvSpPr>
-        <p:spPr>
-          <a:xfrm>
-            <a:off x="886968" y="3017848"/>
-            <a:ext cx="3593592" cy="370840"/>
-          </a:xfrm>
-          <a:prstGeom prst="rect">
-            <a:avLst/>
-          </a:prstGeom>
-          <a:noFill/>
-          <a:ln/>
-        </p:spPr>
-        <p:txBody>
-          <a:bodyPr wrap="square" lIns="0" tIns="0" rIns="0" bIns="0" rtlCol="0" anchor="ctr"/>
-          <a:lstStyle/>
-          <a:p>
-            <a:pPr indent="0" marL="0">
-              <a:buNone/>
-            </a:pPr>
-            <a:r>
-              <a:rPr lang="en-US" sz="1550" b="1" dirty="0">
-                <a:solidFill>
-                  <a:srgbClr val="1E2761"/>
-                </a:solidFill>
-                <a:latin typeface="Arial" pitchFamily="34" charset="0"/>
-                <a:ea typeface="Arial" pitchFamily="34" charset="-122"/>
-                <a:cs typeface="Arial" pitchFamily="34" charset="-120"/>
-              </a:rPr>
-              <a:t>NHitsFit cut loosened as a variation</a:t>
-            </a:r>
-            <a:endParaRPr lang="en-US" sz="1550" dirty="0"/>
-          </a:p>
-        </p:txBody>
-      </p:sp>
-      <p:sp>
-        <p:nvSpPr>
-          <p:cNvPr id="12" name="Text 10"/>
-          <p:cNvSpPr/>
-          <p:nvPr/>
-        </p:nvSpPr>
-        <p:spPr>
-          <a:xfrm>
-            <a:off x="886968" y="3388688"/>
-            <a:ext cx="3593592" cy="740000"/>
-          </a:xfrm>
-          <a:prstGeom prst="rect">
-            <a:avLst/>
-          </a:prstGeom>
-          <a:noFill/>
-          <a:ln/>
-        </p:spPr>
-        <p:txBody>
-          <a:bodyPr wrap="square" lIns="0" tIns="0" rIns="0" bIns="0" rtlCol="0" anchor="t"/>
-          <a:lstStyle/>
-          <a:p>
-            <a:pPr indent="0" marL="0">
-              <a:buNone/>
-            </a:pPr>
-            <a:r>
-              <a:rPr lang="en-US" sz="1250" dirty="0">
-                <a:solidFill>
-                  <a:srgbClr val="5B6382"/>
-                </a:solidFill>
-                <a:latin typeface="Arial" pitchFamily="34" charset="0"/>
-                <a:ea typeface="Arial" pitchFamily="34" charset="-122"/>
-                <a:cs typeface="Arial" pitchFamily="34" charset="-120"/>
-              </a:rPr>
-              <a:t>Lowered 20 to 10 to test forward-track recovery -- a systematic variation, not yet the validated production value.</a:t>
-            </a:r>
-            <a:endParaRPr lang="en-US" sz="1250" dirty="0"/>
-          </a:p>
-        </p:txBody>
-      </p:sp>
-      <p:sp>
-        <p:nvSpPr>
-          <p:cNvPr id="13" name="Text 11"/>
-          <p:cNvSpPr/>
-          <p:nvPr/>
-        </p:nvSpPr>
-        <p:spPr>
-          <a:xfrm>
-            <a:off x="4754880" y="3017848"/>
-            <a:ext cx="365760" cy="370840"/>
-          </a:xfrm>
-          <a:prstGeom prst="rect">
-            <a:avLst/>
-          </a:prstGeom>
-          <a:noFill/>
-          <a:ln/>
-        </p:spPr>
-        <p:txBody>
-          <a:bodyPr wrap="square" lIns="0" tIns="0" rIns="0" bIns="0" rtlCol="0" anchor="ctr"/>
-          <a:lstStyle/>
-          <a:p>
-            <a:pPr indent="0" marL="0">
-              <a:buNone/>
-            </a:pPr>
-            <a:r>
-              <a:rPr lang="en-US" sz="1700" b="1" dirty="0">
-                <a:solidFill>
-                  <a:srgbClr val="1E2761"/>
-                </a:solidFill>
-                <a:latin typeface="Arial" pitchFamily="34" charset="0"/>
-                <a:ea typeface="Arial" pitchFamily="34" charset="-122"/>
-                <a:cs typeface="Arial" pitchFamily="34" charset="-120"/>
-              </a:rPr>
-              <a:t>4.</a:t>
-            </a:r>
-            <a:endParaRPr lang="en-US" sz="1700" dirty="0"/>
-          </a:p>
-        </p:txBody>
-      </p:sp>
-      <p:sp>
-        <p:nvSpPr>
-          <p:cNvPr id="14" name="Text 12"/>
-          <p:cNvSpPr/>
-          <p:nvPr/>
-        </p:nvSpPr>
-        <p:spPr>
-          <a:xfrm>
-            <a:off x="5138928" y="3017848"/>
-            <a:ext cx="3593592" cy="370840"/>
-          </a:xfrm>
-          <a:prstGeom prst="rect">
-            <a:avLst/>
-          </a:prstGeom>
-          <a:noFill/>
-          <a:ln/>
-        </p:spPr>
-        <p:txBody>
-          <a:bodyPr wrap="square" lIns="0" tIns="0" rIns="0" bIns="0" rtlCol="0" anchor="ctr"/>
-          <a:lstStyle/>
-          <a:p>
-            <a:pPr indent="0" marL="0">
-              <a:buNone/>
-            </a:pPr>
-            <a:r>
-              <a:rPr lang="en-US" sz="1550" b="1" dirty="0">
-                <a:solidFill>
-                  <a:srgbClr val="1E2761"/>
-                </a:solidFill>
-                <a:latin typeface="Arial" pitchFamily="34" charset="0"/>
-                <a:ea typeface="Arial" pitchFamily="34" charset="-122"/>
-                <a:cs typeface="Arial" pitchFamily="34" charset="-120"/>
-              </a:rPr>
-              <a:t>TPC corner traced to acceptance</a:t>
-            </a:r>
-            <a:endParaRPr lang="en-US" sz="1550" dirty="0"/>
-          </a:p>
-        </p:txBody>
-      </p:sp>
-      <p:sp>
-        <p:nvSpPr>
-          <p:cNvPr id="15" name="Text 13"/>
-          <p:cNvSpPr/>
-          <p:nvPr/>
-        </p:nvSpPr>
-        <p:spPr>
-          <a:xfrm>
-            <a:off x="5138928" y="3388688"/>
-            <a:ext cx="3593592" cy="740000"/>
-          </a:xfrm>
-          <a:prstGeom prst="rect">
-            <a:avLst/>
-          </a:prstGeom>
-          <a:noFill/>
-          <a:ln/>
-        </p:spPr>
-        <p:txBody>
-          <a:bodyPr wrap="square" lIns="0" tIns="0" rIns="0" bIns="0" rtlCol="0" anchor="t"/>
-          <a:lstStyle/>
-          <a:p>
-            <a:pPr indent="0" marL="0">
-              <a:buNone/>
-            </a:pPr>
-            <a:r>
-              <a:rPr lang="en-US" sz="1250" dirty="0">
-                <a:solidFill>
-                  <a:srgbClr val="5B6382"/>
-                </a:solidFill>
-                <a:latin typeface="Arial" pitchFamily="34" charset="0"/>
-                <a:ea typeface="Arial" pitchFamily="34" charset="-122"/>
-                <a:cs typeface="Arial" pitchFamily="34" charset="-120"/>
-              </a:rPr>
-              <a:t>Large |#eta| combined with low p_{T} reduces both N_{hits}^{max} and N_{hits}^{fit} together -- geometric, not a cut artifact.</a:t>
-            </a:r>
-            <a:endParaRPr lang="en-US" sz="1250" dirty="0"/>
-          </a:p>
-        </p:txBody>
-      </p:sp>
-      <p:pic>
-        <p:nvPicPr>
-          <p:cNvPr id="19" name="Image 0" descr="assets/ucdavis_seal.png"/>
-          <p:cNvPicPr>
-            <a:picLocks noChangeAspect="1"/>
-          </p:cNvPicPr>
-          <p:nvPr/>
-        </p:nvPicPr>
-        <p:blipFill>
-          <a:blip r:embed="rId1"/>
-          <a:stretch>
-            <a:fillRect/>
-          </a:stretch>
-        </p:blipFill>
-        <p:spPr>
-          <a:xfrm>
-            <a:off x="457200" y="4709160"/>
-            <a:ext cx="274320" cy="282092"/>
-          </a:xfrm>
-          <a:prstGeom prst="rect">
-            <a:avLst/>
-          </a:prstGeom>
-        </p:spPr>
-      </p:pic>
-      <p:pic>
-        <p:nvPicPr>
-          <p:cNvPr id="20" name="Image 1" descr="assets/star_logo.png"/>
-          <p:cNvPicPr>
-            <a:picLocks noChangeAspect="1"/>
-          </p:cNvPicPr>
-          <p:nvPr/>
-        </p:nvPicPr>
-        <p:blipFill>
-          <a:blip r:embed="rId2"/>
-          <a:stretch>
-            <a:fillRect/>
-          </a:stretch>
-        </p:blipFill>
-        <p:spPr>
-          <a:xfrm>
-            <a:off x="8092440" y="4709160"/>
-            <a:ext cx="379365" cy="292608"/>
-          </a:xfrm>
-          <a:prstGeom prst="rect">
-            <a:avLst/>
-          </a:prstGeom>
-        </p:spPr>
-      </p:pic>
-      <p:sp>
-        <p:nvSpPr>
-          <p:cNvPr id="21" name="Text 17"/>
-          <p:cNvSpPr/>
-          <p:nvPr/>
-        </p:nvSpPr>
-        <p:spPr>
-          <a:xfrm>
-            <a:off x="8549640" y="4828032"/>
-            <a:ext cx="457200" cy="274320"/>
-          </a:xfrm>
-          <a:prstGeom prst="rect">
-            <a:avLst/>
-          </a:prstGeom>
-          <a:noFill/>
-          <a:ln/>
-        </p:spPr>
-        <p:txBody>
-          <a:bodyPr wrap="square" lIns="0" tIns="0" rIns="0" bIns="0" rtlCol="0" anchor="ctr"/>
-          <a:lstStyle/>
-          <a:p>
-            <a:pPr algn="r" indent="0" marL="0">
-              <a:buNone/>
-            </a:pPr>
-            <a:r>
-              <a:rPr lang="en-US" sz="1000" dirty="0">
-                <a:solidFill>
-                  <a:srgbClr val="5B6382"/>
-                </a:solidFill>
-                <a:latin typeface="Arial" pitchFamily="34" charset="0"/>
-                <a:ea typeface="Arial" pitchFamily="34" charset="-122"/>
-                <a:cs typeface="Arial" pitchFamily="34" charset="-120"/>
-              </a:rPr>
-              <a:t>8</a:t>
-            </a:r>
-            <a:endParaRPr lang="en-US" sz="1000" dirty="0"/>
-          </a:p>
-        </p:txBody>
-      </p:sp>
-      <p:sp>
-        <p:nvSpPr>
-          <p:cNvPr id="22" name="Text 18"/>
-          <p:cNvSpPr/>
-          <p:nvPr/>
-        </p:nvSpPr>
-        <p:spPr>
-          <a:xfrm>
-            <a:off x="841248" y="4828032"/>
-            <a:ext cx="6766560" cy="274320"/>
-          </a:xfrm>
-          <a:prstGeom prst="rect">
-            <a:avLst/>
-          </a:prstGeom>
-          <a:noFill/>
-          <a:ln/>
-        </p:spPr>
-        <p:txBody>
-          <a:bodyPr wrap="square" lIns="0" tIns="0" rIns="0" bIns="0" rtlCol="0" anchor="ctr"/>
-          <a:lstStyle/>
-          <a:p>
-            <a:pPr algn="l" indent="0" marL="0">
-              <a:buNone/>
-            </a:pPr>
-            <a:r>
-              <a:rPr lang="en-US" sz="1000" dirty="0">
-                <a:solidFill>
-                  <a:srgbClr val="5B6382"/>
-                </a:solidFill>
-                <a:latin typeface="Arial" pitchFamily="34" charset="0"/>
-                <a:ea typeface="Arial" pitchFamily="34" charset="-122"/>
-                <a:cs typeface="Arial" pitchFamily="34" charset="-120"/>
-              </a:rPr>
-              <a:t>Andrew Liggett  •  July 13, 2026</a:t>
-            </a:r>
-            <a:endParaRPr lang="en-US" sz="1000" dirty="0"/>
-          </a:p>
-        </p:txBody>
-      </p:sp>
-    </p:spTree>
-  </p:cSld>
-  <p:clrMapOvr>
-    <a:masterClrMapping/>
-  </p:clrMapOvr>
-</p:sld>
-</file>
-
-<file path=ppt/slides/slide22.xml><?xml version="1.0" encoding="utf-8"?>
-<p:sld xmlns:a="http://schemas.openxmlformats.org/drawingml/2006/main" xmlns:r="http://schemas.openxmlformats.org/officeDocument/2006/relationships" xmlns:p="http://schemas.openxmlformats.org/presentationml/2006/main">
-  <p:cSld name="Slide 22">
-    <p:bg>
-      <p:bgPr>
-        <a:solidFill>
-          <a:srgbClr val="FFFFFF"/>
-        </a:solidFill>
-      </p:bgPr>
-    </p:bg>
-    <p:spTree>
-      <p:nvGrpSpPr>
-        <p:cNvPr id="1" name=""/>
-        <p:cNvGrpSpPr/>
-        <p:nvPr/>
-      </p:nvGrpSpPr>
-      <p:grpSpPr>
-        <a:xfrm>
-          <a:off x="0" y="0"/>
-          <a:ext cx="0" cy="0"/>
-          <a:chOff x="0" y="0"/>
-          <a:chExt cx="0" cy="0"/>
-        </a:xfrm>
-      </p:grpSpPr>
-      <p:sp>
-        <p:nvSpPr>
-          <p:cNvPr id="2" name="Text 0"/>
-          <p:cNvSpPr/>
-          <p:nvPr/>
-        </p:nvSpPr>
-        <p:spPr>
-          <a:xfrm>
-            <a:off x="457200" y="320040"/>
-            <a:ext cx="8229600" cy="274320"/>
-          </a:xfrm>
-          <a:prstGeom prst="rect">
-            <a:avLst/>
-          </a:prstGeom>
-          <a:noFill/>
-          <a:ln/>
-        </p:spPr>
-        <p:txBody>
-          <a:bodyPr wrap="square" lIns="0" tIns="0" rIns="0" bIns="0" rtlCol="0" anchor="ctr"/>
-          <a:lstStyle/>
-          <a:p>
-            <a:pPr indent="0" marL="0">
-              <a:buNone/>
-            </a:pPr>
-            <a:r>
-              <a:rPr lang="en-US" sz="1200" b="1" spc="200" kern="0" dirty="0">
-                <a:solidFill>
-                  <a:srgbClr val="5B6382"/>
-                </a:solidFill>
-                <a:latin typeface="Arial" pitchFamily="34" charset="0"/>
-                <a:ea typeface="Arial" pitchFamily="34" charset="-122"/>
-                <a:cs typeface="Arial" pitchFamily="34" charset="-120"/>
-              </a:rPr>
-              <a:t>CUT UPDATES</a:t>
-            </a:r>
-            <a:endParaRPr lang="en-US" sz="1200" dirty="0"/>
-          </a:p>
-        </p:txBody>
-      </p:sp>
-      <p:sp>
-        <p:nvSpPr>
-          <p:cNvPr id="3" name="Text 1"/>
-          <p:cNvSpPr/>
-          <p:nvPr/>
-        </p:nvSpPr>
-        <p:spPr>
-          <a:xfrm>
-            <a:off x="457200" y="566928"/>
-            <a:ext cx="8229600" cy="640080"/>
-          </a:xfrm>
-          <a:prstGeom prst="rect">
-            <a:avLst/>
-          </a:prstGeom>
-          <a:noFill/>
-          <a:ln/>
-        </p:spPr>
-        <p:txBody>
-          <a:bodyPr wrap="square" lIns="0" tIns="0" rIns="0" bIns="0" rtlCol="0" anchor="ctr"/>
-          <a:lstStyle/>
-          <a:p>
-            <a:pPr indent="0" marL="0">
-              <a:buNone/>
-            </a:pPr>
-            <a:r>
-              <a:rPr lang="en-US" sz="3000" b="1" dirty="0">
-                <a:solidFill>
-                  <a:srgbClr val="1E2761"/>
-                </a:solidFill>
-                <a:latin typeface="Arial" pitchFamily="34" charset="0"/>
-                <a:ea typeface="Arial" pitchFamily="34" charset="-122"/>
-                <a:cs typeface="Arial" pitchFamily="34" charset="-120"/>
-              </a:rPr>
-              <a:t>DCA &amp; Vertex Cuts</a:t>
-            </a:r>
-            <a:endParaRPr lang="en-US" sz="3000" dirty="0"/>
-          </a:p>
-        </p:txBody>
-      </p:sp>
-      <p:sp>
-        <p:nvSpPr>
-          <p:cNvPr id="4" name="Text 2"/>
-          <p:cNvSpPr/>
-          <p:nvPr/>
-        </p:nvSpPr>
-        <p:spPr>
-          <a:xfrm>
-            <a:off x="502920" y="1557008"/>
-            <a:ext cx="365760" cy="370840"/>
-          </a:xfrm>
-          <a:prstGeom prst="rect">
-            <a:avLst/>
-          </a:prstGeom>
-          <a:noFill/>
-          <a:ln/>
-        </p:spPr>
-        <p:txBody>
-          <a:bodyPr wrap="square" lIns="0" tIns="0" rIns="0" bIns="0" rtlCol="0" anchor="ctr"/>
-          <a:lstStyle/>
-          <a:p>
-            <a:pPr indent="0" marL="0">
-              <a:buNone/>
-            </a:pPr>
-            <a:r>
-              <a:rPr lang="en-US" sz="1700" b="1" dirty="0">
-                <a:solidFill>
-                  <a:srgbClr val="1E2761"/>
-                </a:solidFill>
-                <a:latin typeface="Arial" pitchFamily="34" charset="0"/>
-                <a:ea typeface="Arial" pitchFamily="34" charset="-122"/>
-                <a:cs typeface="Arial" pitchFamily="34" charset="-120"/>
-              </a:rPr>
-              <a:t>1.</a:t>
-            </a:r>
-            <a:endParaRPr lang="en-US" sz="1700" dirty="0"/>
-          </a:p>
-        </p:txBody>
-      </p:sp>
-      <p:sp>
-        <p:nvSpPr>
-          <p:cNvPr id="5" name="Text 3"/>
-          <p:cNvSpPr/>
-          <p:nvPr/>
-        </p:nvSpPr>
-        <p:spPr>
-          <a:xfrm>
-            <a:off x="886968" y="1557008"/>
-            <a:ext cx="3593592" cy="370840"/>
-          </a:xfrm>
-          <a:prstGeom prst="rect">
-            <a:avLst/>
-          </a:prstGeom>
-          <a:noFill/>
-          <a:ln/>
-        </p:spPr>
-        <p:txBody>
-          <a:bodyPr wrap="square" lIns="0" tIns="0" rIns="0" bIns="0" rtlCol="0" anchor="ctr"/>
-          <a:lstStyle/>
-          <a:p>
-            <a:pPr indent="0" marL="0">
-              <a:buNone/>
-            </a:pPr>
-            <a:r>
-              <a:rPr lang="en-US" sz="1550" b="1" dirty="0">
-                <a:solidFill>
-                  <a:srgbClr val="1E2761"/>
-                </a:solidFill>
-                <a:latin typeface="Arial" pitchFamily="34" charset="0"/>
-                <a:ea typeface="Arial" pitchFamily="34" charset="-122"/>
-                <a:cs typeface="Arial" pitchFamily="34" charset="-120"/>
-              </a:rPr>
-              <a:t>DCA relaxed to 1 cm as a variation</a:t>
-            </a:r>
-            <a:endParaRPr lang="en-US" sz="1550" dirty="0"/>
-          </a:p>
-        </p:txBody>
-      </p:sp>
-      <p:sp>
-        <p:nvSpPr>
-          <p:cNvPr id="6" name="Text 4"/>
-          <p:cNvSpPr/>
-          <p:nvPr/>
-        </p:nvSpPr>
-        <p:spPr>
-          <a:xfrm>
-            <a:off x="886968" y="1927848"/>
-            <a:ext cx="3593592" cy="740000"/>
-          </a:xfrm>
-          <a:prstGeom prst="rect">
-            <a:avLst/>
-          </a:prstGeom>
-          <a:noFill/>
-          <a:ln/>
-        </p:spPr>
-        <p:txBody>
-          <a:bodyPr wrap="square" lIns="0" tIns="0" rIns="0" bIns="0" rtlCol="0" anchor="t"/>
-          <a:lstStyle/>
-          <a:p>
-            <a:pPr indent="0" marL="0">
-              <a:buNone/>
-            </a:pPr>
-            <a:r>
-              <a:rPr lang="en-US" sz="1250" dirty="0">
-                <a:solidFill>
-                  <a:srgbClr val="5B6382"/>
-                </a:solidFill>
-                <a:latin typeface="Arial" pitchFamily="34" charset="0"/>
-                <a:ea typeface="Arial" pitchFamily="34" charset="-122"/>
-                <a:cs typeface="Arial" pitchFamily="34" charset="-120"/>
-              </a:rPr>
-              <a:t>The SDCC-matched, validated value is 3 cm; the current 1 cm setting hasn't been re-verified against SDCC output.</a:t>
-            </a:r>
-            <a:endParaRPr lang="en-US" sz="1250" dirty="0"/>
-          </a:p>
-        </p:txBody>
-      </p:sp>
-      <p:sp>
-        <p:nvSpPr>
-          <p:cNvPr id="7" name="Text 5"/>
-          <p:cNvSpPr/>
-          <p:nvPr/>
-        </p:nvSpPr>
-        <p:spPr>
-          <a:xfrm>
-            <a:off x="4754880" y="1557008"/>
-            <a:ext cx="365760" cy="370840"/>
-          </a:xfrm>
-          <a:prstGeom prst="rect">
-            <a:avLst/>
-          </a:prstGeom>
-          <a:noFill/>
-          <a:ln/>
-        </p:spPr>
-        <p:txBody>
-          <a:bodyPr wrap="square" lIns="0" tIns="0" rIns="0" bIns="0" rtlCol="0" anchor="ctr"/>
-          <a:lstStyle/>
-          <a:p>
-            <a:pPr indent="0" marL="0">
-              <a:buNone/>
-            </a:pPr>
-            <a:r>
-              <a:rPr lang="en-US" sz="1700" b="1" dirty="0">
-                <a:solidFill>
-                  <a:srgbClr val="1E2761"/>
-                </a:solidFill>
-                <a:latin typeface="Arial" pitchFamily="34" charset="0"/>
-                <a:ea typeface="Arial" pitchFamily="34" charset="-122"/>
-                <a:cs typeface="Arial" pitchFamily="34" charset="-120"/>
-              </a:rPr>
-              <a:t>2.</a:t>
-            </a:r>
-            <a:endParaRPr lang="en-US" sz="1700" dirty="0"/>
-          </a:p>
-        </p:txBody>
-      </p:sp>
-      <p:sp>
-        <p:nvSpPr>
-          <p:cNvPr id="8" name="Text 6"/>
-          <p:cNvSpPr/>
-          <p:nvPr/>
-        </p:nvSpPr>
-        <p:spPr>
-          <a:xfrm>
-            <a:off x="5138928" y="1557008"/>
-            <a:ext cx="3593592" cy="370840"/>
-          </a:xfrm>
-          <a:prstGeom prst="rect">
-            <a:avLst/>
-          </a:prstGeom>
-          <a:noFill/>
-          <a:ln/>
-        </p:spPr>
-        <p:txBody>
-          <a:bodyPr wrap="square" lIns="0" tIns="0" rIns="0" bIns="0" rtlCol="0" anchor="ctr"/>
-          <a:lstStyle/>
-          <a:p>
-            <a:pPr indent="0" marL="0">
-              <a:buNone/>
-            </a:pPr>
-            <a:r>
-              <a:rPr lang="en-US" sz="1550" b="1" dirty="0">
-                <a:solidFill>
-                  <a:srgbClr val="1E2761"/>
-                </a:solidFill>
-                <a:latin typeface="Arial" pitchFamily="34" charset="0"/>
-                <a:ea typeface="Arial" pitchFamily="34" charset="-122"/>
-                <a:cs typeface="Arial" pitchFamily="34" charset="-120"/>
-              </a:rPr>
-              <a:t>Event-level z-vertex cut unchanged</a:t>
-            </a:r>
-            <a:endParaRPr lang="en-US" sz="1550" dirty="0"/>
-          </a:p>
-        </p:txBody>
-      </p:sp>
-      <p:sp>
-        <p:nvSpPr>
-          <p:cNvPr id="9" name="Text 7"/>
-          <p:cNvSpPr/>
-          <p:nvPr/>
-        </p:nvSpPr>
-        <p:spPr>
-          <a:xfrm>
-            <a:off x="5138928" y="1927848"/>
-            <a:ext cx="3593592" cy="740000"/>
-          </a:xfrm>
-          <a:prstGeom prst="rect">
-            <a:avLst/>
-          </a:prstGeom>
-          <a:noFill/>
-          <a:ln/>
-        </p:spPr>
-        <p:txBody>
-          <a:bodyPr wrap="square" lIns="0" tIns="0" rIns="0" bIns="0" rtlCol="0" anchor="t"/>
-          <a:lstStyle/>
-          <a:p>
-            <a:pPr indent="0" marL="0">
-              <a:buNone/>
-            </a:pPr>
-            <a:r>
-              <a:rPr lang="en-US" sz="1250" dirty="0">
-                <a:solidFill>
-                  <a:srgbClr val="5B6382"/>
-                </a:solidFill>
-                <a:latin typeface="Arial" pitchFamily="34" charset="0"/>
-                <a:ea typeface="Arial" pitchFamily="34" charset="-122"/>
-                <a:cs typeface="Arial" pitchFamily="34" charset="-120"/>
-              </a:rPr>
-              <a:t>cuts-&gt;setZRange(-2,2) in SetCutClass.C is untouched -- this is the actual event selection, not a display setting.</a:t>
-            </a:r>
-            <a:endParaRPr lang="en-US" sz="1250" dirty="0"/>
-          </a:p>
-        </p:txBody>
-      </p:sp>
-      <p:sp>
-        <p:nvSpPr>
-          <p:cNvPr id="10" name="Text 8"/>
-          <p:cNvSpPr/>
-          <p:nvPr/>
-        </p:nvSpPr>
-        <p:spPr>
-          <a:xfrm>
-            <a:off x="502920" y="3017848"/>
-            <a:ext cx="365760" cy="370840"/>
-          </a:xfrm>
-          <a:prstGeom prst="rect">
-            <a:avLst/>
-          </a:prstGeom>
-          <a:noFill/>
-          <a:ln/>
-        </p:spPr>
-        <p:txBody>
-          <a:bodyPr wrap="square" lIns="0" tIns="0" rIns="0" bIns="0" rtlCol="0" anchor="ctr"/>
-          <a:lstStyle/>
-          <a:p>
-            <a:pPr indent="0" marL="0">
-              <a:buNone/>
-            </a:pPr>
-            <a:r>
-              <a:rPr lang="en-US" sz="1700" b="1" dirty="0">
-                <a:solidFill>
-                  <a:srgbClr val="1E2761"/>
-                </a:solidFill>
-                <a:latin typeface="Arial" pitchFamily="34" charset="0"/>
-                <a:ea typeface="Arial" pitchFamily="34" charset="-122"/>
-                <a:cs typeface="Arial" pitchFamily="34" charset="-120"/>
-              </a:rPr>
-              <a:t>3.</a:t>
-            </a:r>
-            <a:endParaRPr lang="en-US" sz="1700" dirty="0"/>
-          </a:p>
-        </p:txBody>
-      </p:sp>
-      <p:sp>
-        <p:nvSpPr>
-          <p:cNvPr id="11" name="Text 9"/>
-          <p:cNvSpPr/>
-          <p:nvPr/>
-        </p:nvSpPr>
-        <p:spPr>
-          <a:xfrm>
-            <a:off x="886968" y="3017848"/>
-            <a:ext cx="3593592" cy="370840"/>
-          </a:xfrm>
-          <a:prstGeom prst="rect">
-            <a:avLst/>
-          </a:prstGeom>
-          <a:noFill/>
-          <a:ln/>
-        </p:spPr>
-        <p:txBody>
-          <a:bodyPr wrap="square" lIns="0" tIns="0" rIns="0" bIns="0" rtlCol="0" anchor="ctr"/>
-          <a:lstStyle/>
-          <a:p>
-            <a:pPr indent="0" marL="0">
-              <a:buNone/>
-            </a:pPr>
-            <a:r>
-              <a:rPr lang="en-US" sz="1550" b="1" dirty="0">
-                <a:solidFill>
-                  <a:srgbClr val="1E2761"/>
-                </a:solidFill>
-                <a:latin typeface="Arial" pitchFamily="34" charset="0"/>
-                <a:ea typeface="Arial" pitchFamily="34" charset="-122"/>
-                <a:cs typeface="Arial" pitchFamily="34" charset="-120"/>
-              </a:rPr>
-              <a:t>QA display window tightened only</a:t>
-            </a:r>
-            <a:endParaRPr lang="en-US" sz="1550" dirty="0"/>
-          </a:p>
-        </p:txBody>
-      </p:sp>
-      <p:sp>
-        <p:nvSpPr>
-          <p:cNvPr id="12" name="Text 10"/>
-          <p:cNvSpPr/>
-          <p:nvPr/>
-        </p:nvSpPr>
-        <p:spPr>
-          <a:xfrm>
-            <a:off x="886968" y="3388688"/>
-            <a:ext cx="3593592" cy="740000"/>
-          </a:xfrm>
-          <a:prstGeom prst="rect">
-            <a:avLst/>
-          </a:prstGeom>
-          <a:noFill/>
-          <a:ln/>
-        </p:spPr>
-        <p:txBody>
-          <a:bodyPr wrap="square" lIns="0" tIns="0" rIns="0" bIns="0" rtlCol="0" anchor="t"/>
-          <a:lstStyle/>
-          <a:p>
-            <a:pPr indent="0" marL="0">
-              <a:buNone/>
-            </a:pPr>
-            <a:r>
-              <a:rPr lang="en-US" sz="1250" dirty="0">
-                <a:solidFill>
-                  <a:srgbClr val="5B6382"/>
-                </a:solidFill>
-                <a:latin typeface="Arial" pitchFamily="34" charset="0"/>
-                <a:ea typeface="Arial" pitchFamily="34" charset="-122"/>
-                <a:cs typeface="Arial" pitchFamily="34" charset="-120"/>
-              </a:rPr>
-              <a:t>PresentEventQA.C now zooms the z-vertex plot to +/-3cm for readability; it doesn't change the cut or drop any entries.</a:t>
-            </a:r>
-            <a:endParaRPr lang="en-US" sz="1250" dirty="0"/>
-          </a:p>
-        </p:txBody>
-      </p:sp>
-      <p:sp>
-        <p:nvSpPr>
-          <p:cNvPr id="13" name="Text 11"/>
-          <p:cNvSpPr/>
-          <p:nvPr/>
-        </p:nvSpPr>
-        <p:spPr>
-          <a:xfrm>
-            <a:off x="4754880" y="3017848"/>
-            <a:ext cx="365760" cy="370840"/>
-          </a:xfrm>
-          <a:prstGeom prst="rect">
-            <a:avLst/>
-          </a:prstGeom>
-          <a:noFill/>
-          <a:ln/>
-        </p:spPr>
-        <p:txBody>
-          <a:bodyPr wrap="square" lIns="0" tIns="0" rIns="0" bIns="0" rtlCol="0" anchor="ctr"/>
-          <a:lstStyle/>
-          <a:p>
-            <a:pPr indent="0" marL="0">
-              <a:buNone/>
-            </a:pPr>
-            <a:r>
-              <a:rPr lang="en-US" sz="1700" b="1" dirty="0">
-                <a:solidFill>
-                  <a:srgbClr val="1E2761"/>
-                </a:solidFill>
-                <a:latin typeface="Arial" pitchFamily="34" charset="0"/>
-                <a:ea typeface="Arial" pitchFamily="34" charset="-122"/>
-                <a:cs typeface="Arial" pitchFamily="34" charset="-120"/>
-              </a:rPr>
-              <a:t/>
-            </a:r>
-            <a:endParaRPr lang="en-US" sz="1700" dirty="0"/>
-          </a:p>
-        </p:txBody>
-      </p:sp>
-      <p:sp>
-        <p:nvSpPr>
-          <p:cNvPr id="14" name="Text 12"/>
-          <p:cNvSpPr/>
-          <p:nvPr/>
-        </p:nvSpPr>
-        <p:spPr>
-          <a:xfrm>
-            <a:off x="5138928" y="3017848"/>
-            <a:ext cx="3593592" cy="370840"/>
-          </a:xfrm>
-          <a:prstGeom prst="rect">
-            <a:avLst/>
-          </a:prstGeom>
-          <a:noFill/>
-          <a:ln/>
-        </p:spPr>
-        <p:txBody>
-          <a:bodyPr wrap="square" lIns="0" tIns="0" rIns="0" bIns="0" rtlCol="0" anchor="ctr"/>
-          <a:lstStyle/>
-          <a:p>
-            <a:pPr indent="0" marL="0">
-              <a:buNone/>
-            </a:pPr>
-            <a:r>
-              <a:rPr lang="en-US" sz="1550" b="1" dirty="0">
-                <a:solidFill>
-                  <a:srgbClr val="1E2761"/>
-                </a:solidFill>
-                <a:latin typeface="Arial" pitchFamily="34" charset="0"/>
-                <a:ea typeface="Arial" pitchFamily="34" charset="-122"/>
-                <a:cs typeface="Arial" pitchFamily="34" charset="-120"/>
-              </a:rPr>
-              <a:t/>
-            </a:r>
-            <a:endParaRPr lang="en-US" sz="1550" dirty="0"/>
-          </a:p>
-        </p:txBody>
-      </p:sp>
-      <p:sp>
-        <p:nvSpPr>
-          <p:cNvPr id="15" name="Text 13"/>
-          <p:cNvSpPr/>
-          <p:nvPr/>
-        </p:nvSpPr>
-        <p:spPr>
-          <a:xfrm>
-            <a:off x="5138928" y="3388688"/>
-            <a:ext cx="3593592" cy="740000"/>
-          </a:xfrm>
-          <a:prstGeom prst="rect">
-            <a:avLst/>
-          </a:prstGeom>
-          <a:noFill/>
-          <a:ln/>
-        </p:spPr>
-        <p:txBody>
-          <a:bodyPr wrap="square" lIns="0" tIns="0" rIns="0" bIns="0" rtlCol="0" anchor="t"/>
-          <a:lstStyle/>
-          <a:p>
-            <a:pPr indent="0" marL="0">
-              <a:buNone/>
-            </a:pPr>
-            <a:r>
-              <a:rPr lang="en-US" sz="1250" dirty="0">
-                <a:solidFill>
-                  <a:srgbClr val="5B6382"/>
-                </a:solidFill>
-                <a:latin typeface="Arial" pitchFamily="34" charset="0"/>
-                <a:ea typeface="Arial" pitchFamily="34" charset="-122"/>
-                <a:cs typeface="Arial" pitchFamily="34" charset="-120"/>
-              </a:rPr>
-              <a:t/>
-            </a:r>
-            <a:endParaRPr lang="en-US" sz="1250" dirty="0"/>
-          </a:p>
-        </p:txBody>
-      </p:sp>
-      <p:pic>
-        <p:nvPicPr>
-          <p:cNvPr id="19" name="Image 0" descr="assets/ucdavis_seal.png"/>
-          <p:cNvPicPr>
-            <a:picLocks noChangeAspect="1"/>
-          </p:cNvPicPr>
-          <p:nvPr/>
-        </p:nvPicPr>
-        <p:blipFill>
-          <a:blip r:embed="rId1"/>
-          <a:stretch>
-            <a:fillRect/>
-          </a:stretch>
-        </p:blipFill>
-        <p:spPr>
-          <a:xfrm>
-            <a:off x="457200" y="4709160"/>
-            <a:ext cx="274320" cy="282092"/>
-          </a:xfrm>
-          <a:prstGeom prst="rect">
-            <a:avLst/>
-          </a:prstGeom>
-        </p:spPr>
-      </p:pic>
-      <p:pic>
-        <p:nvPicPr>
-          <p:cNvPr id="20" name="Image 1" descr="assets/star_logo.png"/>
-          <p:cNvPicPr>
-            <a:picLocks noChangeAspect="1"/>
-          </p:cNvPicPr>
-          <p:nvPr/>
-        </p:nvPicPr>
-        <p:blipFill>
-          <a:blip r:embed="rId2"/>
-          <a:stretch>
-            <a:fillRect/>
-          </a:stretch>
-        </p:blipFill>
-        <p:spPr>
-          <a:xfrm>
-            <a:off x="8092440" y="4709160"/>
-            <a:ext cx="379365" cy="292608"/>
-          </a:xfrm>
-          <a:prstGeom prst="rect">
-            <a:avLst/>
-          </a:prstGeom>
-        </p:spPr>
-      </p:pic>
-      <p:sp>
-        <p:nvSpPr>
-          <p:cNvPr id="21" name="Text 17"/>
-          <p:cNvSpPr/>
-          <p:nvPr/>
-        </p:nvSpPr>
-        <p:spPr>
-          <a:xfrm>
-            <a:off x="8549640" y="4828032"/>
-            <a:ext cx="457200" cy="274320"/>
-          </a:xfrm>
-          <a:prstGeom prst="rect">
-            <a:avLst/>
-          </a:prstGeom>
-          <a:noFill/>
-          <a:ln/>
-        </p:spPr>
-        <p:txBody>
-          <a:bodyPr wrap="square" lIns="0" tIns="0" rIns="0" bIns="0" rtlCol="0" anchor="ctr"/>
-          <a:lstStyle/>
-          <a:p>
-            <a:pPr algn="r" indent="0" marL="0">
-              <a:buNone/>
-            </a:pPr>
-            <a:r>
-              <a:rPr lang="en-US" sz="1000" dirty="0">
-                <a:solidFill>
-                  <a:srgbClr val="5B6382"/>
-                </a:solidFill>
-                <a:latin typeface="Arial" pitchFamily="34" charset="0"/>
-                <a:ea typeface="Arial" pitchFamily="34" charset="-122"/>
-                <a:cs typeface="Arial" pitchFamily="34" charset="-120"/>
-              </a:rPr>
-              <a:t>9</a:t>
-            </a:r>
-            <a:endParaRPr lang="en-US" sz="1000" dirty="0"/>
-          </a:p>
-        </p:txBody>
-      </p:sp>
-      <p:sp>
-        <p:nvSpPr>
-          <p:cNvPr id="22" name="Text 18"/>
-          <p:cNvSpPr/>
-          <p:nvPr/>
-        </p:nvSpPr>
-        <p:spPr>
-          <a:xfrm>
-            <a:off x="841248" y="4828032"/>
-            <a:ext cx="6766560" cy="274320"/>
-          </a:xfrm>
-          <a:prstGeom prst="rect">
-            <a:avLst/>
-          </a:prstGeom>
-          <a:noFill/>
-          <a:ln/>
-        </p:spPr>
-        <p:txBody>
-          <a:bodyPr wrap="square" lIns="0" tIns="0" rIns="0" bIns="0" rtlCol="0" anchor="ctr"/>
-          <a:lstStyle/>
-          <a:p>
-            <a:pPr algn="l" indent="0" marL="0">
-              <a:buNone/>
-            </a:pPr>
-            <a:r>
-              <a:rPr lang="en-US" sz="1000" dirty="0">
-                <a:solidFill>
-                  <a:srgbClr val="5B6382"/>
-                </a:solidFill>
-                <a:latin typeface="Arial" pitchFamily="34" charset="0"/>
-                <a:ea typeface="Arial" pitchFamily="34" charset="-122"/>
-                <a:cs typeface="Arial" pitchFamily="34" charset="-120"/>
-              </a:rPr>
-              <a:t>Andrew Liggett  •  July 13, 2026</a:t>
+              <a:t>Andrew Liggett  •  July 14, 2026</a:t>
             </a:r>
             <a:endParaRPr lang="en-US" sz="1000" dirty="0"/>
           </a:p>

</xml_diff>

<commit_message>
Remove mentions of the peripheral bin having been previously dropped
</commit_message>
<xml_diff>
--- a/docs/OO200_Spectra_Status_Update.pptx
+++ b/docs/OO200_Spectra_Status_Update.pptx
@@ -2762,7 +2762,7 @@
                 <a:ea typeface="Arial" pitchFamily="34" charset="-122"/>
                 <a:cs typeface="Arial" pitchFamily="34" charset="-120"/>
               </a:rPr>
-              <a:t>Centrality: 6-bin scheme, periphery restored</a:t>
+              <a:t>Centrality: 6-bin scheme</a:t>
             </a:r>
             <a:endParaRPr lang="en-US" sz="1550" dirty="0"/>
           </a:p>
@@ -2801,7 +2801,7 @@
                 <a:ea typeface="Arial" pitchFamily="34" charset="-122"/>
                 <a:cs typeface="Arial" pitchFamily="34" charset="-120"/>
               </a:rPr>
-              <a:t>Six bins: 0-5%, 5-10%, 10-20%, 20-40%, 40-80%, 80-100% -- the 80-100% bin was previously dropped.</a:t>
+              <a:t>Six bins: 0-5%, 5-10%, 10-20%, 20-40%, 40-80%, 80-100%.</a:t>
             </a:r>
             <a:endParaRPr lang="en-US" sz="1250" dirty="0"/>
           </a:p>

</xml_diff>

<commit_message>
Fix DCA bullet: tightened (not loosened) to 1cm from 3cm
</commit_message>
<xml_diff>
--- a/docs/OO200_Spectra_Status_Update.pptx
+++ b/docs/OO200_Spectra_Status_Update.pptx
@@ -2996,7 +2996,7 @@
                 <a:ea typeface="Arial" pitchFamily="34" charset="-122"/>
                 <a:cs typeface="Arial" pitchFamily="34" charset="-120"/>
               </a:rPr>
-              <a:t>DCA &amp; vertex: relaxed cuts under test</a:t>
+              <a:t>DCA &amp; vertex: tightened cut under test</a:t>
             </a:r>
             <a:endParaRPr lang="en-US" sz="1550" dirty="0"/>
           </a:p>
@@ -3035,7 +3035,7 @@
                 <a:ea typeface="Arial" pitchFamily="34" charset="-122"/>
                 <a:cs typeface="Arial" pitchFamily="34" charset="-120"/>
               </a:rPr>
-              <a:t>DCA loosened to 1cm as a variation, not yet production; the actual z-vertex cut is unchanged at +/-2cm.</a:t>
+              <a:t>DCA tightened to 1cm as a variation, not yet production; the actual z-vertex cut is unchanged at +/-2cm.</a:t>
             </a:r>
             <a:endParaRPr lang="en-US" sz="1250" dirty="0"/>
           </a:p>

</xml_diff>

<commit_message>
Update all footer dates to July 15, 2026 to match title slide
</commit_message>
<xml_diff>
--- a/docs/OO200_Spectra_Status_Update.pptx
+++ b/docs/OO200_Spectra_Status_Update.pptx
@@ -1378,7 +1378,7 @@
                 <a:ea typeface="Arial" pitchFamily="34" charset="-122"/>
                 <a:cs typeface="Arial" pitchFamily="34" charset="-120"/>
               </a:rPr>
-              <a:t>Andrew Liggett  •  July 8, 2026</a:t>
+              <a:t>Andrew Liggett  •  July 15, 2026</a:t>
             </a:r>
             <a:endParaRPr lang="en-US" sz="1000" dirty="0"/>
           </a:p>
@@ -1677,7 +1677,7 @@
                 <a:ea typeface="Arial" pitchFamily="34" charset="-122"/>
                 <a:cs typeface="Arial" pitchFamily="34" charset="-120"/>
               </a:rPr>
-              <a:t>Andrew Liggett  •  July 8, 2026</a:t>
+              <a:t>Andrew Liggett  •  July 15, 2026</a:t>
             </a:r>
             <a:endParaRPr lang="en-US" sz="1000" dirty="0"/>
           </a:p>
@@ -1976,7 +1976,7 @@
                 <a:ea typeface="Arial" pitchFamily="34" charset="-122"/>
                 <a:cs typeface="Arial" pitchFamily="34" charset="-120"/>
               </a:rPr>
-              <a:t>Andrew Liggett  •  July 8, 2026</a:t>
+              <a:t>Andrew Liggett  •  July 15, 2026</a:t>
             </a:r>
             <a:endParaRPr lang="en-US" sz="1000" dirty="0"/>
           </a:p>
@@ -2275,7 +2275,7 @@
                 <a:ea typeface="Arial" pitchFamily="34" charset="-122"/>
                 <a:cs typeface="Arial" pitchFamily="34" charset="-120"/>
               </a:rPr>
-              <a:t>Andrew Liggett  •  July 8, 2026</a:t>
+              <a:t>Andrew Liggett  •  July 15, 2026</a:t>
             </a:r>
             <a:endParaRPr lang="en-US" sz="1000" dirty="0"/>
           </a:p>
@@ -2574,7 +2574,7 @@
                 <a:ea typeface="Arial" pitchFamily="34" charset="-122"/>
                 <a:cs typeface="Arial" pitchFamily="34" charset="-120"/>
               </a:rPr>
-              <a:t>Andrew Liggett  •  July 8, 2026</a:t>
+              <a:t>Andrew Liggett  •  July 15, 2026</a:t>
             </a:r>
             <a:endParaRPr lang="en-US" sz="1000" dirty="0"/>
           </a:p>
@@ -3278,7 +3278,7 @@
                 <a:ea typeface="Arial" pitchFamily="34" charset="-122"/>
                 <a:cs typeface="Arial" pitchFamily="34" charset="-120"/>
               </a:rPr>
-              <a:t>Andrew Liggett  •  July 14, 2026</a:t>
+              <a:t>Andrew Liggett  •  July 15, 2026</a:t>
             </a:r>
             <a:endParaRPr lang="en-US" sz="1000" dirty="0"/>
           </a:p>

</xml_diff>

<commit_message>
Repurpose slide 4 (was PID) into NHitsFit/NHitsMax/efficiency-vs-eta output preview
</commit_message>
<xml_diff>
--- a/docs/OO200_Spectra_Status_Update.pptx
+++ b/docs/OO200_Spectra_Status_Update.pptx
@@ -1189,7 +1189,7 @@
                 <a:ea typeface="Arial" pitchFamily="34" charset="-122"/>
                 <a:cs typeface="Arial" pitchFamily="34" charset="-120"/>
               </a:rPr>
-              <a:t>Particle ID: dE/dx &amp; Mass vs Momentum</a:t>
+              <a:t>NHitsFit, NHitsMax &amp; Efficiency vs Eta</a:t>
             </a:r>
             <a:endParaRPr lang="en-US" sz="2800" dirty="0"/>
           </a:p>
@@ -1197,7 +1197,7 @@
       </p:sp>
       <p:pic>
         <p:nvPicPr>
-          <p:cNvPr id="4" name="Plot: PresentPID" descr="macros/PresentPID.C output"/>
+          <p:cNvPr id="4" name="Plot: PresentNHitsEta" descr="macros/PresentNHitsEta.C output"/>
           <p:cNvPicPr>
             <a:picLocks noChangeAspect="1"/>
           </p:cNvPicPr>
@@ -1211,8 +1211,8 @@
         </p:blipFill>
         <p:spPr>
           <a:xfrm>
-            <a:off x="1478703" y="1210000"/>
-            <a:ext cx="6186593" cy="3279160"/>
+            <a:off x="1079088" y="1210000"/>
+            <a:ext cx="6985825" cy="3279160"/>
           </a:xfrm>
           <a:prstGeom prst="rect">
             <a:avLst/>
@@ -1252,7 +1252,7 @@
                 <a:ea typeface="Arial" pitchFamily="34" charset="-122"/>
                 <a:cs typeface="Arial" pitchFamily="34" charset="-120"/>
               </a:rPr>
-              <a:t>The classic PID plots -- dE/dx (TPC) and time-of-flight mass (BTOF) for pion, kaon, and proton tracks.</a:t>
+              <a:t>NHitsFit, NHitsMax, and their ratio vs eta -- isolates hit-finding efficiency loss from pure acceptance falloff.</a:t>
             </a:r>
             <a:endParaRPr lang="en-US" sz="1000" dirty="0"/>
           </a:p>

</xml_diff>

<commit_message>
Slide 5: swap in updated PresentAcceptance.png (2-panel, [-2,2] range)
</commit_message>
<xml_diff>
--- a/docs/OO200_Spectra_Status_Update.pptx
+++ b/docs/OO200_Spectra_Status_Update.pptx
@@ -1510,8 +1510,8 @@
         </p:blipFill>
         <p:spPr>
           <a:xfrm>
-            <a:off x="502920" y="1292444"/>
-            <a:ext cx="8138160" cy="2765112"/>
+            <a:off x="1667178" y="1292444"/>
+            <a:ext cx="5809645" cy="2765112"/>
           </a:xfrm>
           <a:prstGeom prst="rect">
             <a:avLst/>

</xml_diff>

<commit_message>
Replace last 2 slides (CalibrationQA, RawYield) with a single Next Steps slide: finalize cuts, begin ZFitter fits
</commit_message>
<xml_diff>
--- a/docs/OO200_Spectra_Status_Update.pptx
+++ b/docs/OO200_Spectra_Status_Update.pptx
@@ -10,8 +10,7 @@
     <p:sldId id="271" r:id="rId22"/>
     <p:sldId id="269" r:id="rId20"/>
     <p:sldId id="270" r:id="rId21"/>
-    <p:sldId id="272" r:id="rId23"/>
-    <p:sldId id="273" r:id="rId24"/>
+    <p:sldId id="275" r:id="rId26"/>
   </p:sldIdLst>
   <p:notesMasterIdLst>
     <p:notesMasterId r:id="rId14"/>
@@ -1990,604 +1989,6 @@
 </p:sld>
 </file>
 
-<file path=ppt/slides/slide17.xml><?xml version="1.0" encoding="utf-8"?>
-<p:sld xmlns:a="http://schemas.openxmlformats.org/drawingml/2006/main" xmlns:r="http://schemas.openxmlformats.org/officeDocument/2006/relationships" xmlns:p="http://schemas.openxmlformats.org/presentationml/2006/main">
-  <p:cSld name="Slide 17">
-    <p:bg>
-      <p:bgPr>
-        <a:solidFill>
-          <a:srgbClr val="FFFFFF"/>
-        </a:solidFill>
-      </p:bgPr>
-    </p:bg>
-    <p:spTree>
-      <p:nvGrpSpPr>
-        <p:cNvPr id="1" name=""/>
-        <p:cNvGrpSpPr/>
-        <p:nvPr/>
-      </p:nvGrpSpPr>
-      <p:grpSpPr>
-        <a:xfrm>
-          <a:off x="0" y="0"/>
-          <a:ext cx="0" cy="0"/>
-          <a:chOff x="0" y="0"/>
-          <a:chExt cx="0" cy="0"/>
-        </a:xfrm>
-      </p:grpSpPr>
-      <p:sp>
-        <p:nvSpPr>
-          <p:cNvPr id="2" name="Text 0"/>
-          <p:cNvSpPr/>
-          <p:nvPr/>
-        </p:nvSpPr>
-        <p:spPr>
-          <a:xfrm>
-            <a:off x="457200" y="320040"/>
-            <a:ext cx="8229600" cy="274320"/>
-          </a:xfrm>
-          <a:prstGeom prst="rect">
-            <a:avLst/>
-          </a:prstGeom>
-          <a:noFill/>
-          <a:ln/>
-        </p:spPr>
-        <p:txBody>
-          <a:bodyPr wrap="square" lIns="0" tIns="0" rIns="0" bIns="0" rtlCol="0" anchor="ctr"/>
-          <a:lstStyle/>
-          <a:p>
-            <a:pPr indent="0" marL="0">
-              <a:buNone/>
-            </a:pPr>
-            <a:r>
-              <a:rPr lang="en-US" sz="1200" b="1" spc="200" kern="0" dirty="0">
-                <a:solidFill>
-                  <a:srgbClr val="5B6382"/>
-                </a:solidFill>
-                <a:latin typeface="Arial" pitchFamily="34" charset="0"/>
-                <a:ea typeface="Arial" pitchFamily="34" charset="-122"/>
-                <a:cs typeface="Arial" pitchFamily="34" charset="-120"/>
-              </a:rPr>
-              <a:t>OUTPUT PREVIEW</a:t>
-            </a:r>
-            <a:endParaRPr lang="en-US" sz="1200" dirty="0"/>
-          </a:p>
-        </p:txBody>
-      </p:sp>
-      <p:sp>
-        <p:nvSpPr>
-          <p:cNvPr id="3" name="Text 1"/>
-          <p:cNvSpPr/>
-          <p:nvPr/>
-        </p:nvSpPr>
-        <p:spPr>
-          <a:xfrm>
-            <a:off x="457200" y="566928"/>
-            <a:ext cx="8229600" cy="640080"/>
-          </a:xfrm>
-          <a:prstGeom prst="rect">
-            <a:avLst/>
-          </a:prstGeom>
-          <a:noFill/>
-          <a:ln/>
-        </p:spPr>
-        <p:txBody>
-          <a:bodyPr wrap="square" lIns="0" tIns="0" rIns="0" bIns="0" rtlCol="0" anchor="ctr"/>
-          <a:lstStyle/>
-          <a:p>
-            <a:pPr indent="0" marL="0">
-              <a:buNone/>
-            </a:pPr>
-            <a:r>
-              <a:rPr lang="en-US" sz="2800" b="1" dirty="0">
-                <a:solidFill>
-                  <a:srgbClr val="1E2761"/>
-                </a:solidFill>
-                <a:latin typeface="Arial" pitchFamily="34" charset="0"/>
-                <a:ea typeface="Arial" pitchFamily="34" charset="-122"/>
-                <a:cs typeface="Arial" pitchFamily="34" charset="-120"/>
-              </a:rPr>
-              <a:t>Calibration QA: dE/dx vs Bichsel Prediction</a:t>
-            </a:r>
-            <a:endParaRPr lang="en-US" sz="2800" dirty="0"/>
-          </a:p>
-        </p:txBody>
-      </p:sp>
-      <p:pic>
-        <p:nvPicPr>
-          <p:cNvPr id="4" name="Plot: PresentCalibrationQA" descr="macros/PresentCalibrationQA.C output"/>
-          <p:cNvPicPr>
-            <a:picLocks noChangeAspect="1"/>
-          </p:cNvPicPr>
-          <p:nvPr/>
-        </p:nvPicPr>
-        <p:blipFill>
-          <a:blip r:embed="rId4"/>
-          <a:stretch>
-            <a:fillRect/>
-          </a:stretch>
-        </p:blipFill>
-        <p:spPr>
-          <a:xfrm>
-            <a:off x="1107391" y="1250000"/>
-            <a:ext cx="6929217" cy="2850000"/>
-          </a:xfrm>
-          <a:prstGeom prst="rect">
-            <a:avLst/>
-          </a:prstGeom>
-        </p:spPr>
-      </p:pic>
-      <p:sp>
-        <p:nvSpPr>
-          <p:cNvPr id="6" name="Text 3"/>
-          <p:cNvSpPr/>
-          <p:nvPr/>
-        </p:nvSpPr>
-        <p:spPr>
-          <a:xfrm>
-            <a:off x="502920" y="4130000"/>
-            <a:ext cx="8138160" cy="450000"/>
-          </a:xfrm>
-          <a:prstGeom prst="rect">
-            <a:avLst/>
-          </a:prstGeom>
-          <a:noFill/>
-          <a:ln/>
-        </p:spPr>
-        <p:txBody>
-          <a:bodyPr wrap="square" lIns="0" tIns="0" rIns="0" bIns="0" rtlCol="0" anchor="t"/>
-          <a:lstStyle/>
-          <a:p>
-            <a:pPr indent="0" marL="0">
-              <a:buNone/>
-            </a:pPr>
-            <a:r>
-              <a:rPr lang="en-US" sz="1300" dirty="0">
-                <a:solidFill>
-                  <a:srgbClr val="20233B"/>
-                </a:solidFill>
-                <a:latin typeface="Arial" pitchFamily="34" charset="0"/>
-                <a:ea typeface="Arial" pitchFamily="34" charset="-122"/>
-                <a:cs typeface="Arial" pitchFamily="34" charset="-120"/>
-              </a:rPr>
-              <a:t>Checks that the Bichsel-curve dE/dx prediction lines up with the data at each Vz calibration slice.</a:t>
-            </a:r>
-            <a:endParaRPr lang="en-US" sz="1300" dirty="0"/>
-          </a:p>
-        </p:txBody>
-      </p:sp>
-      <p:pic>
-        <p:nvPicPr>
-          <p:cNvPr id="7" name="Image 0" descr="assets/ucdavis_seal.png"/>
-          <p:cNvPicPr>
-            <a:picLocks noChangeAspect="1"/>
-          </p:cNvPicPr>
-          <p:nvPr/>
-        </p:nvPicPr>
-        <p:blipFill>
-          <a:blip r:embed="rId1"/>
-          <a:stretch>
-            <a:fillRect/>
-          </a:stretch>
-        </p:blipFill>
-        <p:spPr>
-          <a:xfrm>
-            <a:off x="457200" y="4709160"/>
-            <a:ext cx="274320" cy="282092"/>
-          </a:xfrm>
-          <a:prstGeom prst="rect">
-            <a:avLst/>
-          </a:prstGeom>
-        </p:spPr>
-      </p:pic>
-      <p:pic>
-        <p:nvPicPr>
-          <p:cNvPr id="8" name="Image 1" descr="assets/star_logo.png"/>
-          <p:cNvPicPr>
-            <a:picLocks noChangeAspect="1"/>
-          </p:cNvPicPr>
-          <p:nvPr/>
-        </p:nvPicPr>
-        <p:blipFill>
-          <a:blip r:embed="rId2"/>
-          <a:stretch>
-            <a:fillRect/>
-          </a:stretch>
-        </p:blipFill>
-        <p:spPr>
-          <a:xfrm>
-            <a:off x="8092440" y="4709160"/>
-            <a:ext cx="379365" cy="292608"/>
-          </a:xfrm>
-          <a:prstGeom prst="rect">
-            <a:avLst/>
-          </a:prstGeom>
-        </p:spPr>
-      </p:pic>
-      <p:sp>
-        <p:nvSpPr>
-          <p:cNvPr id="9" name="Text 4"/>
-          <p:cNvSpPr/>
-          <p:nvPr/>
-        </p:nvSpPr>
-        <p:spPr>
-          <a:xfrm>
-            <a:off x="8549640" y="4828032"/>
-            <a:ext cx="457200" cy="274320"/>
-          </a:xfrm>
-          <a:prstGeom prst="rect">
-            <a:avLst/>
-          </a:prstGeom>
-          <a:noFill/>
-          <a:ln/>
-        </p:spPr>
-        <p:txBody>
-          <a:bodyPr wrap="square" lIns="0" tIns="0" rIns="0" bIns="0" rtlCol="0" anchor="ctr"/>
-          <a:lstStyle/>
-          <a:p>
-            <a:pPr algn="r" indent="0" marL="0">
-              <a:buNone/>
-            </a:pPr>
-            <a:r>
-              <a:rPr lang="en-US" sz="1000" dirty="0">
-                <a:solidFill>
-                  <a:srgbClr val="5B6382"/>
-                </a:solidFill>
-                <a:latin typeface="Arial" pitchFamily="34" charset="0"/>
-                <a:ea typeface="Arial" pitchFamily="34" charset="-122"/>
-                <a:cs typeface="Arial" pitchFamily="34" charset="-120"/>
-              </a:rPr>
-              <a:t>6</a:t>
-            </a:r>
-            <a:endParaRPr lang="en-US" sz="1000" dirty="0"/>
-          </a:p>
-        </p:txBody>
-      </p:sp>
-      <p:sp>
-        <p:nvSpPr>
-          <p:cNvPr id="10" name="Text 5"/>
-          <p:cNvSpPr/>
-          <p:nvPr/>
-        </p:nvSpPr>
-        <p:spPr>
-          <a:xfrm>
-            <a:off x="841248" y="4828032"/>
-            <a:ext cx="6766560" cy="274320"/>
-          </a:xfrm>
-          <a:prstGeom prst="rect">
-            <a:avLst/>
-          </a:prstGeom>
-          <a:noFill/>
-          <a:ln/>
-        </p:spPr>
-        <p:txBody>
-          <a:bodyPr wrap="square" lIns="0" tIns="0" rIns="0" bIns="0" rtlCol="0" anchor="ctr"/>
-          <a:lstStyle/>
-          <a:p>
-            <a:pPr algn="l" indent="0" marL="0">
-              <a:buNone/>
-            </a:pPr>
-            <a:r>
-              <a:rPr lang="en-US" sz="1000" dirty="0">
-                <a:solidFill>
-                  <a:srgbClr val="5B6382"/>
-                </a:solidFill>
-                <a:latin typeface="Arial" pitchFamily="34" charset="0"/>
-                <a:ea typeface="Arial" pitchFamily="34" charset="-122"/>
-                <a:cs typeface="Arial" pitchFamily="34" charset="-120"/>
-              </a:rPr>
-              <a:t>Andrew Liggett  •  July 15, 2026</a:t>
-            </a:r>
-            <a:endParaRPr lang="en-US" sz="1000" dirty="0"/>
-          </a:p>
-        </p:txBody>
-      </p:sp>
-    </p:spTree>
-  </p:cSld>
-  <p:clrMapOvr>
-    <a:masterClrMapping/>
-  </p:clrMapOvr>
-</p:sld>
-</file>
-
-<file path=ppt/slides/slide18.xml><?xml version="1.0" encoding="utf-8"?>
-<p:sld xmlns:a="http://schemas.openxmlformats.org/drawingml/2006/main" xmlns:r="http://schemas.openxmlformats.org/officeDocument/2006/relationships" xmlns:p="http://schemas.openxmlformats.org/presentationml/2006/main">
-  <p:cSld name="Slide 18">
-    <p:bg>
-      <p:bgPr>
-        <a:solidFill>
-          <a:srgbClr val="FFFFFF"/>
-        </a:solidFill>
-      </p:bgPr>
-    </p:bg>
-    <p:spTree>
-      <p:nvGrpSpPr>
-        <p:cNvPr id="1" name=""/>
-        <p:cNvGrpSpPr/>
-        <p:nvPr/>
-      </p:nvGrpSpPr>
-      <p:grpSpPr>
-        <a:xfrm>
-          <a:off x="0" y="0"/>
-          <a:ext cx="0" cy="0"/>
-          <a:chOff x="0" y="0"/>
-          <a:chExt cx="0" cy="0"/>
-        </a:xfrm>
-      </p:grpSpPr>
-      <p:sp>
-        <p:nvSpPr>
-          <p:cNvPr id="2" name="Text 0"/>
-          <p:cNvSpPr/>
-          <p:nvPr/>
-        </p:nvSpPr>
-        <p:spPr>
-          <a:xfrm>
-            <a:off x="457200" y="320040"/>
-            <a:ext cx="8229600" cy="274320"/>
-          </a:xfrm>
-          <a:prstGeom prst="rect">
-            <a:avLst/>
-          </a:prstGeom>
-          <a:noFill/>
-          <a:ln/>
-        </p:spPr>
-        <p:txBody>
-          <a:bodyPr wrap="square" lIns="0" tIns="0" rIns="0" bIns="0" rtlCol="0" anchor="ctr"/>
-          <a:lstStyle/>
-          <a:p>
-            <a:pPr indent="0" marL="0">
-              <a:buNone/>
-            </a:pPr>
-            <a:r>
-              <a:rPr lang="en-US" sz="1200" b="1" spc="200" kern="0" dirty="0">
-                <a:solidFill>
-                  <a:srgbClr val="5B6382"/>
-                </a:solidFill>
-                <a:latin typeface="Arial" pitchFamily="34" charset="0"/>
-                <a:ea typeface="Arial" pitchFamily="34" charset="-122"/>
-                <a:cs typeface="Arial" pitchFamily="34" charset="-120"/>
-              </a:rPr>
-              <a:t>OUTPUT PREVIEW</a:t>
-            </a:r>
-            <a:endParaRPr lang="en-US" sz="1200" dirty="0"/>
-          </a:p>
-        </p:txBody>
-      </p:sp>
-      <p:sp>
-        <p:nvSpPr>
-          <p:cNvPr id="3" name="Text 1"/>
-          <p:cNvSpPr/>
-          <p:nvPr/>
-        </p:nvSpPr>
-        <p:spPr>
-          <a:xfrm>
-            <a:off x="457200" y="566928"/>
-            <a:ext cx="8229600" cy="640080"/>
-          </a:xfrm>
-          <a:prstGeom prst="rect">
-            <a:avLst/>
-          </a:prstGeom>
-          <a:noFill/>
-          <a:ln/>
-        </p:spPr>
-        <p:txBody>
-          <a:bodyPr wrap="square" lIns="0" tIns="0" rIns="0" bIns="0" rtlCol="0" anchor="ctr"/>
-          <a:lstStyle/>
-          <a:p>
-            <a:pPr indent="0" marL="0">
-              <a:buNone/>
-            </a:pPr>
-            <a:r>
-              <a:rPr lang="en-US" sz="2800" b="1" dirty="0">
-                <a:solidFill>
-                  <a:srgbClr val="1E2761"/>
-                </a:solidFill>
-                <a:latin typeface="Arial" pitchFamily="34" charset="0"/>
-                <a:ea typeface="Arial" pitchFamily="34" charset="-122"/>
-                <a:cs typeface="Arial" pitchFamily="34" charset="-120"/>
-              </a:rPr>
-              <a:t>Raw Yield: y vs mT-m0 (Pre-Fit)</a:t>
-            </a:r>
-            <a:endParaRPr lang="en-US" sz="2800" dirty="0"/>
-          </a:p>
-        </p:txBody>
-      </p:sp>
-      <p:pic>
-        <p:nvPicPr>
-          <p:cNvPr id="4" name="Plot: PresentPhysicsOutput" descr="macros/PresentPhysicsOutput.C output"/>
-          <p:cNvPicPr>
-            <a:picLocks noChangeAspect="1"/>
-          </p:cNvPicPr>
-          <p:nvPr/>
-        </p:nvPicPr>
-        <p:blipFill>
-          <a:blip r:embed="rId4"/>
-          <a:stretch>
-            <a:fillRect/>
-          </a:stretch>
-        </p:blipFill>
-        <p:spPr>
-          <a:xfrm>
-            <a:off x="1107391" y="1250000"/>
-            <a:ext cx="6929217" cy="2850000"/>
-          </a:xfrm>
-          <a:prstGeom prst="rect">
-            <a:avLst/>
-          </a:prstGeom>
-        </p:spPr>
-      </p:pic>
-      <p:sp>
-        <p:nvSpPr>
-          <p:cNvPr id="6" name="Text 3"/>
-          <p:cNvSpPr/>
-          <p:nvPr/>
-        </p:nvSpPr>
-        <p:spPr>
-          <a:xfrm>
-            <a:off x="502920" y="4130000"/>
-            <a:ext cx="8138160" cy="450000"/>
-          </a:xfrm>
-          <a:prstGeom prst="rect">
-            <a:avLst/>
-          </a:prstGeom>
-          <a:noFill/>
-          <a:ln/>
-        </p:spPr>
-        <p:txBody>
-          <a:bodyPr wrap="square" lIns="0" tIns="0" rIns="0" bIns="0" rtlCol="0" anchor="t"/>
-          <a:lstStyle/>
-          <a:p>
-            <a:pPr indent="0" marL="0">
-              <a:buNone/>
-            </a:pPr>
-            <a:r>
-              <a:rPr lang="en-US" sz="1300" dirty="0">
-                <a:solidFill>
-                  <a:srgbClr val="20233B"/>
-                </a:solidFill>
-                <a:latin typeface="Arial" pitchFamily="34" charset="0"/>
-                <a:ea typeface="Arial" pitchFamily="34" charset="-122"/>
-                <a:cs typeface="Arial" pitchFamily="34" charset="-120"/>
-              </a:rPr>
-              <a:t>The raw input ZFitter fits bin-by-bin -- not a result yet, just the starting point for the spectra.</a:t>
-            </a:r>
-            <a:endParaRPr lang="en-US" sz="1300" dirty="0"/>
-          </a:p>
-        </p:txBody>
-      </p:sp>
-      <p:pic>
-        <p:nvPicPr>
-          <p:cNvPr id="7" name="Image 0" descr="assets/ucdavis_seal.png"/>
-          <p:cNvPicPr>
-            <a:picLocks noChangeAspect="1"/>
-          </p:cNvPicPr>
-          <p:nvPr/>
-        </p:nvPicPr>
-        <p:blipFill>
-          <a:blip r:embed="rId1"/>
-          <a:stretch>
-            <a:fillRect/>
-          </a:stretch>
-        </p:blipFill>
-        <p:spPr>
-          <a:xfrm>
-            <a:off x="457200" y="4709160"/>
-            <a:ext cx="274320" cy="282092"/>
-          </a:xfrm>
-          <a:prstGeom prst="rect">
-            <a:avLst/>
-          </a:prstGeom>
-        </p:spPr>
-      </p:pic>
-      <p:pic>
-        <p:nvPicPr>
-          <p:cNvPr id="8" name="Image 1" descr="assets/star_logo.png"/>
-          <p:cNvPicPr>
-            <a:picLocks noChangeAspect="1"/>
-          </p:cNvPicPr>
-          <p:nvPr/>
-        </p:nvPicPr>
-        <p:blipFill>
-          <a:blip r:embed="rId2"/>
-          <a:stretch>
-            <a:fillRect/>
-          </a:stretch>
-        </p:blipFill>
-        <p:spPr>
-          <a:xfrm>
-            <a:off x="8092440" y="4709160"/>
-            <a:ext cx="379365" cy="292608"/>
-          </a:xfrm>
-          <a:prstGeom prst="rect">
-            <a:avLst/>
-          </a:prstGeom>
-        </p:spPr>
-      </p:pic>
-      <p:sp>
-        <p:nvSpPr>
-          <p:cNvPr id="9" name="Text 4"/>
-          <p:cNvSpPr/>
-          <p:nvPr/>
-        </p:nvSpPr>
-        <p:spPr>
-          <a:xfrm>
-            <a:off x="8549640" y="4828032"/>
-            <a:ext cx="457200" cy="274320"/>
-          </a:xfrm>
-          <a:prstGeom prst="rect">
-            <a:avLst/>
-          </a:prstGeom>
-          <a:noFill/>
-          <a:ln/>
-        </p:spPr>
-        <p:txBody>
-          <a:bodyPr wrap="square" lIns="0" tIns="0" rIns="0" bIns="0" rtlCol="0" anchor="ctr"/>
-          <a:lstStyle/>
-          <a:p>
-            <a:pPr algn="r" indent="0" marL="0">
-              <a:buNone/>
-            </a:pPr>
-            <a:r>
-              <a:rPr lang="en-US" sz="1000" dirty="0">
-                <a:solidFill>
-                  <a:srgbClr val="5B6382"/>
-                </a:solidFill>
-                <a:latin typeface="Arial" pitchFamily="34" charset="0"/>
-                <a:ea typeface="Arial" pitchFamily="34" charset="-122"/>
-                <a:cs typeface="Arial" pitchFamily="34" charset="-120"/>
-              </a:rPr>
-              <a:t>7</a:t>
-            </a:r>
-            <a:endParaRPr lang="en-US" sz="1000" dirty="0"/>
-          </a:p>
-        </p:txBody>
-      </p:sp>
-      <p:sp>
-        <p:nvSpPr>
-          <p:cNvPr id="10" name="Text 5"/>
-          <p:cNvSpPr/>
-          <p:nvPr/>
-        </p:nvSpPr>
-        <p:spPr>
-          <a:xfrm>
-            <a:off x="841248" y="4828032"/>
-            <a:ext cx="6766560" cy="274320"/>
-          </a:xfrm>
-          <a:prstGeom prst="rect">
-            <a:avLst/>
-          </a:prstGeom>
-          <a:noFill/>
-          <a:ln/>
-        </p:spPr>
-        <p:txBody>
-          <a:bodyPr wrap="square" lIns="0" tIns="0" rIns="0" bIns="0" rtlCol="0" anchor="ctr"/>
-          <a:lstStyle/>
-          <a:p>
-            <a:pPr algn="l" indent="0" marL="0">
-              <a:buNone/>
-            </a:pPr>
-            <a:r>
-              <a:rPr lang="en-US" sz="1000" dirty="0">
-                <a:solidFill>
-                  <a:srgbClr val="5B6382"/>
-                </a:solidFill>
-                <a:latin typeface="Arial" pitchFamily="34" charset="0"/>
-                <a:ea typeface="Arial" pitchFamily="34" charset="-122"/>
-                <a:cs typeface="Arial" pitchFamily="34" charset="-120"/>
-              </a:rPr>
-              <a:t>Andrew Liggett  •  July 15, 2026</a:t>
-            </a:r>
-            <a:endParaRPr lang="en-US" sz="1000" dirty="0"/>
-          </a:p>
-        </p:txBody>
-      </p:sp>
-    </p:spTree>
-  </p:cSld>
-  <p:clrMapOvr>
-    <a:masterClrMapping/>
-  </p:clrMapOvr>
-</p:sld>
-</file>
-
 <file path=ppt/slides/slide23.xml><?xml version="1.0" encoding="utf-8"?>
 <p:sld xmlns:a="http://schemas.openxmlformats.org/drawingml/2006/main" xmlns:r="http://schemas.openxmlformats.org/officeDocument/2006/relationships" xmlns:p="http://schemas.openxmlformats.org/presentationml/2006/main">
   <p:cSld name="Slide 23">
@@ -3240,6 +2641,710 @@
                 <a:cs typeface="Arial" pitchFamily="34" charset="-120"/>
               </a:rPr>
               <a:t>2</a:t>
+            </a:r>
+            <a:endParaRPr lang="en-US" sz="1000" dirty="0"/>
+          </a:p>
+        </p:txBody>
+      </p:sp>
+      <p:sp>
+        <p:nvSpPr>
+          <p:cNvPr id="22" name="Text 18"/>
+          <p:cNvSpPr/>
+          <p:nvPr/>
+        </p:nvSpPr>
+        <p:spPr>
+          <a:xfrm>
+            <a:off x="841248" y="4828032"/>
+            <a:ext cx="6766560" cy="274320"/>
+          </a:xfrm>
+          <a:prstGeom prst="rect">
+            <a:avLst/>
+          </a:prstGeom>
+          <a:noFill/>
+          <a:ln/>
+        </p:spPr>
+        <p:txBody>
+          <a:bodyPr wrap="square" lIns="0" tIns="0" rIns="0" bIns="0" rtlCol="0" anchor="ctr"/>
+          <a:lstStyle/>
+          <a:p>
+            <a:pPr algn="l" indent="0" marL="0">
+              <a:buNone/>
+            </a:pPr>
+            <a:r>
+              <a:rPr lang="en-US" sz="1000" dirty="0">
+                <a:solidFill>
+                  <a:srgbClr val="5B6382"/>
+                </a:solidFill>
+                <a:latin typeface="Arial" pitchFamily="34" charset="0"/>
+                <a:ea typeface="Arial" pitchFamily="34" charset="-122"/>
+                <a:cs typeface="Arial" pitchFamily="34" charset="-120"/>
+              </a:rPr>
+              <a:t>Andrew Liggett  •  July 15, 2026</a:t>
+            </a:r>
+            <a:endParaRPr lang="en-US" sz="1000" dirty="0"/>
+          </a:p>
+        </p:txBody>
+      </p:sp>
+    </p:spTree>
+  </p:cSld>
+  <p:clrMapOvr>
+    <a:masterClrMapping/>
+  </p:clrMapOvr>
+</p:sld>
+</file>
+
+<file path=ppt/slides/slide24.xml><?xml version="1.0" encoding="utf-8"?>
+<p:sld xmlns:a="http://schemas.openxmlformats.org/drawingml/2006/main" xmlns:r="http://schemas.openxmlformats.org/officeDocument/2006/relationships" xmlns:p="http://schemas.openxmlformats.org/presentationml/2006/main">
+  <p:cSld name="Slide 24">
+    <p:bg>
+      <p:bgPr>
+        <a:solidFill>
+          <a:srgbClr val="FFFFFF"/>
+        </a:solidFill>
+      </p:bgPr>
+    </p:bg>
+    <p:spTree>
+      <p:nvGrpSpPr>
+        <p:cNvPr id="1" name=""/>
+        <p:cNvGrpSpPr/>
+        <p:nvPr/>
+      </p:nvGrpSpPr>
+      <p:grpSpPr>
+        <a:xfrm>
+          <a:off x="0" y="0"/>
+          <a:ext cx="0" cy="0"/>
+          <a:chOff x="0" y="0"/>
+          <a:chExt cx="0" cy="0"/>
+        </a:xfrm>
+      </p:grpSpPr>
+      <p:sp>
+        <p:nvSpPr>
+          <p:cNvPr id="2" name="Text 0"/>
+          <p:cNvSpPr/>
+          <p:nvPr/>
+        </p:nvSpPr>
+        <p:spPr>
+          <a:xfrm>
+            <a:off x="457200" y="320040"/>
+            <a:ext cx="8229600" cy="274320"/>
+          </a:xfrm>
+          <a:prstGeom prst="rect">
+            <a:avLst/>
+          </a:prstGeom>
+          <a:noFill/>
+          <a:ln/>
+        </p:spPr>
+        <p:txBody>
+          <a:bodyPr wrap="square" lIns="0" tIns="0" rIns="0" bIns="0" rtlCol="0" anchor="ctr"/>
+          <a:lstStyle/>
+          <a:p>
+            <a:pPr indent="0" marL="0">
+              <a:buNone/>
+            </a:pPr>
+            <a:r>
+              <a:rPr lang="en-US" sz="1200" b="1" spc="200" kern="0" dirty="0">
+                <a:solidFill>
+                  <a:srgbClr val="5B6382"/>
+                </a:solidFill>
+                <a:latin typeface="Arial" pitchFamily="34" charset="0"/>
+                <a:ea typeface="Arial" pitchFamily="34" charset="-122"/>
+                <a:cs typeface="Arial" pitchFamily="34" charset="-120"/>
+              </a:rPr>
+              <a:t>NEXT STEPS</a:t>
+            </a:r>
+            <a:endParaRPr lang="en-US" sz="1200" dirty="0"/>
+          </a:p>
+        </p:txBody>
+      </p:sp>
+      <p:sp>
+        <p:nvSpPr>
+          <p:cNvPr id="3" name="Text 1"/>
+          <p:cNvSpPr/>
+          <p:nvPr/>
+        </p:nvSpPr>
+        <p:spPr>
+          <a:xfrm>
+            <a:off x="457200" y="566928"/>
+            <a:ext cx="8229600" cy="640080"/>
+          </a:xfrm>
+          <a:prstGeom prst="rect">
+            <a:avLst/>
+          </a:prstGeom>
+          <a:noFill/>
+          <a:ln/>
+        </p:spPr>
+        <p:txBody>
+          <a:bodyPr wrap="square" lIns="0" tIns="0" rIns="0" bIns="0" rtlCol="0" anchor="ctr"/>
+          <a:lstStyle/>
+          <a:p>
+            <a:pPr indent="0" marL="0">
+              <a:buNone/>
+            </a:pPr>
+            <a:r>
+              <a:rPr lang="en-US" sz="3000" b="1" dirty="0">
+                <a:solidFill>
+                  <a:srgbClr val="1E2761"/>
+                </a:solidFill>
+                <a:latin typeface="Arial" pitchFamily="34" charset="0"/>
+                <a:ea typeface="Arial" pitchFamily="34" charset="-122"/>
+                <a:cs typeface="Arial" pitchFamily="34" charset="-120"/>
+              </a:rPr>
+              <a:t>Finalizing Cuts &amp; Moving to ZFitter</a:t>
+            </a:r>
+            <a:endParaRPr lang="en-US" sz="3000" dirty="0"/>
+          </a:p>
+        </p:txBody>
+      </p:sp>
+      <p:sp>
+        <p:nvSpPr>
+          <p:cNvPr id="4" name="Text 2"/>
+          <p:cNvSpPr/>
+          <p:nvPr/>
+        </p:nvSpPr>
+        <p:spPr>
+          <a:xfrm>
+            <a:off x="502920" y="1557008"/>
+            <a:ext cx="365760" cy="370840"/>
+          </a:xfrm>
+          <a:prstGeom prst="rect">
+            <a:avLst/>
+          </a:prstGeom>
+          <a:noFill/>
+          <a:ln/>
+        </p:spPr>
+        <p:txBody>
+          <a:bodyPr wrap="square" lIns="0" tIns="0" rIns="0" bIns="0" rtlCol="0" anchor="ctr"/>
+          <a:lstStyle/>
+          <a:p>
+            <a:pPr indent="0" marL="0">
+              <a:buNone/>
+            </a:pPr>
+            <a:r>
+              <a:rPr lang="en-US" sz="1700" b="1" dirty="0">
+                <a:solidFill>
+                  <a:srgbClr val="1E2761"/>
+                </a:solidFill>
+                <a:latin typeface="Arial" pitchFamily="34" charset="0"/>
+                <a:ea typeface="Arial" pitchFamily="34" charset="-122"/>
+                <a:cs typeface="Arial" pitchFamily="34" charset="-120"/>
+              </a:rPr>
+              <a:t>1.</a:t>
+            </a:r>
+            <a:endParaRPr lang="en-US" sz="1700" dirty="0"/>
+          </a:p>
+        </p:txBody>
+      </p:sp>
+      <p:sp>
+        <p:nvSpPr>
+          <p:cNvPr id="5" name="Text 3"/>
+          <p:cNvSpPr/>
+          <p:nvPr/>
+        </p:nvSpPr>
+        <p:spPr>
+          <a:xfrm>
+            <a:off x="886968" y="1557008"/>
+            <a:ext cx="3593592" cy="370840"/>
+          </a:xfrm>
+          <a:prstGeom prst="rect">
+            <a:avLst/>
+          </a:prstGeom>
+          <a:noFill/>
+          <a:ln/>
+        </p:spPr>
+        <p:txBody>
+          <a:bodyPr wrap="square" lIns="0" tIns="0" rIns="0" bIns="0" rtlCol="0" anchor="ctr"/>
+          <a:lstStyle/>
+          <a:p>
+            <a:pPr indent="0" marL="0">
+              <a:buNone/>
+            </a:pPr>
+            <a:r>
+              <a:rPr lang="en-US" sz="1550" b="1" dirty="0">
+                <a:solidFill>
+                  <a:srgbClr val="1E2761"/>
+                </a:solidFill>
+                <a:latin typeface="Arial" pitchFamily="34" charset="0"/>
+                <a:ea typeface="Arial" pitchFamily="34" charset="-122"/>
+                <a:cs typeface="Arial" pitchFamily="34" charset="-120"/>
+              </a:rPr>
+              <a:t>Finalize track &amp; event cuts</a:t>
+            </a:r>
+            <a:endParaRPr lang="en-US" sz="1550" dirty="0"/>
+          </a:p>
+        </p:txBody>
+      </p:sp>
+      <p:sp>
+        <p:nvSpPr>
+          <p:cNvPr id="6" name="Text 4"/>
+          <p:cNvSpPr/>
+          <p:nvPr/>
+        </p:nvSpPr>
+        <p:spPr>
+          <a:xfrm>
+            <a:off x="886968" y="1927848"/>
+            <a:ext cx="3593592" cy="740000"/>
+          </a:xfrm>
+          <a:prstGeom prst="rect">
+            <a:avLst/>
+          </a:prstGeom>
+          <a:noFill/>
+          <a:ln/>
+        </p:spPr>
+        <p:txBody>
+          <a:bodyPr wrap="square" lIns="0" tIns="0" rIns="0" bIns="0" rtlCol="0" anchor="t"/>
+          <a:lstStyle/>
+          <a:p>
+            <a:pPr indent="0" marL="0">
+              <a:buNone/>
+            </a:pPr>
+            <a:r>
+              <a:rPr lang="en-US" sz="1250" dirty="0">
+                <a:solidFill>
+                  <a:srgbClr val="5B6382"/>
+                </a:solidFill>
+                <a:latin typeface="Arial" pitchFamily="34" charset="0"/>
+                <a:ea typeface="Arial" pitchFamily="34" charset="-122"/>
+                <a:cs typeface="Arial" pitchFamily="34" charset="-120"/>
+              </a:rPr>
+              <a:t>Lock in the current NHitsFit, fitMaxRatio, DCA, and radial vertex cuts as final for this analysis.</a:t>
+            </a:r>
+            <a:endParaRPr lang="en-US" sz="1250" dirty="0"/>
+          </a:p>
+        </p:txBody>
+      </p:sp>
+      <p:sp>
+        <p:nvSpPr>
+          <p:cNvPr id="7" name="Text 5"/>
+          <p:cNvSpPr/>
+          <p:nvPr/>
+        </p:nvSpPr>
+        <p:spPr>
+          <a:xfrm>
+            <a:off x="4754880" y="1557008"/>
+            <a:ext cx="365760" cy="370840"/>
+          </a:xfrm>
+          <a:prstGeom prst="rect">
+            <a:avLst/>
+          </a:prstGeom>
+          <a:noFill/>
+          <a:ln/>
+        </p:spPr>
+        <p:txBody>
+          <a:bodyPr wrap="square" lIns="0" tIns="0" rIns="0" bIns="0" rtlCol="0" anchor="ctr"/>
+          <a:lstStyle/>
+          <a:p>
+            <a:pPr indent="0" marL="0">
+              <a:buNone/>
+            </a:pPr>
+            <a:r>
+              <a:rPr lang="en-US" sz="1700" b="1" dirty="0">
+                <a:solidFill>
+                  <a:srgbClr val="1E2761"/>
+                </a:solidFill>
+                <a:latin typeface="Arial" pitchFamily="34" charset="0"/>
+                <a:ea typeface="Arial" pitchFamily="34" charset="-122"/>
+                <a:cs typeface="Arial" pitchFamily="34" charset="-120"/>
+              </a:rPr>
+              <a:t>2.</a:t>
+            </a:r>
+            <a:endParaRPr lang="en-US" sz="1700" dirty="0"/>
+          </a:p>
+        </p:txBody>
+      </p:sp>
+      <p:sp>
+        <p:nvSpPr>
+          <p:cNvPr id="8" name="Text 6"/>
+          <p:cNvSpPr/>
+          <p:nvPr/>
+        </p:nvSpPr>
+        <p:spPr>
+          <a:xfrm>
+            <a:off x="5138928" y="1557008"/>
+            <a:ext cx="3593592" cy="370840"/>
+          </a:xfrm>
+          <a:prstGeom prst="rect">
+            <a:avLst/>
+          </a:prstGeom>
+          <a:noFill/>
+          <a:ln/>
+        </p:spPr>
+        <p:txBody>
+          <a:bodyPr wrap="square" lIns="0" tIns="0" rIns="0" bIns="0" rtlCol="0" anchor="ctr"/>
+          <a:lstStyle/>
+          <a:p>
+            <a:pPr indent="0" marL="0">
+              <a:buNone/>
+            </a:pPr>
+            <a:r>
+              <a:rPr lang="en-US" sz="1550" b="1" dirty="0">
+                <a:solidFill>
+                  <a:srgbClr val="1E2761"/>
+                </a:solidFill>
+                <a:latin typeface="Arial" pitchFamily="34" charset="0"/>
+                <a:ea typeface="Arial" pitchFamily="34" charset="-122"/>
+                <a:cs typeface="Arial" pitchFamily="34" charset="-120"/>
+              </a:rPr>
+              <a:t>Begin ZFitter spectra fits</a:t>
+            </a:r>
+            <a:endParaRPr lang="en-US" sz="1550" dirty="0"/>
+          </a:p>
+        </p:txBody>
+      </p:sp>
+      <p:sp>
+        <p:nvSpPr>
+          <p:cNvPr id="9" name="Text 7"/>
+          <p:cNvSpPr/>
+          <p:nvPr/>
+        </p:nvSpPr>
+        <p:spPr>
+          <a:xfrm>
+            <a:off x="5138928" y="1927848"/>
+            <a:ext cx="3593592" cy="740000"/>
+          </a:xfrm>
+          <a:prstGeom prst="rect">
+            <a:avLst/>
+          </a:prstGeom>
+          <a:noFill/>
+          <a:ln/>
+        </p:spPr>
+        <p:txBody>
+          <a:bodyPr wrap="square" lIns="0" tIns="0" rIns="0" bIns="0" rtlCol="0" anchor="t"/>
+          <a:lstStyle/>
+          <a:p>
+            <a:pPr indent="0" marL="0">
+              <a:buNone/>
+            </a:pPr>
+            <a:r>
+              <a:rPr lang="en-US" sz="1250" dirty="0">
+                <a:solidFill>
+                  <a:srgbClr val="5B6382"/>
+                </a:solidFill>
+                <a:latin typeface="Arial" pitchFamily="34" charset="0"/>
+                <a:ea typeface="Arial" pitchFamily="34" charset="-122"/>
+                <a:cs typeface="Arial" pitchFamily="34" charset="-120"/>
+              </a:rPr>
+              <a:t>Fit bin-by-bin in y and mT-m0: Gaussians for TPC dE/dx yields, Student's t distributions for TOF mass-squared yields.</a:t>
+            </a:r>
+            <a:endParaRPr lang="en-US" sz="1250" dirty="0"/>
+          </a:p>
+        </p:txBody>
+      </p:sp>
+      <p:sp>
+        <p:nvSpPr>
+          <p:cNvPr id="10" name="Text 8"/>
+          <p:cNvSpPr/>
+          <p:nvPr/>
+        </p:nvSpPr>
+        <p:spPr>
+          <a:xfrm>
+            <a:off x="502920" y="3017848"/>
+            <a:ext cx="365760" cy="370840"/>
+          </a:xfrm>
+          <a:prstGeom prst="rect">
+            <a:avLst/>
+          </a:prstGeom>
+          <a:noFill/>
+          <a:ln/>
+        </p:spPr>
+        <p:txBody>
+          <a:bodyPr wrap="square" lIns="0" tIns="0" rIns="0" bIns="0" rtlCol="0" anchor="ctr"/>
+          <a:lstStyle/>
+          <a:p>
+            <a:pPr indent="0" marL="0">
+              <a:buNone/>
+            </a:pPr>
+            <a:r>
+              <a:rPr lang="en-US" sz="1700" b="1" dirty="0">
+                <a:solidFill>
+                  <a:srgbClr val="1E2761"/>
+                </a:solidFill>
+                <a:latin typeface="Arial" pitchFamily="34" charset="0"/>
+                <a:ea typeface="Arial" pitchFamily="34" charset="-122"/>
+                <a:cs typeface="Arial" pitchFamily="34" charset="-120"/>
+              </a:rPr>
+              <a:t/>
+            </a:r>
+            <a:endParaRPr lang="en-US" sz="1700" dirty="0"/>
+          </a:p>
+        </p:txBody>
+      </p:sp>
+      <p:sp>
+        <p:nvSpPr>
+          <p:cNvPr id="11" name="Text 9"/>
+          <p:cNvSpPr/>
+          <p:nvPr/>
+        </p:nvSpPr>
+        <p:spPr>
+          <a:xfrm>
+            <a:off x="886968" y="3017848"/>
+            <a:ext cx="3593592" cy="370840"/>
+          </a:xfrm>
+          <a:prstGeom prst="rect">
+            <a:avLst/>
+          </a:prstGeom>
+          <a:noFill/>
+          <a:ln/>
+        </p:spPr>
+        <p:txBody>
+          <a:bodyPr wrap="square" lIns="0" tIns="0" rIns="0" bIns="0" rtlCol="0" anchor="ctr"/>
+          <a:lstStyle/>
+          <a:p>
+            <a:pPr indent="0" marL="0">
+              <a:buNone/>
+            </a:pPr>
+            <a:r>
+              <a:rPr lang="en-US" sz="1550" b="1" dirty="0">
+                <a:solidFill>
+                  <a:srgbClr val="1E2761"/>
+                </a:solidFill>
+                <a:latin typeface="Arial" pitchFamily="34" charset="0"/>
+                <a:ea typeface="Arial" pitchFamily="34" charset="-122"/>
+                <a:cs typeface="Arial" pitchFamily="34" charset="-120"/>
+              </a:rPr>
+              <a:t/>
+            </a:r>
+            <a:endParaRPr lang="en-US" sz="1550" dirty="0"/>
+          </a:p>
+        </p:txBody>
+      </p:sp>
+      <p:sp>
+        <p:nvSpPr>
+          <p:cNvPr id="12" name="Text 10"/>
+          <p:cNvSpPr/>
+          <p:nvPr/>
+        </p:nvSpPr>
+        <p:spPr>
+          <a:xfrm>
+            <a:off x="886968" y="3388688"/>
+            <a:ext cx="3593592" cy="740000"/>
+          </a:xfrm>
+          <a:prstGeom prst="rect">
+            <a:avLst/>
+          </a:prstGeom>
+          <a:noFill/>
+          <a:ln/>
+        </p:spPr>
+        <p:txBody>
+          <a:bodyPr wrap="square" lIns="0" tIns="0" rIns="0" bIns="0" rtlCol="0" anchor="t"/>
+          <a:lstStyle/>
+          <a:p>
+            <a:pPr indent="0" marL="0">
+              <a:buNone/>
+            </a:pPr>
+            <a:r>
+              <a:rPr lang="en-US" sz="1250" dirty="0">
+                <a:solidFill>
+                  <a:srgbClr val="5B6382"/>
+                </a:solidFill>
+                <a:latin typeface="Arial" pitchFamily="34" charset="0"/>
+                <a:ea typeface="Arial" pitchFamily="34" charset="-122"/>
+                <a:cs typeface="Arial" pitchFamily="34" charset="-120"/>
+              </a:rPr>
+              <a:t/>
+            </a:r>
+            <a:endParaRPr lang="en-US" sz="1250" dirty="0"/>
+          </a:p>
+        </p:txBody>
+      </p:sp>
+      <p:sp>
+        <p:nvSpPr>
+          <p:cNvPr id="13" name="Text 11"/>
+          <p:cNvSpPr/>
+          <p:nvPr/>
+        </p:nvSpPr>
+        <p:spPr>
+          <a:xfrm>
+            <a:off x="4754880" y="3017848"/>
+            <a:ext cx="365760" cy="370840"/>
+          </a:xfrm>
+          <a:prstGeom prst="rect">
+            <a:avLst/>
+          </a:prstGeom>
+          <a:noFill/>
+          <a:ln/>
+        </p:spPr>
+        <p:txBody>
+          <a:bodyPr wrap="square" lIns="0" tIns="0" rIns="0" bIns="0" rtlCol="0" anchor="ctr"/>
+          <a:lstStyle/>
+          <a:p>
+            <a:pPr indent="0" marL="0">
+              <a:buNone/>
+            </a:pPr>
+            <a:r>
+              <a:rPr lang="en-US" sz="1700" b="1" dirty="0">
+                <a:solidFill>
+                  <a:srgbClr val="1E2761"/>
+                </a:solidFill>
+                <a:latin typeface="Arial" pitchFamily="34" charset="0"/>
+                <a:ea typeface="Arial" pitchFamily="34" charset="-122"/>
+                <a:cs typeface="Arial" pitchFamily="34" charset="-120"/>
+              </a:rPr>
+              <a:t/>
+            </a:r>
+            <a:endParaRPr lang="en-US" sz="1700" dirty="0"/>
+          </a:p>
+        </p:txBody>
+      </p:sp>
+      <p:sp>
+        <p:nvSpPr>
+          <p:cNvPr id="14" name="Text 12"/>
+          <p:cNvSpPr/>
+          <p:nvPr/>
+        </p:nvSpPr>
+        <p:spPr>
+          <a:xfrm>
+            <a:off x="5138928" y="3017848"/>
+            <a:ext cx="3593592" cy="370840"/>
+          </a:xfrm>
+          <a:prstGeom prst="rect">
+            <a:avLst/>
+          </a:prstGeom>
+          <a:noFill/>
+          <a:ln/>
+        </p:spPr>
+        <p:txBody>
+          <a:bodyPr wrap="square" lIns="0" tIns="0" rIns="0" bIns="0" rtlCol="0" anchor="ctr"/>
+          <a:lstStyle/>
+          <a:p>
+            <a:pPr indent="0" marL="0">
+              <a:buNone/>
+            </a:pPr>
+            <a:r>
+              <a:rPr lang="en-US" sz="1550" b="1" dirty="0">
+                <a:solidFill>
+                  <a:srgbClr val="1E2761"/>
+                </a:solidFill>
+                <a:latin typeface="Arial" pitchFamily="34" charset="0"/>
+                <a:ea typeface="Arial" pitchFamily="34" charset="-122"/>
+                <a:cs typeface="Arial" pitchFamily="34" charset="-120"/>
+              </a:rPr>
+              <a:t/>
+            </a:r>
+            <a:endParaRPr lang="en-US" sz="1550" dirty="0"/>
+          </a:p>
+        </p:txBody>
+      </p:sp>
+      <p:sp>
+        <p:nvSpPr>
+          <p:cNvPr id="15" name="Text 13"/>
+          <p:cNvSpPr/>
+          <p:nvPr/>
+        </p:nvSpPr>
+        <p:spPr>
+          <a:xfrm>
+            <a:off x="5138928" y="3388688"/>
+            <a:ext cx="3593592" cy="740000"/>
+          </a:xfrm>
+          <a:prstGeom prst="rect">
+            <a:avLst/>
+          </a:prstGeom>
+          <a:noFill/>
+          <a:ln/>
+        </p:spPr>
+        <p:txBody>
+          <a:bodyPr wrap="square" lIns="0" tIns="0" rIns="0" bIns="0" rtlCol="0" anchor="t"/>
+          <a:lstStyle/>
+          <a:p>
+            <a:pPr indent="0" marL="0">
+              <a:buNone/>
+            </a:pPr>
+            <a:r>
+              <a:rPr lang="en-US" sz="1250" dirty="0">
+                <a:solidFill>
+                  <a:srgbClr val="5B6382"/>
+                </a:solidFill>
+                <a:latin typeface="Arial" pitchFamily="34" charset="0"/>
+                <a:ea typeface="Arial" pitchFamily="34" charset="-122"/>
+                <a:cs typeface="Arial" pitchFamily="34" charset="-120"/>
+              </a:rPr>
+              <a:t/>
+            </a:r>
+            <a:endParaRPr lang="en-US" sz="1250" dirty="0"/>
+          </a:p>
+        </p:txBody>
+      </p:sp>
+      <p:pic>
+        <p:nvPicPr>
+          <p:cNvPr id="19" name="Image 0" descr="assets/ucdavis_seal.png"/>
+          <p:cNvPicPr>
+            <a:picLocks noChangeAspect="1"/>
+          </p:cNvPicPr>
+          <p:nvPr/>
+        </p:nvPicPr>
+        <p:blipFill>
+          <a:blip r:embed="rId1"/>
+          <a:stretch>
+            <a:fillRect/>
+          </a:stretch>
+        </p:blipFill>
+        <p:spPr>
+          <a:xfrm>
+            <a:off x="457200" y="4709160"/>
+            <a:ext cx="274320" cy="282092"/>
+          </a:xfrm>
+          <a:prstGeom prst="rect">
+            <a:avLst/>
+          </a:prstGeom>
+        </p:spPr>
+      </p:pic>
+      <p:pic>
+        <p:nvPicPr>
+          <p:cNvPr id="20" name="Image 1" descr="assets/star_logo.png"/>
+          <p:cNvPicPr>
+            <a:picLocks noChangeAspect="1"/>
+          </p:cNvPicPr>
+          <p:nvPr/>
+        </p:nvPicPr>
+        <p:blipFill>
+          <a:blip r:embed="rId2"/>
+          <a:stretch>
+            <a:fillRect/>
+          </a:stretch>
+        </p:blipFill>
+        <p:spPr>
+          <a:xfrm>
+            <a:off x="8092440" y="4709160"/>
+            <a:ext cx="379365" cy="292608"/>
+          </a:xfrm>
+          <a:prstGeom prst="rect">
+            <a:avLst/>
+          </a:prstGeom>
+        </p:spPr>
+      </p:pic>
+      <p:sp>
+        <p:nvSpPr>
+          <p:cNvPr id="21" name="Text 17"/>
+          <p:cNvSpPr/>
+          <p:nvPr/>
+        </p:nvSpPr>
+        <p:spPr>
+          <a:xfrm>
+            <a:off x="8549640" y="4828032"/>
+            <a:ext cx="457200" cy="274320"/>
+          </a:xfrm>
+          <a:prstGeom prst="rect">
+            <a:avLst/>
+          </a:prstGeom>
+          <a:noFill/>
+          <a:ln/>
+        </p:spPr>
+        <p:txBody>
+          <a:bodyPr wrap="square" lIns="0" tIns="0" rIns="0" bIns="0" rtlCol="0" anchor="ctr"/>
+          <a:lstStyle/>
+          <a:p>
+            <a:pPr algn="r" indent="0" marL="0">
+              <a:buNone/>
+            </a:pPr>
+            <a:r>
+              <a:rPr lang="en-US" sz="1000" dirty="0">
+                <a:solidFill>
+                  <a:srgbClr val="5B6382"/>
+                </a:solidFill>
+                <a:latin typeface="Arial" pitchFamily="34" charset="0"/>
+                <a:ea typeface="Arial" pitchFamily="34" charset="-122"/>
+                <a:cs typeface="Arial" pitchFamily="34" charset="-120"/>
+              </a:rPr>
+              <a:t>6</a:t>
             </a:r>
             <a:endParaRPr lang="en-US" sz="1000" dirty="0"/>
           </a:p>

</xml_diff>

<commit_message>
Reformat slides 2 and 6 from 2-column grid to a single-column numbered list
</commit_message>
<xml_diff>
--- a/docs/OO200_Spectra_Status_Update.pptx
+++ b/docs/OO200_Spectra_Status_Update.pptx
@@ -2015,7 +2015,7 @@
       </p:grpSpPr>
       <p:sp>
         <p:nvSpPr>
-          <p:cNvPr id="2" name="Text 0"/>
+          <p:cNvPr id="3" name="Text 1"/>
           <p:cNvSpPr/>
           <p:nvPr/>
         </p:nvSpPr>
@@ -2038,7 +2038,7 @@
               <a:buNone/>
             </a:pPr>
             <a:r>
-              <a:rPr lang="en-US" sz="1200" b="1" spc="200" kern="0" dirty="0">
+              <a:rPr lang="en-US" sz="1200" b="1" dirty="0">
                 <a:solidFill>
                   <a:srgbClr val="5B6382"/>
                 </a:solidFill>
@@ -2054,7 +2054,7 @@
       </p:sp>
       <p:sp>
         <p:nvSpPr>
-          <p:cNvPr id="3" name="Text 1"/>
+          <p:cNvPr id="4" name="Text 2"/>
           <p:cNvSpPr/>
           <p:nvPr/>
         </p:nvSpPr>
@@ -2077,7 +2077,7 @@
               <a:buNone/>
             </a:pPr>
             <a:r>
-              <a:rPr lang="en-US" sz="3000" b="1" dirty="0">
+              <a:rPr lang="en-US" sz="2800" b="1" dirty="0">
                 <a:solidFill>
                   <a:srgbClr val="1E2761"/>
                 </a:solidFill>
@@ -2087,19 +2087,19 @@
               </a:rPr>
               <a:t>Summary of Key Updates</a:t>
             </a:r>
-            <a:endParaRPr lang="en-US" sz="3000" dirty="0"/>
-          </a:p>
-        </p:txBody>
-      </p:sp>
-      <p:sp>
-        <p:nvSpPr>
-          <p:cNvPr id="4" name="Text 2"/>
-          <p:cNvSpPr/>
-          <p:nvPr/>
-        </p:nvSpPr>
-        <p:spPr>
-          <a:xfrm>
-            <a:off x="502920" y="1557008"/>
+            <a:endParaRPr lang="en-US" sz="2800" dirty="0"/>
+          </a:p>
+        </p:txBody>
+      </p:sp>
+      <p:sp>
+        <p:nvSpPr>
+          <p:cNvPr id="5" name="Text 3"/>
+          <p:cNvSpPr/>
+          <p:nvPr/>
+        </p:nvSpPr>
+        <p:spPr>
+          <a:xfrm>
+            <a:off x="502920" y="1300000"/>
             <a:ext cx="365760" cy="370840"/>
           </a:xfrm>
           <a:prstGeom prst="rect">
@@ -2132,14 +2132,14 @@
       </p:sp>
       <p:sp>
         <p:nvSpPr>
-          <p:cNvPr id="5" name="Text 3"/>
-          <p:cNvSpPr/>
-          <p:nvPr/>
-        </p:nvSpPr>
-        <p:spPr>
-          <a:xfrm>
-            <a:off x="886968" y="1557008"/>
-            <a:ext cx="3593592" cy="370840"/>
+          <p:cNvPr id="6" name="Text 4"/>
+          <p:cNvSpPr/>
+          <p:nvPr/>
+        </p:nvSpPr>
+        <p:spPr>
+          <a:xfrm>
+            <a:off x="886968" y="1300000"/>
+            <a:ext cx="7799832" cy="370840"/>
           </a:xfrm>
           <a:prstGeom prst="rect">
             <a:avLst/>
@@ -2171,14 +2171,14 @@
       </p:sp>
       <p:sp>
         <p:nvSpPr>
-          <p:cNvPr id="6" name="Text 4"/>
-          <p:cNvSpPr/>
-          <p:nvPr/>
-        </p:nvSpPr>
-        <p:spPr>
-          <a:xfrm>
-            <a:off x="886968" y="1927848"/>
-            <a:ext cx="3593592" cy="740000"/>
+          <p:cNvPr id="7" name="Text 5"/>
+          <p:cNvSpPr/>
+          <p:nvPr/>
+        </p:nvSpPr>
+        <p:spPr>
+          <a:xfrm>
+            <a:off x="886968" y="1690000"/>
+            <a:ext cx="7799832" cy="500000"/>
           </a:xfrm>
           <a:prstGeom prst="rect">
             <a:avLst/>
@@ -2210,13 +2210,13 @@
       </p:sp>
       <p:sp>
         <p:nvSpPr>
-          <p:cNvPr id="7" name="Text 5"/>
-          <p:cNvSpPr/>
-          <p:nvPr/>
-        </p:nvSpPr>
-        <p:spPr>
-          <a:xfrm>
-            <a:off x="4754880" y="1557008"/>
+          <p:cNvPr id="8" name="Text 6"/>
+          <p:cNvSpPr/>
+          <p:nvPr/>
+        </p:nvSpPr>
+        <p:spPr>
+          <a:xfrm>
+            <a:off x="502920" y="2200000"/>
             <a:ext cx="365760" cy="370840"/>
           </a:xfrm>
           <a:prstGeom prst="rect">
@@ -2249,14 +2249,14 @@
       </p:sp>
       <p:sp>
         <p:nvSpPr>
-          <p:cNvPr id="8" name="Text 6"/>
-          <p:cNvSpPr/>
-          <p:nvPr/>
-        </p:nvSpPr>
-        <p:spPr>
-          <a:xfrm>
-            <a:off x="5138928" y="1557008"/>
-            <a:ext cx="3593592" cy="370840"/>
+          <p:cNvPr id="9" name="Text 7"/>
+          <p:cNvSpPr/>
+          <p:nvPr/>
+        </p:nvSpPr>
+        <p:spPr>
+          <a:xfrm>
+            <a:off x="886968" y="2200000"/>
+            <a:ext cx="7799832" cy="370840"/>
           </a:xfrm>
           <a:prstGeom prst="rect">
             <a:avLst/>
@@ -2288,14 +2288,14 @@
       </p:sp>
       <p:sp>
         <p:nvSpPr>
-          <p:cNvPr id="9" name="Text 7"/>
-          <p:cNvSpPr/>
-          <p:nvPr/>
-        </p:nvSpPr>
-        <p:spPr>
-          <a:xfrm>
-            <a:off x="5138928" y="1927848"/>
-            <a:ext cx="3593592" cy="740000"/>
+          <p:cNvPr id="10" name="Text 8"/>
+          <p:cNvSpPr/>
+          <p:nvPr/>
+        </p:nvSpPr>
+        <p:spPr>
+          <a:xfrm>
+            <a:off x="886968" y="2590000"/>
+            <a:ext cx="7799832" cy="500000"/>
           </a:xfrm>
           <a:prstGeom prst="rect">
             <a:avLst/>
@@ -2327,13 +2327,13 @@
       </p:sp>
       <p:sp>
         <p:nvSpPr>
-          <p:cNvPr id="10" name="Text 8"/>
-          <p:cNvSpPr/>
-          <p:nvPr/>
-        </p:nvSpPr>
-        <p:spPr>
-          <a:xfrm>
-            <a:off x="502920" y="3017848"/>
+          <p:cNvPr id="11" name="Text 9"/>
+          <p:cNvSpPr/>
+          <p:nvPr/>
+        </p:nvSpPr>
+        <p:spPr>
+          <a:xfrm>
+            <a:off x="502920" y="3100000"/>
             <a:ext cx="365760" cy="370840"/>
           </a:xfrm>
           <a:prstGeom prst="rect">
@@ -2366,14 +2366,14 @@
       </p:sp>
       <p:sp>
         <p:nvSpPr>
-          <p:cNvPr id="11" name="Text 9"/>
-          <p:cNvSpPr/>
-          <p:nvPr/>
-        </p:nvSpPr>
-        <p:spPr>
-          <a:xfrm>
-            <a:off x="886968" y="3017848"/>
-            <a:ext cx="3593592" cy="370840"/>
+          <p:cNvPr id="12" name="Text 10"/>
+          <p:cNvSpPr/>
+          <p:nvPr/>
+        </p:nvSpPr>
+        <p:spPr>
+          <a:xfrm>
+            <a:off x="886968" y="3100000"/>
+            <a:ext cx="7799832" cy="370840"/>
           </a:xfrm>
           <a:prstGeom prst="rect">
             <a:avLst/>
@@ -2405,14 +2405,14 @@
       </p:sp>
       <p:sp>
         <p:nvSpPr>
-          <p:cNvPr id="12" name="Text 10"/>
-          <p:cNvSpPr/>
-          <p:nvPr/>
-        </p:nvSpPr>
-        <p:spPr>
-          <a:xfrm>
-            <a:off x="886968" y="3388688"/>
-            <a:ext cx="3593592" cy="740000"/>
+          <p:cNvPr id="13" name="Text 11"/>
+          <p:cNvSpPr/>
+          <p:nvPr/>
+        </p:nvSpPr>
+        <p:spPr>
+          <a:xfrm>
+            <a:off x="886968" y="3490000"/>
+            <a:ext cx="7799832" cy="500000"/>
           </a:xfrm>
           <a:prstGeom prst="rect">
             <a:avLst/>
@@ -2437,123 +2437,6 @@
                 <a:cs typeface="Arial" pitchFamily="34" charset="-120"/>
               </a:rPr>
               <a:t>DCA tightened to 1cm to better match the TPC's own ~1mm DCA resolution; the radial (XY) vertex cut was also tightened, from 2cm to 1cm.</a:t>
-            </a:r>
-            <a:endParaRPr lang="en-US" sz="1250" dirty="0"/>
-          </a:p>
-        </p:txBody>
-      </p:sp>
-      <p:sp>
-        <p:nvSpPr>
-          <p:cNvPr id="13" name="Text 11"/>
-          <p:cNvSpPr/>
-          <p:nvPr/>
-        </p:nvSpPr>
-        <p:spPr>
-          <a:xfrm>
-            <a:off x="4754880" y="3017848"/>
-            <a:ext cx="365760" cy="370840"/>
-          </a:xfrm>
-          <a:prstGeom prst="rect">
-            <a:avLst/>
-          </a:prstGeom>
-          <a:noFill/>
-          <a:ln/>
-        </p:spPr>
-        <p:txBody>
-          <a:bodyPr wrap="square" lIns="0" tIns="0" rIns="0" bIns="0" rtlCol="0" anchor="ctr"/>
-          <a:lstStyle/>
-          <a:p>
-            <a:pPr indent="0" marL="0">
-              <a:buNone/>
-            </a:pPr>
-            <a:r>
-              <a:rPr lang="en-US" sz="1700" b="1" dirty="0">
-                <a:solidFill>
-                  <a:srgbClr val="1E2761"/>
-                </a:solidFill>
-                <a:latin typeface="Arial" pitchFamily="34" charset="0"/>
-                <a:ea typeface="Arial" pitchFamily="34" charset="-122"/>
-                <a:cs typeface="Arial" pitchFamily="34" charset="-120"/>
-              </a:rPr>
-              <a:t/>
-            </a:r>
-            <a:endParaRPr lang="en-US" sz="1700" dirty="0"/>
-          </a:p>
-        </p:txBody>
-      </p:sp>
-      <p:sp>
-        <p:nvSpPr>
-          <p:cNvPr id="14" name="Text 12"/>
-          <p:cNvSpPr/>
-          <p:nvPr/>
-        </p:nvSpPr>
-        <p:spPr>
-          <a:xfrm>
-            <a:off x="5138928" y="3017848"/>
-            <a:ext cx="3593592" cy="370840"/>
-          </a:xfrm>
-          <a:prstGeom prst="rect">
-            <a:avLst/>
-          </a:prstGeom>
-          <a:noFill/>
-          <a:ln/>
-        </p:spPr>
-        <p:txBody>
-          <a:bodyPr wrap="square" lIns="0" tIns="0" rIns="0" bIns="0" rtlCol="0" anchor="ctr"/>
-          <a:lstStyle/>
-          <a:p>
-            <a:pPr indent="0" marL="0">
-              <a:buNone/>
-            </a:pPr>
-            <a:r>
-              <a:rPr lang="en-US" sz="1550" b="1" dirty="0">
-                <a:solidFill>
-                  <a:srgbClr val="1E2761"/>
-                </a:solidFill>
-                <a:latin typeface="Arial" pitchFamily="34" charset="0"/>
-                <a:ea typeface="Arial" pitchFamily="34" charset="-122"/>
-                <a:cs typeface="Arial" pitchFamily="34" charset="-120"/>
-              </a:rPr>
-              <a:t/>
-            </a:r>
-            <a:endParaRPr lang="en-US" sz="1550" dirty="0"/>
-          </a:p>
-        </p:txBody>
-      </p:sp>
-      <p:sp>
-        <p:nvSpPr>
-          <p:cNvPr id="15" name="Text 13"/>
-          <p:cNvSpPr/>
-          <p:nvPr/>
-        </p:nvSpPr>
-        <p:spPr>
-          <a:xfrm>
-            <a:off x="5138928" y="3388688"/>
-            <a:ext cx="3593592" cy="740000"/>
-          </a:xfrm>
-          <a:prstGeom prst="rect">
-            <a:avLst/>
-          </a:prstGeom>
-          <a:noFill/>
-          <a:ln/>
-        </p:spPr>
-        <p:txBody>
-          <a:bodyPr wrap="square" lIns="0" tIns="0" rIns="0" bIns="0" rtlCol="0" anchor="t"/>
-          <a:lstStyle/>
-          <a:p>
-            <a:pPr indent="0" marL="0">
-              <a:buNone/>
-            </a:pPr>
-            <a:r>
-              <a:rPr lang="en-US" sz="1250" dirty="0">
-                <a:solidFill>
-                  <a:srgbClr val="5B6382"/>
-                </a:solidFill>
-                <a:latin typeface="Arial" pitchFamily="34" charset="0"/>
-                <a:ea typeface="Arial" pitchFamily="34" charset="-122"/>
-                <a:cs typeface="Arial" pitchFamily="34" charset="-120"/>
-              </a:rPr>
-              <a:t/>
             </a:r>
             <a:endParaRPr lang="en-US" sz="1250" dirty="0"/>
           </a:p>
@@ -2719,7 +2602,7 @@
       </p:grpSpPr>
       <p:sp>
         <p:nvSpPr>
-          <p:cNvPr id="2" name="Text 0"/>
+          <p:cNvPr id="3" name="Text 1"/>
           <p:cNvSpPr/>
           <p:nvPr/>
         </p:nvSpPr>
@@ -2742,7 +2625,7 @@
               <a:buNone/>
             </a:pPr>
             <a:r>
-              <a:rPr lang="en-US" sz="1200" b="1" spc="200" kern="0" dirty="0">
+              <a:rPr lang="en-US" sz="1200" b="1" dirty="0">
                 <a:solidFill>
                   <a:srgbClr val="5B6382"/>
                 </a:solidFill>
@@ -2758,7 +2641,7 @@
       </p:sp>
       <p:sp>
         <p:nvSpPr>
-          <p:cNvPr id="3" name="Text 1"/>
+          <p:cNvPr id="4" name="Text 2"/>
           <p:cNvSpPr/>
           <p:nvPr/>
         </p:nvSpPr>
@@ -2781,7 +2664,7 @@
               <a:buNone/>
             </a:pPr>
             <a:r>
-              <a:rPr lang="en-US" sz="3000" b="1" dirty="0">
+              <a:rPr lang="en-US" sz="2800" b="1" dirty="0">
                 <a:solidFill>
                   <a:srgbClr val="1E2761"/>
                 </a:solidFill>
@@ -2791,19 +2674,19 @@
               </a:rPr>
               <a:t>Finalizing Cuts &amp; Moving to ZFitter</a:t>
             </a:r>
-            <a:endParaRPr lang="en-US" sz="3000" dirty="0"/>
-          </a:p>
-        </p:txBody>
-      </p:sp>
-      <p:sp>
-        <p:nvSpPr>
-          <p:cNvPr id="4" name="Text 2"/>
-          <p:cNvSpPr/>
-          <p:nvPr/>
-        </p:nvSpPr>
-        <p:spPr>
-          <a:xfrm>
-            <a:off x="502920" y="1557008"/>
+            <a:endParaRPr lang="en-US" sz="2800" dirty="0"/>
+          </a:p>
+        </p:txBody>
+      </p:sp>
+      <p:sp>
+        <p:nvSpPr>
+          <p:cNvPr id="5" name="Text 3"/>
+          <p:cNvSpPr/>
+          <p:nvPr/>
+        </p:nvSpPr>
+        <p:spPr>
+          <a:xfrm>
+            <a:off x="502920" y="1500000"/>
             <a:ext cx="365760" cy="370840"/>
           </a:xfrm>
           <a:prstGeom prst="rect">
@@ -2836,14 +2719,14 @@
       </p:sp>
       <p:sp>
         <p:nvSpPr>
-          <p:cNvPr id="5" name="Text 3"/>
-          <p:cNvSpPr/>
-          <p:nvPr/>
-        </p:nvSpPr>
-        <p:spPr>
-          <a:xfrm>
-            <a:off x="886968" y="1557008"/>
-            <a:ext cx="3593592" cy="370840"/>
+          <p:cNvPr id="6" name="Text 4"/>
+          <p:cNvSpPr/>
+          <p:nvPr/>
+        </p:nvSpPr>
+        <p:spPr>
+          <a:xfrm>
+            <a:off x="886968" y="1500000"/>
+            <a:ext cx="7799832" cy="370840"/>
           </a:xfrm>
           <a:prstGeom prst="rect">
             <a:avLst/>
@@ -2875,14 +2758,14 @@
       </p:sp>
       <p:sp>
         <p:nvSpPr>
-          <p:cNvPr id="6" name="Text 4"/>
-          <p:cNvSpPr/>
-          <p:nvPr/>
-        </p:nvSpPr>
-        <p:spPr>
-          <a:xfrm>
-            <a:off x="886968" y="1927848"/>
-            <a:ext cx="3593592" cy="740000"/>
+          <p:cNvPr id="7" name="Text 5"/>
+          <p:cNvSpPr/>
+          <p:nvPr/>
+        </p:nvSpPr>
+        <p:spPr>
+          <a:xfrm>
+            <a:off x="886968" y="1890000"/>
+            <a:ext cx="7799832" cy="500000"/>
           </a:xfrm>
           <a:prstGeom prst="rect">
             <a:avLst/>
@@ -2914,13 +2797,13 @@
       </p:sp>
       <p:sp>
         <p:nvSpPr>
-          <p:cNvPr id="7" name="Text 5"/>
-          <p:cNvSpPr/>
-          <p:nvPr/>
-        </p:nvSpPr>
-        <p:spPr>
-          <a:xfrm>
-            <a:off x="4754880" y="1557008"/>
+          <p:cNvPr id="8" name="Text 6"/>
+          <p:cNvSpPr/>
+          <p:nvPr/>
+        </p:nvSpPr>
+        <p:spPr>
+          <a:xfrm>
+            <a:off x="502920" y="2900000"/>
             <a:ext cx="365760" cy="370840"/>
           </a:xfrm>
           <a:prstGeom prst="rect">
@@ -2953,14 +2836,14 @@
       </p:sp>
       <p:sp>
         <p:nvSpPr>
-          <p:cNvPr id="8" name="Text 6"/>
-          <p:cNvSpPr/>
-          <p:nvPr/>
-        </p:nvSpPr>
-        <p:spPr>
-          <a:xfrm>
-            <a:off x="5138928" y="1557008"/>
-            <a:ext cx="3593592" cy="370840"/>
+          <p:cNvPr id="9" name="Text 7"/>
+          <p:cNvSpPr/>
+          <p:nvPr/>
+        </p:nvSpPr>
+        <p:spPr>
+          <a:xfrm>
+            <a:off x="886968" y="2900000"/>
+            <a:ext cx="7799832" cy="370840"/>
           </a:xfrm>
           <a:prstGeom prst="rect">
             <a:avLst/>
@@ -2992,14 +2875,14 @@
       </p:sp>
       <p:sp>
         <p:nvSpPr>
-          <p:cNvPr id="9" name="Text 7"/>
-          <p:cNvSpPr/>
-          <p:nvPr/>
-        </p:nvSpPr>
-        <p:spPr>
-          <a:xfrm>
-            <a:off x="5138928" y="1927848"/>
-            <a:ext cx="3593592" cy="740000"/>
+          <p:cNvPr id="10" name="Text 8"/>
+          <p:cNvSpPr/>
+          <p:nvPr/>
+        </p:nvSpPr>
+        <p:spPr>
+          <a:xfrm>
+            <a:off x="886968" y="3290000"/>
+            <a:ext cx="7799832" cy="500000"/>
           </a:xfrm>
           <a:prstGeom prst="rect">
             <a:avLst/>
@@ -3024,240 +2907,6 @@
                 <a:cs typeface="Arial" pitchFamily="34" charset="-120"/>
               </a:rPr>
               <a:t>Fit bin-by-bin in y and mT-m0: Gaussians for TPC dE/dx yields, Student's t distributions for TOF mass-squared yields.</a:t>
-            </a:r>
-            <a:endParaRPr lang="en-US" sz="1250" dirty="0"/>
-          </a:p>
-        </p:txBody>
-      </p:sp>
-      <p:sp>
-        <p:nvSpPr>
-          <p:cNvPr id="10" name="Text 8"/>
-          <p:cNvSpPr/>
-          <p:nvPr/>
-        </p:nvSpPr>
-        <p:spPr>
-          <a:xfrm>
-            <a:off x="502920" y="3017848"/>
-            <a:ext cx="365760" cy="370840"/>
-          </a:xfrm>
-          <a:prstGeom prst="rect">
-            <a:avLst/>
-          </a:prstGeom>
-          <a:noFill/>
-          <a:ln/>
-        </p:spPr>
-        <p:txBody>
-          <a:bodyPr wrap="square" lIns="0" tIns="0" rIns="0" bIns="0" rtlCol="0" anchor="ctr"/>
-          <a:lstStyle/>
-          <a:p>
-            <a:pPr indent="0" marL="0">
-              <a:buNone/>
-            </a:pPr>
-            <a:r>
-              <a:rPr lang="en-US" sz="1700" b="1" dirty="0">
-                <a:solidFill>
-                  <a:srgbClr val="1E2761"/>
-                </a:solidFill>
-                <a:latin typeface="Arial" pitchFamily="34" charset="0"/>
-                <a:ea typeface="Arial" pitchFamily="34" charset="-122"/>
-                <a:cs typeface="Arial" pitchFamily="34" charset="-120"/>
-              </a:rPr>
-              <a:t/>
-            </a:r>
-            <a:endParaRPr lang="en-US" sz="1700" dirty="0"/>
-          </a:p>
-        </p:txBody>
-      </p:sp>
-      <p:sp>
-        <p:nvSpPr>
-          <p:cNvPr id="11" name="Text 9"/>
-          <p:cNvSpPr/>
-          <p:nvPr/>
-        </p:nvSpPr>
-        <p:spPr>
-          <a:xfrm>
-            <a:off x="886968" y="3017848"/>
-            <a:ext cx="3593592" cy="370840"/>
-          </a:xfrm>
-          <a:prstGeom prst="rect">
-            <a:avLst/>
-          </a:prstGeom>
-          <a:noFill/>
-          <a:ln/>
-        </p:spPr>
-        <p:txBody>
-          <a:bodyPr wrap="square" lIns="0" tIns="0" rIns="0" bIns="0" rtlCol="0" anchor="ctr"/>
-          <a:lstStyle/>
-          <a:p>
-            <a:pPr indent="0" marL="0">
-              <a:buNone/>
-            </a:pPr>
-            <a:r>
-              <a:rPr lang="en-US" sz="1550" b="1" dirty="0">
-                <a:solidFill>
-                  <a:srgbClr val="1E2761"/>
-                </a:solidFill>
-                <a:latin typeface="Arial" pitchFamily="34" charset="0"/>
-                <a:ea typeface="Arial" pitchFamily="34" charset="-122"/>
-                <a:cs typeface="Arial" pitchFamily="34" charset="-120"/>
-              </a:rPr>
-              <a:t/>
-            </a:r>
-            <a:endParaRPr lang="en-US" sz="1550" dirty="0"/>
-          </a:p>
-        </p:txBody>
-      </p:sp>
-      <p:sp>
-        <p:nvSpPr>
-          <p:cNvPr id="12" name="Text 10"/>
-          <p:cNvSpPr/>
-          <p:nvPr/>
-        </p:nvSpPr>
-        <p:spPr>
-          <a:xfrm>
-            <a:off x="886968" y="3388688"/>
-            <a:ext cx="3593592" cy="740000"/>
-          </a:xfrm>
-          <a:prstGeom prst="rect">
-            <a:avLst/>
-          </a:prstGeom>
-          <a:noFill/>
-          <a:ln/>
-        </p:spPr>
-        <p:txBody>
-          <a:bodyPr wrap="square" lIns="0" tIns="0" rIns="0" bIns="0" rtlCol="0" anchor="t"/>
-          <a:lstStyle/>
-          <a:p>
-            <a:pPr indent="0" marL="0">
-              <a:buNone/>
-            </a:pPr>
-            <a:r>
-              <a:rPr lang="en-US" sz="1250" dirty="0">
-                <a:solidFill>
-                  <a:srgbClr val="5B6382"/>
-                </a:solidFill>
-                <a:latin typeface="Arial" pitchFamily="34" charset="0"/>
-                <a:ea typeface="Arial" pitchFamily="34" charset="-122"/>
-                <a:cs typeface="Arial" pitchFamily="34" charset="-120"/>
-              </a:rPr>
-              <a:t/>
-            </a:r>
-            <a:endParaRPr lang="en-US" sz="1250" dirty="0"/>
-          </a:p>
-        </p:txBody>
-      </p:sp>
-      <p:sp>
-        <p:nvSpPr>
-          <p:cNvPr id="13" name="Text 11"/>
-          <p:cNvSpPr/>
-          <p:nvPr/>
-        </p:nvSpPr>
-        <p:spPr>
-          <a:xfrm>
-            <a:off x="4754880" y="3017848"/>
-            <a:ext cx="365760" cy="370840"/>
-          </a:xfrm>
-          <a:prstGeom prst="rect">
-            <a:avLst/>
-          </a:prstGeom>
-          <a:noFill/>
-          <a:ln/>
-        </p:spPr>
-        <p:txBody>
-          <a:bodyPr wrap="square" lIns="0" tIns="0" rIns="0" bIns="0" rtlCol="0" anchor="ctr"/>
-          <a:lstStyle/>
-          <a:p>
-            <a:pPr indent="0" marL="0">
-              <a:buNone/>
-            </a:pPr>
-            <a:r>
-              <a:rPr lang="en-US" sz="1700" b="1" dirty="0">
-                <a:solidFill>
-                  <a:srgbClr val="1E2761"/>
-                </a:solidFill>
-                <a:latin typeface="Arial" pitchFamily="34" charset="0"/>
-                <a:ea typeface="Arial" pitchFamily="34" charset="-122"/>
-                <a:cs typeface="Arial" pitchFamily="34" charset="-120"/>
-              </a:rPr>
-              <a:t/>
-            </a:r>
-            <a:endParaRPr lang="en-US" sz="1700" dirty="0"/>
-          </a:p>
-        </p:txBody>
-      </p:sp>
-      <p:sp>
-        <p:nvSpPr>
-          <p:cNvPr id="14" name="Text 12"/>
-          <p:cNvSpPr/>
-          <p:nvPr/>
-        </p:nvSpPr>
-        <p:spPr>
-          <a:xfrm>
-            <a:off x="5138928" y="3017848"/>
-            <a:ext cx="3593592" cy="370840"/>
-          </a:xfrm>
-          <a:prstGeom prst="rect">
-            <a:avLst/>
-          </a:prstGeom>
-          <a:noFill/>
-          <a:ln/>
-        </p:spPr>
-        <p:txBody>
-          <a:bodyPr wrap="square" lIns="0" tIns="0" rIns="0" bIns="0" rtlCol="0" anchor="ctr"/>
-          <a:lstStyle/>
-          <a:p>
-            <a:pPr indent="0" marL="0">
-              <a:buNone/>
-            </a:pPr>
-            <a:r>
-              <a:rPr lang="en-US" sz="1550" b="1" dirty="0">
-                <a:solidFill>
-                  <a:srgbClr val="1E2761"/>
-                </a:solidFill>
-                <a:latin typeface="Arial" pitchFamily="34" charset="0"/>
-                <a:ea typeface="Arial" pitchFamily="34" charset="-122"/>
-                <a:cs typeface="Arial" pitchFamily="34" charset="-120"/>
-              </a:rPr>
-              <a:t/>
-            </a:r>
-            <a:endParaRPr lang="en-US" sz="1550" dirty="0"/>
-          </a:p>
-        </p:txBody>
-      </p:sp>
-      <p:sp>
-        <p:nvSpPr>
-          <p:cNvPr id="15" name="Text 13"/>
-          <p:cNvSpPr/>
-          <p:nvPr/>
-        </p:nvSpPr>
-        <p:spPr>
-          <a:xfrm>
-            <a:off x="5138928" y="3388688"/>
-            <a:ext cx="3593592" cy="740000"/>
-          </a:xfrm>
-          <a:prstGeom prst="rect">
-            <a:avLst/>
-          </a:prstGeom>
-          <a:noFill/>
-          <a:ln/>
-        </p:spPr>
-        <p:txBody>
-          <a:bodyPr wrap="square" lIns="0" tIns="0" rIns="0" bIns="0" rtlCol="0" anchor="t"/>
-          <a:lstStyle/>
-          <a:p>
-            <a:pPr indent="0" marL="0">
-              <a:buNone/>
-            </a:pPr>
-            <a:r>
-              <a:rPr lang="en-US" sz="1250" dirty="0">
-                <a:solidFill>
-                  <a:srgbClr val="5B6382"/>
-                </a:solidFill>
-                <a:latin typeface="Arial" pitchFamily="34" charset="0"/>
-                <a:ea typeface="Arial" pitchFamily="34" charset="-122"/>
-                <a:cs typeface="Arial" pitchFamily="34" charset="-120"/>
-              </a:rPr>
-              <a:t/>
             </a:r>
             <a:endParaRPr lang="en-US" sz="1250" dirty="0"/>
           </a:p>

</xml_diff>